<commit_message>
Reframe pitch deck around buying Founding Member tier
Founding Member ($2,000/mo, all Platinum features, lifetime price lock)
is now the recommendation: price-list slide highlights it, break-even
callout centers on its 5.7 jobs/yr, the pilot becomes a full-team
90-day proof period with a 2-rep control group and $6,000 at risk, and
the objections/ask slides argue the price lock is a free option if
billing is monthly and cancelable.

Co-Authored-By: Claude Fable 5 <noreply@anthropic.com>
Claude-Session: https://claude.ai/code/session_01Qj1b2D7LVH4xves4mfA9FY
</commit_message>
<xml_diff>
--- a/pitch/Storm-Scout-Pitch.pptx
+++ b/pitch/Storm-Scout-Pitch.pptx
@@ -2420,7 +2420,7 @@
                 <a:ea typeface="Arial" pitchFamily="34" charset="-122"/>
                 <a:cs typeface="Arial" pitchFamily="34" charset="-120"/>
               </a:rPr>
-              <a:t>30 minutes. Verify storm-map coverage in our markets, confirm month-to-month terms, and pin down what counts as a “lead.”</a:t>
+              <a:t>30 minutes. Confirm the Founding offer is still open, bills monthly, and cancels clean. Verify storm-map coverage in our markets.</a:t>
             </a:r>
             <a:endParaRPr lang="en-US" sz="1250" dirty="0"/>
           </a:p>
@@ -2564,7 +2564,7 @@
                 <a:ea typeface="Arial" pitchFamily="34" charset="-122"/>
                 <a:cs typeface="Arial" pitchFamily="34" charset="-120"/>
               </a:rPr>
-              <a:t>Run the pilot on Silver</a:t>
+              <a:t>Buy Founding Member</a:t>
             </a:r>
             <a:endParaRPr lang="en-US" sz="1700" dirty="0"/>
           </a:p>
@@ -2603,7 +2603,7 @@
                 <a:ea typeface="Arial" pitchFamily="34" charset="-122"/>
                 <a:cs typeface="Arial" pitchFamily="34" charset="-120"/>
               </a:rPr>
-              <a:t>2 reps, 1 storm market, $500/mo — $1,500 total, hard cap. Weekly scorecard to Aaron &amp; Alan.</a:t>
+              <a:t>$2,000/mo, every Platinum feature, price locked for life. Full team live day 1; 2 control reps keep the old playbook.</a:t>
             </a:r>
             <a:endParaRPr lang="en-US" sz="1250" dirty="0"/>
           </a:p>
@@ -2747,7 +2747,7 @@
                 <a:ea typeface="Arial" pitchFamily="34" charset="-122"/>
                 <a:cs typeface="Arial" pitchFamily="34" charset="-120"/>
               </a:rPr>
-              <a:t>Decide on data at day 90</a:t>
+              <a:t>Day-90 scorecard: keep or kill</a:t>
             </a:r>
             <a:endParaRPr lang="en-US" sz="1700" dirty="0"/>
           </a:p>
@@ -2786,7 +2786,7 @@
                 <a:ea typeface="Arial" pitchFamily="34" charset="-122"/>
                 <a:cs typeface="Arial" pitchFamily="34" charset="-120"/>
               </a:rPr>
-              <a:t>Beats baseline → scale to Gold for automated outreach, then talk Platinum/Founding. Misses → cancel, out $1,500.</a:t>
+              <a:t>Beats baseline → we own Platinum features at $500/mo under sticker, forever. Misses → cancel; at risk was $6,000.</a:t>
             </a:r>
             <a:endParaRPr lang="en-US" sz="1250" dirty="0"/>
           </a:p>
@@ -2825,7 +2825,7 @@
                 <a:ea typeface="Arial" pitchFamily="34" charset="-122"/>
                 <a:cs typeface="Arial" pitchFamily="34" charset="-120"/>
               </a:rPr>
-              <a:t>Cheap to test. Measured on our own baseline. Easy to kill.</a:t>
+              <a:t>Locked-in price. Measured on our own baseline. Easy to kill.</a:t>
             </a:r>
             <a:endParaRPr lang="en-US" sz="2200" dirty="0"/>
           </a:p>
@@ -2864,7 +2864,7 @@
                 <a:ea typeface="Arial" pitchFamily="34" charset="-122"/>
                 <a:cs typeface="Arial" pitchFamily="34" charset="-120"/>
               </a:rPr>
-              <a:t>Total downside: $1,500.  Upside: every storm season, our crews knock verified-damage doors first.</a:t>
+              <a:t>Downside: $6,000.  Upside: Platinum features at $2,000 for life — and crews knocking verified-damage doors first, every storm season.</a:t>
             </a:r>
             <a:endParaRPr lang="en-US" sz="1400" dirty="0"/>
           </a:p>
@@ -6958,7 +6958,7 @@
                 <a:ea typeface="Arial" pitchFamily="34" charset="-122"/>
                 <a:cs typeface="Arial" pitchFamily="34" charset="-120"/>
               </a:rPr>
-              <a:t>Published on stormscout.ai/pricing — no quote games. Silver is the pilot tier.</a:t>
+              <a:t>Published on stormscout.ai/pricing — no quote games. Founding Member is the play.</a:t>
             </a:r>
             <a:endParaRPr lang="en-US" sz="1500" dirty="0"/>
           </a:p>
@@ -7137,7 +7137,7 @@
                           <a:ea typeface="Arial" pitchFamily="34" charset="-122"/>
                           <a:cs typeface="Arial" pitchFamily="34" charset="-120"/>
                         </a:rPr>
-                        <a:t>Silver  (pilot)</a:t>
+                        <a:t>Silver</a:t>
                       </a:r>
                       <a:endParaRPr lang="en-US" sz="1250" dirty="0">
                         <a:latin typeface="Arial" charset="0"/>
@@ -7184,7 +7184,7 @@
                       <a:tailEnd type="none" w="med" len="med"/>
                     </a:lnB>
                     <a:solidFill>
-                      <a:srgbClr val="C8102E"/>
+                      <a:srgbClr val="111111"/>
                     </a:solidFill>
                   </a:tcPr>
                 </a:tc>
@@ -7341,7 +7341,7 @@
                           <a:ea typeface="Arial" pitchFamily="34" charset="-122"/>
                           <a:cs typeface="Arial" pitchFamily="34" charset="-120"/>
                         </a:rPr>
-                        <a:t>Founding*</a:t>
+                        <a:t>Founding*  (our pick)</a:t>
                       </a:r>
                       <a:endParaRPr lang="en-US" sz="1250" dirty="0">
                         <a:latin typeface="Arial" charset="0"/>
@@ -7388,7 +7388,7 @@
                       <a:tailEnd type="none" w="med" len="med"/>
                     </a:lnB>
                     <a:solidFill>
-                      <a:srgbClr val="111111"/>
+                      <a:srgbClr val="C8102E"/>
                     </a:solidFill>
                   </a:tcPr>
                 </a:tc>
@@ -7587,9 +7587,6 @@
                       <a:headEnd type="none" w="med" len="med"/>
                       <a:tailEnd type="none" w="med" len="med"/>
                     </a:lnB>
-                    <a:solidFill>
-                      <a:srgbClr val="FBEAEC"/>
-                    </a:solidFill>
                   </a:tcPr>
                 </a:tc>
                 <a:tc>
@@ -7785,6 +7782,9 @@
                       <a:headEnd type="none" w="med" len="med"/>
                       <a:tailEnd type="none" w="med" len="med"/>
                     </a:lnB>
+                    <a:solidFill>
+                      <a:srgbClr val="FBEAEC"/>
+                    </a:solidFill>
                   </a:tcPr>
                 </a:tc>
               </a:tr>
@@ -7982,9 +7982,6 @@
                       <a:headEnd type="none" w="med" len="med"/>
                       <a:tailEnd type="none" w="med" len="med"/>
                     </a:lnB>
-                    <a:solidFill>
-                      <a:srgbClr val="FBEAEC"/>
-                    </a:solidFill>
                   </a:tcPr>
                 </a:tc>
                 <a:tc>
@@ -8180,6 +8177,9 @@
                       <a:headEnd type="none" w="med" len="med"/>
                       <a:tailEnd type="none" w="med" len="med"/>
                     </a:lnB>
+                    <a:solidFill>
+                      <a:srgbClr val="FBEAEC"/>
+                    </a:solidFill>
                   </a:tcPr>
                 </a:tc>
               </a:tr>
@@ -8377,9 +8377,6 @@
                       <a:headEnd type="none" w="med" len="med"/>
                       <a:tailEnd type="none" w="med" len="med"/>
                     </a:lnB>
-                    <a:solidFill>
-                      <a:srgbClr val="FBEAEC"/>
-                    </a:solidFill>
                   </a:tcPr>
                 </a:tc>
                 <a:tc>
@@ -8575,6 +8572,9 @@
                       <a:headEnd type="none" w="med" len="med"/>
                       <a:tailEnd type="none" w="med" len="med"/>
                     </a:lnB>
+                    <a:solidFill>
+                      <a:srgbClr val="FBEAEC"/>
+                    </a:solidFill>
                   </a:tcPr>
                 </a:tc>
               </a:tr>
@@ -8772,9 +8772,6 @@
                       <a:headEnd type="none" w="med" len="med"/>
                       <a:tailEnd type="none" w="med" len="med"/>
                     </a:lnB>
-                    <a:solidFill>
-                      <a:srgbClr val="FBEAEC"/>
-                    </a:solidFill>
                   </a:tcPr>
                 </a:tc>
                 <a:tc>
@@ -8970,6 +8967,9 @@
                       <a:headEnd type="none" w="med" len="med"/>
                       <a:tailEnd type="none" w="med" len="med"/>
                     </a:lnB>
+                    <a:solidFill>
+                      <a:srgbClr val="FBEAEC"/>
+                    </a:solidFill>
                   </a:tcPr>
                 </a:tc>
               </a:tr>
@@ -9167,9 +9167,6 @@
                       <a:headEnd type="none" w="med" len="med"/>
                       <a:tailEnd type="none" w="med" len="med"/>
                     </a:lnB>
-                    <a:solidFill>
-                      <a:srgbClr val="FBEAEC"/>
-                    </a:solidFill>
                   </a:tcPr>
                 </a:tc>
                 <a:tc>
@@ -9365,6 +9362,9 @@
                       <a:headEnd type="none" w="med" len="med"/>
                       <a:tailEnd type="none" w="med" len="med"/>
                     </a:lnB>
+                    <a:solidFill>
+                      <a:srgbClr val="FBEAEC"/>
+                    </a:solidFill>
                   </a:tcPr>
                 </a:tc>
               </a:tr>
@@ -9562,9 +9562,6 @@
                       <a:headEnd type="none" w="med" len="med"/>
                       <a:tailEnd type="none" w="med" len="med"/>
                     </a:lnB>
-                    <a:solidFill>
-                      <a:srgbClr val="FBEAEC"/>
-                    </a:solidFill>
                   </a:tcPr>
                 </a:tc>
                 <a:tc>
@@ -9760,6 +9757,9 @@
                       <a:headEnd type="none" w="med" len="med"/>
                       <a:tailEnd type="none" w="med" len="med"/>
                     </a:lnB>
+                    <a:solidFill>
+                      <a:srgbClr val="FBEAEC"/>
+                    </a:solidFill>
                   </a:tcPr>
                 </a:tc>
               </a:tr>
@@ -9822,7 +9822,7 @@
                 <a:ea typeface="Arial" pitchFamily="34" charset="-122"/>
                 <a:cs typeface="Arial" pitchFamily="34" charset="-120"/>
               </a:rPr>
-              <a:t>Silver: ≤ $3.33 per damage-filtered homeowner record. </a:t>
+              <a:t>Founding = every Platinum feature at $2,000 — $6,000/yr under sticker, locked for life. </a:t>
             </a:r>
             <a:pPr indent="0" marL="0">
               <a:buNone/>
@@ -9836,7 +9836,7 @@
                 <a:ea typeface="Arial" pitchFamily="34" charset="-122"/>
                 <a:cs typeface="Arial" pitchFamily="34" charset="-120"/>
               </a:rPr>
-              <a:t>Shared-lead sellers: $150–300 per lead, resold to competitors. Not identical products — but that gap is the whole thesis.</a:t>
+              <a:t>Unlimited maps, leads, and outreach for the whole team, vs. $150–300 per shared lead resold to competitors.</a:t>
             </a:r>
             <a:endParaRPr lang="en-US" sz="1350" dirty="0"/>
           </a:p>
@@ -10334,7 +10334,7 @@
                 <a:ea typeface="Arial" pitchFamily="34" charset="-122"/>
                 <a:cs typeface="Arial" pitchFamily="34" charset="-120"/>
               </a:rPr>
-              <a:t>Silver pays for itself with 2 jobs a year. </a:t>
+              <a:t>Founding breaks even at 5.7 jobs a year — one incremental job every ~9 weeks. </a:t>
             </a:r>
             <a:pPr indent="0" marL="0">
               <a:buNone/>
@@ -10348,7 +10348,7 @@
                 <a:ea typeface="Arial" pitchFamily="34" charset="-122"/>
                 <a:cs typeface="Arial" pitchFamily="34" charset="-120"/>
               </a:rPr>
-              <a:t>Even top-tier Platinum only needs ~7 — one good hailstorm.</a:t>
+              <a:t>Everything past that is margin, and it's $500/mo under Platinum sticker forever.</a:t>
             </a:r>
             <a:endParaRPr lang="en-US" sz="1600" dirty="0"/>
           </a:p>
@@ -10486,7 +10486,7 @@
                 <a:ea typeface="Arial" pitchFamily="34" charset="-122"/>
                 <a:cs typeface="Arial" pitchFamily="34" charset="-120"/>
               </a:rPr>
-              <a:t>The 90-day pilot: scored, capped, killable</a:t>
+              <a:t>The 90-day proof period: scored, capped, killable</a:t>
             </a:r>
             <a:endParaRPr lang="en-US" sz="3200" dirty="0"/>
           </a:p>
@@ -10525,7 +10525,7 @@
                 <a:ea typeface="Arial" pitchFamily="34" charset="-122"/>
                 <a:cs typeface="Arial" pitchFamily="34" charset="-120"/>
               </a:rPr>
-              <a:t>Two reps run Storm Scout on Silver ($500/mo); the rest keep the current playbook. Same scorecard for both.</a:t>
+              <a:t>Full team goes live on Founding day 1 — but 2 reps keep the current playbook as the control, so the comparison stays honest.</a:t>
             </a:r>
             <a:endParaRPr lang="en-US" sz="1500" dirty="0"/>
           </a:p>
@@ -11647,7 +11647,7 @@
                 <a:ea typeface="Arial" pitchFamily="34" charset="-122"/>
                 <a:cs typeface="Arial" pitchFamily="34" charset="-120"/>
               </a:rPr>
-              <a:t>if all-in cost per sold job isn't beating our current baseline at day 90, we cancel. Total pilot spend: $1,500 — about a third of one job's gross profit. We confirm month-to-month terms in the demo; no annual lock-in without pilot data.</a:t>
+              <a:t>if all-in cost per sold job isn't beating our current baseline at day 90, we cancel. Spend at risk: $6,000 — under 1.5 jobs' gross profit. Condition: the demo must confirm Founding bills monthly and cancels clean. No prepaid annual, period.</a:t>
             </a:r>
             <a:endParaRPr lang="en-US" sz="1450" dirty="0"/>
           </a:p>
@@ -11686,7 +11686,7 @@
                 <a:ea typeface="Arial" pitchFamily="34" charset="-122"/>
                 <a:cs typeface="Arial" pitchFamily="34" charset="-120"/>
               </a:rPr>
-              <a:t>Silver's 150 homeowner records/month covers 2 reps; upgrade to Gold mid-pilot only if the cap actually binds.</a:t>
+              <a:t>Targets are proposals — Aaron/Alan set final thresholds before we start.</a:t>
             </a:r>
             <a:endParaRPr lang="en-US" sz="900" dirty="0"/>
           </a:p>
@@ -11901,7 +11901,7 @@
                 <a:ea typeface="Arial" pitchFamily="34" charset="-122"/>
                 <a:cs typeface="Arial" pitchFamily="34" charset="-120"/>
               </a:rPr>
-              <a:t>“Why not the $2,000 Founding deal?”</a:t>
+              <a:t>“Isn't the ‘limited offer’ a sales tactic?”</a:t>
             </a:r>
             <a:endParaRPr lang="en-US" sz="1600" dirty="0"/>
           </a:p>
@@ -11940,7 +11940,7 @@
                 <a:ea typeface="Arial" pitchFamily="34" charset="-122"/>
                 <a:cs typeface="Arial" pitchFamily="34" charset="-120"/>
               </a:rPr>
-              <a:t>Because it's a $24k/yr decision sold on urgency. If the tool proves out, paying full Platinum later still breaks even at ~7 jobs/yr. Pilot at $500/mo first; lock in only with our own data.</a:t>
+              <a:t>Probably — and it doesn't matter. If billing is monthly, the lock is a free option: keep it and we pay $500/mo under sticker forever; cancel at day 90 and we lose a rate we no longer wanted. We only walk if they demand prepaid annual.</a:t>
             </a:r>
             <a:endParaRPr lang="en-US" sz="1200" dirty="0"/>
           </a:p>
@@ -12372,7 +12372,7 @@
                 <a:ea typeface="Arial" pitchFamily="34" charset="-122"/>
                 <a:cs typeface="Arial" pitchFamily="34" charset="-120"/>
               </a:rPr>
-              <a:t>Adoption is the real risk with any tool. That's why it's 2 named reps with a named owner (Dom), not a company-wide rollout. Small test, clean data, no chaos.</a:t>
+              <a:t>Adoption is the real risk with any tool. So it gets a named owner (Dom), the whole team trains on it day 1, and usage shows up in the weekly scorecard. Reps not working the lists is visible in the numbers within two weeks.</a:t>
             </a:r>
             <a:endParaRPr lang="en-US" sz="1200" dirty="0"/>
           </a:p>

</xml_diff>

<commit_message>
Use T-Rock actual job economics in the pitch deck
Break-even model now uses the real $30,000 average ticket at 35%
margin ($10,500 gross profit per job): Founding breaks even at 2.3
jobs/year. Founding billing stated as confirmed $2,000/month locked
for life, with cancellation terms in writing as the remaining
demo checklist item.

Co-Authored-By: Claude Fable 5 <noreply@anthropic.com>
Claude-Session: https://claude.ai/code/session_01Qj1b2D7LVH4xves4mfA9FY
</commit_message>
<xml_diff>
--- a/pitch/Storm-Scout-Pitch.pptx
+++ b/pitch/Storm-Scout-Pitch.pptx
@@ -234,19 +234,19 @@
                 <c:formatCode>General</c:formatCode>
                 <c:ptCount val="5"/>
                 <c:pt idx="0">
-                  <c:v>0.3</c:v>
+                  <c:v>0.1</c:v>
                 </c:pt>
                 <c:pt idx="1">
-                  <c:v>1.4</c:v>
+                  <c:v>0.6</c:v>
                 </c:pt>
                 <c:pt idx="2">
-                  <c:v>2.9</c:v>
+                  <c:v>1.1</c:v>
                 </c:pt>
                 <c:pt idx="3">
-                  <c:v>5.7</c:v>
+                  <c:v>2.3</c:v>
                 </c:pt>
                 <c:pt idx="4">
-                  <c:v>7.1</c:v>
+                  <c:v>2.9</c:v>
                 </c:pt>
               </c:numCache>
             </c:numRef>
@@ -327,7 +327,7 @@
         <c:axId val="2094734552"/>
         <c:scaling>
           <c:orientation val="minMax"/>
-          <c:max val="8"/>
+          <c:max val="3.5"/>
         </c:scaling>
         <c:delete val="0"/>
         <c:axPos val="l"/>
@@ -2420,7 +2420,7 @@
                 <a:ea typeface="Arial" pitchFamily="34" charset="-122"/>
                 <a:cs typeface="Arial" pitchFamily="34" charset="-120"/>
               </a:rPr>
-              <a:t>30 minutes. Confirm the Founding offer is still open, bills monthly, and cancels clean. Verify storm-map coverage in our markets.</a:t>
+              <a:t>30 minutes. Confirm the Founding offer is still open and get cancellation terms in writing. Verify storm-map coverage in our markets.</a:t>
             </a:r>
             <a:endParaRPr lang="en-US" sz="1250" dirty="0"/>
           </a:p>
@@ -9875,7 +9875,7 @@
                 <a:ea typeface="Arial" pitchFamily="34" charset="-122"/>
                 <a:cs typeface="Arial" pitchFamily="34" charset="-120"/>
               </a:rPr>
-              <a:t>*Founding Member: all Platinum features, “limited offer” price lock — verify billing cadence and terms on the demo. Source: stormscout.ai/pricing, Aug 20, 2026.</a:t>
+              <a:t>*Founding Member: all Platinum features, $2,000/month locked for life. Get cancellation terms in writing on the demo. Source: stormscout.ai/pricing, Aug 20, 2026.</a:t>
             </a:r>
             <a:endParaRPr lang="en-US" sz="900" dirty="0"/>
           </a:p>
@@ -10024,7 +10024,7 @@
                 <a:ea typeface="Arial" pitchFamily="34" charset="-122"/>
                 <a:cs typeface="Arial" pitchFamily="34" charset="-120"/>
               </a:rPr>
-              <a:t>Their published prices against our job economics. Assumptions on the left — swap in T-Rock actuals.</a:t>
+              <a:t>Their published prices against T-Rock's actual job economics.</a:t>
             </a:r>
             <a:endParaRPr lang="en-US" sz="1500" dirty="0"/>
           </a:p>
@@ -10085,7 +10085,7 @@
                 <a:ea typeface="Arial" pitchFamily="34" charset="-122"/>
                 <a:cs typeface="Arial" pitchFamily="34" charset="-120"/>
               </a:rPr>
-              <a:t>Model assumptions</a:t>
+              <a:t>T-Rock job economics</a:t>
             </a:r>
             <a:endParaRPr lang="en-US" sz="1600" dirty="0"/>
           </a:p>
@@ -10125,7 +10125,7 @@
                 <a:ea typeface="Arial" pitchFamily="34" charset="-122"/>
                 <a:cs typeface="Arial" pitchFamily="34" charset="-120"/>
               </a:rPr>
-              <a:t>Avg. insurance replacement job</a:t>
+              <a:t>Average ticket</a:t>
             </a:r>
             <a:endParaRPr lang="en-US" sz="1350" dirty="0"/>
           </a:p>
@@ -10145,7 +10145,7 @@
                 <a:ea typeface="Arial" pitchFamily="34" charset="-122"/>
                 <a:cs typeface="Arial" pitchFamily="34" charset="-120"/>
               </a:rPr>
-              <a:t>$12,000 revenue</a:t>
+              <a:t>$30,000 revenue</a:t>
             </a:r>
             <a:endParaRPr lang="en-US" sz="1350" dirty="0"/>
           </a:p>
@@ -10183,7 +10183,7 @@
                 <a:ea typeface="Arial" pitchFamily="34" charset="-122"/>
                 <a:cs typeface="Arial" pitchFamily="34" charset="-120"/>
               </a:rPr>
-              <a:t>35%  →  ~$4,200 gross profit / job</a:t>
+              <a:t>35%  →  ~$10,500 gross profit / job</a:t>
             </a:r>
             <a:endParaRPr lang="en-US" sz="1350" dirty="0"/>
           </a:p>
@@ -10218,7 +10218,7 @@
                 <a:ea typeface="Arial" pitchFamily="34" charset="-122"/>
                 <a:cs typeface="Arial" pitchFamily="34" charset="-120"/>
               </a:rPr>
-              <a:t>annual cost ÷ $4,200</a:t>
+              <a:t>annual cost ÷ $10,500</a:t>
             </a:r>
             <a:endParaRPr lang="en-US" sz="1350" dirty="0"/>
           </a:p>
@@ -10257,7 +10257,7 @@
                 <a:ea typeface="Arial" pitchFamily="34" charset="-122"/>
                 <a:cs typeface="Arial" pitchFamily="34" charset="-120"/>
               </a:rPr>
-              <a:t>Placeholder benchmarks — swap in T-Rock's actual avg. ticket and margin before the meeting.</a:t>
+              <a:t>Average ticket and margin per Dom — T-Rock actuals, not industry benchmarks.</a:t>
             </a:r>
             <a:endParaRPr lang="en-US" sz="1050" dirty="0"/>
           </a:p>
@@ -10334,7 +10334,7 @@
                 <a:ea typeface="Arial" pitchFamily="34" charset="-122"/>
                 <a:cs typeface="Arial" pitchFamily="34" charset="-120"/>
               </a:rPr>
-              <a:t>Founding breaks even at 5.7 jobs a year — one incremental job every ~9 weeks. </a:t>
+              <a:t>Founding breaks even at 2.3 jobs a year — one incremental roof every ~5 months. </a:t>
             </a:r>
             <a:pPr indent="0" marL="0">
               <a:buNone/>
@@ -11647,7 +11647,7 @@
                 <a:ea typeface="Arial" pitchFamily="34" charset="-122"/>
                 <a:cs typeface="Arial" pitchFamily="34" charset="-120"/>
               </a:rPr>
-              <a:t>if all-in cost per sold job isn't beating our current baseline at day 90, we cancel. Spend at risk: $6,000 — under 1.5 jobs' gross profit. Condition: the demo must confirm Founding bills monthly and cancels clean. No prepaid annual, period.</a:t>
+              <a:t>if all-in cost per sold job isn't beating our current baseline at day 90, we cancel. Spend at risk: $6,000 — about half of one job's gross profit. Founding bills $2,000 monthly; we get clean cancellation terms in writing before signing.</a:t>
             </a:r>
             <a:endParaRPr lang="en-US" sz="1450" dirty="0"/>
           </a:p>
@@ -11940,7 +11940,7 @@
                 <a:ea typeface="Arial" pitchFamily="34" charset="-122"/>
                 <a:cs typeface="Arial" pitchFamily="34" charset="-120"/>
               </a:rPr>
-              <a:t>Probably — and it doesn't matter. If billing is monthly, the lock is a free option: keep it and we pay $500/mo under sticker forever; cancel at day 90 and we lose a rate we no longer wanted. We only walk if they demand prepaid annual.</a:t>
+              <a:t>Probably — and it doesn't matter. Billing is $2,000 monthly, locked forever: keep it and we pay $500/mo under sticker for life; cancel at day 90 and we're out $6,000 — half of one job's gross profit. Only dealbreaker: cancellation terms that aren't clean.</a:t>
             </a:r>
             <a:endParaRPr lang="en-US" sz="1200" dirty="0"/>
           </a:p>

</xml_diff>

<commit_message>
Model break-even on T-Rock's net share per job
Per-job economics now reflect the real structure: $30,000 RCV x 35% =
$10,500, less the 2% RCV scope fee ($600) as a job cost, then a 50/50
PM profit split, netting T-Rock $4,950/job. The subscription is treated
as overhead against that share, so Founding breaks even at 4.8
jobs/year. Demo checklist adds DNC/TCPA compliance for automated
outreach.

Co-Authored-By: Claude Fable 5 <noreply@anthropic.com>
Claude-Session: https://claude.ai/code/session_01Qj1b2D7LVH4xves4mfA9FY
</commit_message>
<xml_diff>
--- a/pitch/Storm-Scout-Pitch.pptx
+++ b/pitch/Storm-Scout-Pitch.pptx
@@ -234,19 +234,19 @@
                 <c:formatCode>General</c:formatCode>
                 <c:ptCount val="5"/>
                 <c:pt idx="0">
-                  <c:v>0.1</c:v>
+                  <c:v>0.2</c:v>
                 </c:pt>
                 <c:pt idx="1">
-                  <c:v>0.6</c:v>
+                  <c:v>1.2</c:v>
                 </c:pt>
                 <c:pt idx="2">
-                  <c:v>1.1</c:v>
+                  <c:v>2.4</c:v>
                 </c:pt>
                 <c:pt idx="3">
-                  <c:v>2.3</c:v>
+                  <c:v>4.8</c:v>
                 </c:pt>
                 <c:pt idx="4">
-                  <c:v>2.9</c:v>
+                  <c:v>6.1</c:v>
                 </c:pt>
               </c:numCache>
             </c:numRef>
@@ -327,7 +327,7 @@
         <c:axId val="2094734552"/>
         <c:scaling>
           <c:orientation val="minMax"/>
-          <c:max val="3.5"/>
+          <c:max val="7"/>
         </c:scaling>
         <c:delete val="0"/>
         <c:axPos val="l"/>
@@ -2420,7 +2420,7 @@
                 <a:ea typeface="Arial" pitchFamily="34" charset="-122"/>
                 <a:cs typeface="Arial" pitchFamily="34" charset="-120"/>
               </a:rPr>
-              <a:t>30 minutes. Confirm the Founding offer is still open and get cancellation terms in writing. Verify storm-map coverage in our markets.</a:t>
+              <a:t>30 minutes. Confirm the Founding offer is still open, get cancellation terms in writing, and ask how automated calls/texts handle DNC &amp; TCPA compliance.</a:t>
             </a:r>
             <a:endParaRPr lang="en-US" sz="1250" dirty="0"/>
           </a:p>
@@ -10085,7 +10085,7 @@
                 <a:ea typeface="Arial" pitchFamily="34" charset="-122"/>
                 <a:cs typeface="Arial" pitchFamily="34" charset="-120"/>
               </a:rPr>
-              <a:t>T-Rock job economics</a:t>
+              <a:t>T-Rock net per job</a:t>
             </a:r>
             <a:endParaRPr lang="en-US" sz="1600" dirty="0"/>
           </a:p>
@@ -10100,7 +10100,7 @@
         <p:spPr>
           <a:xfrm>
             <a:off x="868680" y="2240280"/>
-            <a:ext cx="3566160" cy="2194560"/>
+            <a:ext cx="3566160" cy="2286000"/>
           </a:xfrm>
           <a:prstGeom prst="rect">
             <a:avLst/>
@@ -10117,7 +10117,7 @@
               <a:buChar char="•"/>
             </a:pPr>
             <a:r>
-              <a:rPr lang="en-US" sz="1350" b="1" dirty="0">
+              <a:rPr lang="en-US" sz="1250" b="1" dirty="0">
                 <a:solidFill>
                   <a:srgbClr val="2A2A2A"/>
                 </a:solidFill>
@@ -10125,19 +10125,16 @@
                 <a:ea typeface="Arial" pitchFamily="34" charset="-122"/>
                 <a:cs typeface="Arial" pitchFamily="34" charset="-120"/>
               </a:rPr>
-              <a:t>Average ticket</a:t>
+              <a:t>Avg ticket (RCV):  </a:t>
             </a:r>
-            <a:endParaRPr lang="en-US" sz="1350" dirty="0"/>
-          </a:p>
-          <a:p>
-            <a:pPr lvl="1" indent="0" marL="0">
+            <a:pPr indent="0" marL="0">
               <a:spcAft>
-                <a:spcPts val="800"/>
+                <a:spcPts val="600"/>
               </a:spcAft>
               <a:buNone/>
             </a:pPr>
             <a:r>
-              <a:rPr lang="en-US" sz="1350" b="1" dirty="0">
+              <a:rPr lang="en-US" sz="1250" b="1" dirty="0">
                 <a:solidFill>
                   <a:srgbClr val="C8102E"/>
                 </a:solidFill>
@@ -10145,9 +10142,9 @@
                 <a:ea typeface="Arial" pitchFamily="34" charset="-122"/>
                 <a:cs typeface="Arial" pitchFamily="34" charset="-120"/>
               </a:rPr>
-              <a:t>$30,000 revenue</a:t>
+              <a:t>$30,000</a:t>
             </a:r>
-            <a:endParaRPr lang="en-US" sz="1350" dirty="0"/>
+            <a:endParaRPr lang="en-US" sz="1250" dirty="0"/>
           </a:p>
           <a:p>
             <a:pPr marL="342900" indent="-342900">
@@ -10155,7 +10152,7 @@
               <a:buChar char="•"/>
             </a:pPr>
             <a:r>
-              <a:rPr lang="en-US" sz="1350" b="1" dirty="0">
+              <a:rPr lang="en-US" sz="1250" b="1" dirty="0">
                 <a:solidFill>
                   <a:srgbClr val="2A2A2A"/>
                 </a:solidFill>
@@ -10163,19 +10160,16 @@
                 <a:ea typeface="Arial" pitchFamily="34" charset="-122"/>
                 <a:cs typeface="Arial" pitchFamily="34" charset="-120"/>
               </a:rPr>
-              <a:t>Gross margin</a:t>
+              <a:t>Gross margin 35%:  </a:t>
             </a:r>
-            <a:endParaRPr lang="en-US" sz="1350" dirty="0"/>
-          </a:p>
-          <a:p>
-            <a:pPr lvl="1" indent="0" marL="0">
+            <a:pPr indent="0" marL="0">
               <a:spcAft>
-                <a:spcPts val="800"/>
+                <a:spcPts val="600"/>
               </a:spcAft>
               <a:buNone/>
             </a:pPr>
             <a:r>
-              <a:rPr lang="en-US" sz="1350" b="1" dirty="0">
+              <a:rPr lang="en-US" sz="1250" b="1" dirty="0">
                 <a:solidFill>
                   <a:srgbClr val="C8102E"/>
                 </a:solidFill>
@@ -10183,9 +10177,9 @@
                 <a:ea typeface="Arial" pitchFamily="34" charset="-122"/>
                 <a:cs typeface="Arial" pitchFamily="34" charset="-120"/>
               </a:rPr>
-              <a:t>35%  →  ~$10,500 gross profit / job</a:t>
+              <a:t>$10,500</a:t>
             </a:r>
-            <a:endParaRPr lang="en-US" sz="1350" dirty="0"/>
+            <a:endParaRPr lang="en-US" sz="1250" dirty="0"/>
           </a:p>
           <a:p>
             <a:pPr marL="342900" indent="-342900">
@@ -10193,7 +10187,7 @@
               <a:buChar char="•"/>
             </a:pPr>
             <a:r>
-              <a:rPr lang="en-US" sz="1350" b="1" dirty="0">
+              <a:rPr lang="en-US" sz="1250" b="1" dirty="0">
                 <a:solidFill>
                   <a:srgbClr val="2A2A2A"/>
                 </a:solidFill>
@@ -10201,16 +10195,16 @@
                 <a:ea typeface="Arial" pitchFamily="34" charset="-122"/>
                 <a:cs typeface="Arial" pitchFamily="34" charset="-120"/>
               </a:rPr>
-              <a:t>Jobs to break even</a:t>
+              <a:t>Scope fee (2% RCV):  </a:t>
             </a:r>
-            <a:endParaRPr lang="en-US" sz="1350" dirty="0"/>
-          </a:p>
-          <a:p>
-            <a:pPr lvl="1" indent="0" marL="0">
+            <a:pPr indent="0" marL="0">
+              <a:spcAft>
+                <a:spcPts val="600"/>
+              </a:spcAft>
               <a:buNone/>
             </a:pPr>
             <a:r>
-              <a:rPr lang="en-US" sz="1350" b="1" dirty="0">
+              <a:rPr lang="en-US" sz="1250" b="1" dirty="0">
                 <a:solidFill>
                   <a:srgbClr val="C8102E"/>
                 </a:solidFill>
@@ -10218,9 +10212,111 @@
                 <a:ea typeface="Arial" pitchFamily="34" charset="-122"/>
                 <a:cs typeface="Arial" pitchFamily="34" charset="-120"/>
               </a:rPr>
-              <a:t>annual cost ÷ $10,500</a:t>
+              <a:t>− $600</a:t>
             </a:r>
-            <a:endParaRPr lang="en-US" sz="1350" dirty="0"/>
+            <a:endParaRPr lang="en-US" sz="1250" dirty="0"/>
+          </a:p>
+          <a:p>
+            <a:pPr marL="342900" indent="-342900">
+              <a:buSzPct val="100000"/>
+              <a:buChar char="•"/>
+            </a:pPr>
+            <a:r>
+              <a:rPr lang="en-US" sz="1250" b="1" dirty="0">
+                <a:solidFill>
+                  <a:srgbClr val="2A2A2A"/>
+                </a:solidFill>
+                <a:latin typeface="Arial" pitchFamily="34" charset="0"/>
+                <a:ea typeface="Arial" pitchFamily="34" charset="-122"/>
+                <a:cs typeface="Arial" pitchFamily="34" charset="-120"/>
+              </a:rPr>
+              <a:t>Job profit:  </a:t>
+            </a:r>
+            <a:pPr indent="0" marL="0">
+              <a:spcAft>
+                <a:spcPts val="600"/>
+              </a:spcAft>
+              <a:buNone/>
+            </a:pPr>
+            <a:r>
+              <a:rPr lang="en-US" sz="1250" b="1" dirty="0">
+                <a:solidFill>
+                  <a:srgbClr val="C8102E"/>
+                </a:solidFill>
+                <a:latin typeface="Arial" pitchFamily="34" charset="0"/>
+                <a:ea typeface="Arial" pitchFamily="34" charset="-122"/>
+                <a:cs typeface="Arial" pitchFamily="34" charset="-120"/>
+              </a:rPr>
+              <a:t>$9,900, split 50/50 w/ PM</a:t>
+            </a:r>
+            <a:endParaRPr lang="en-US" sz="1250" dirty="0"/>
+          </a:p>
+          <a:p>
+            <a:pPr marL="342900" indent="-342900">
+              <a:buSzPct val="100000"/>
+              <a:buChar char="•"/>
+            </a:pPr>
+            <a:r>
+              <a:rPr lang="en-US" sz="1250" b="1" dirty="0">
+                <a:solidFill>
+                  <a:srgbClr val="2A2A2A"/>
+                </a:solidFill>
+                <a:latin typeface="Arial" pitchFamily="34" charset="0"/>
+                <a:ea typeface="Arial" pitchFamily="34" charset="-122"/>
+                <a:cs typeface="Arial" pitchFamily="34" charset="-120"/>
+              </a:rPr>
+              <a:t>T-Rock net / job:  </a:t>
+            </a:r>
+            <a:pPr indent="0" marL="0">
+              <a:spcAft>
+                <a:spcPts val="600"/>
+              </a:spcAft>
+              <a:buNone/>
+            </a:pPr>
+            <a:r>
+              <a:rPr lang="en-US" sz="1250" b="1" dirty="0">
+                <a:solidFill>
+                  <a:srgbClr val="C8102E"/>
+                </a:solidFill>
+                <a:latin typeface="Arial" pitchFamily="34" charset="0"/>
+                <a:ea typeface="Arial" pitchFamily="34" charset="-122"/>
+                <a:cs typeface="Arial" pitchFamily="34" charset="-120"/>
+              </a:rPr>
+              <a:t>$4,950</a:t>
+            </a:r>
+            <a:endParaRPr lang="en-US" sz="1250" dirty="0"/>
+          </a:p>
+          <a:p>
+            <a:pPr marL="342900" indent="-342900">
+              <a:buSzPct val="100000"/>
+              <a:buChar char="•"/>
+            </a:pPr>
+            <a:r>
+              <a:rPr lang="en-US" sz="1250" b="1" dirty="0">
+                <a:solidFill>
+                  <a:srgbClr val="2A2A2A"/>
+                </a:solidFill>
+                <a:latin typeface="Arial" pitchFamily="34" charset="0"/>
+                <a:ea typeface="Arial" pitchFamily="34" charset="-122"/>
+                <a:cs typeface="Arial" pitchFamily="34" charset="-120"/>
+              </a:rPr>
+              <a:t>Break even:  </a:t>
+            </a:r>
+            <a:pPr indent="0" marL="0">
+              <a:buNone/>
+            </a:pPr>
+            <a:r>
+              <a:rPr lang="en-US" sz="1250" b="1" dirty="0">
+                <a:solidFill>
+                  <a:srgbClr val="C8102E"/>
+                </a:solidFill>
+                <a:latin typeface="Arial" pitchFamily="34" charset="0"/>
+                <a:ea typeface="Arial" pitchFamily="34" charset="-122"/>
+                <a:cs typeface="Arial" pitchFamily="34" charset="-120"/>
+              </a:rPr>
+              <a:t>annual cost ÷ $4,950</a:t>
+            </a:r>
+            <a:endParaRPr lang="en-US" sz="1250" dirty="0"/>
           </a:p>
         </p:txBody>
       </p:sp>
@@ -10257,7 +10353,7 @@
                 <a:ea typeface="Arial" pitchFamily="34" charset="-122"/>
                 <a:cs typeface="Arial" pitchFamily="34" charset="-120"/>
               </a:rPr>
-              <a:t>Average ticket and margin per Dom — T-Rock actuals, not industry benchmarks.</a:t>
+              <a:t>Subscription is overhead (not job-attributable), so it's measured against T-Rock's share — the conservative view.</a:t>
             </a:r>
             <a:endParaRPr lang="en-US" sz="1050" dirty="0"/>
           </a:p>
@@ -10326,7 +10422,7 @@
               <a:buNone/>
             </a:pPr>
             <a:r>
-              <a:rPr lang="en-US" sz="1600" b="1" dirty="0">
+              <a:rPr lang="en-US" sz="1500" b="1" dirty="0">
                 <a:solidFill>
                   <a:srgbClr val="FFFFFF"/>
                 </a:solidFill>
@@ -10334,13 +10430,13 @@
                 <a:ea typeface="Arial" pitchFamily="34" charset="-122"/>
                 <a:cs typeface="Arial" pitchFamily="34" charset="-120"/>
               </a:rPr>
-              <a:t>Founding breaks even at 2.3 jobs a year — one incremental roof every ~5 months. </a:t>
+              <a:t>Founding breaks even at 4.8 jobs a year — one incremental roof every ~11 weeks — on T-Rock's share alone. </a:t>
             </a:r>
             <a:pPr indent="0" marL="0">
               <a:buNone/>
             </a:pPr>
             <a:r>
-              <a:rPr lang="en-US" sz="1600" dirty="0">
+              <a:rPr lang="en-US" sz="1500" dirty="0">
                 <a:solidFill>
                   <a:srgbClr val="E6E6E6"/>
                 </a:solidFill>
@@ -10348,9 +10444,9 @@
                 <a:ea typeface="Arial" pitchFamily="34" charset="-122"/>
                 <a:cs typeface="Arial" pitchFamily="34" charset="-120"/>
               </a:rPr>
-              <a:t>Everything past that is margin, and it's $500/mo under Platinum sticker forever.</a:t>
+              <a:t>Past that it's margin, at $500/mo under Platinum sticker forever.</a:t>
             </a:r>
-            <a:endParaRPr lang="en-US" sz="1600" dirty="0"/>
+            <a:endParaRPr lang="en-US" sz="1500" dirty="0"/>
           </a:p>
         </p:txBody>
       </p:sp>
@@ -10378,6 +10474,17 @@
             <a:pPr indent="0" marL="0">
               <a:buNone/>
             </a:pPr>
+            <a:r>
+              <a:rPr lang="en-US" sz="900" dirty="0">
+                <a:solidFill>
+                  <a:srgbClr val="6E6E6E"/>
+                </a:solidFill>
+                <a:latin typeface="Arial" pitchFamily="34" charset="0"/>
+                <a:ea typeface="Arial" pitchFamily="34" charset="-122"/>
+                <a:cs typeface="Arial" pitchFamily="34" charset="-120"/>
+              </a:rPr>
+              <a:t>Per job: $30,000 × 35% = $10,500, less 2% RCV scope fee ($600) = $9,900, split 50/50 with the PM → $4,950 to T-Rock.</a:t>
+            </a:r>
             <a:endParaRPr lang="en-US" sz="900" dirty="0"/>
           </a:p>
         </p:txBody>
@@ -11647,7 +11754,7 @@
                 <a:ea typeface="Arial" pitchFamily="34" charset="-122"/>
                 <a:cs typeface="Arial" pitchFamily="34" charset="-120"/>
               </a:rPr>
-              <a:t>if all-in cost per sold job isn't beating our current baseline at day 90, we cancel. Spend at risk: $6,000 — about half of one job's gross profit. Founding bills $2,000 monthly; we get clean cancellation terms in writing before signing.</a:t>
+              <a:t>if all-in cost per sold job isn't beating our current baseline at day 90, we cancel. Spend at risk: $6,000 — T-Rock's net on about 1.2 jobs. Founding bills $2,000 monthly; we get clean cancellation terms in writing before signing.</a:t>
             </a:r>
             <a:endParaRPr lang="en-US" sz="1450" dirty="0"/>
           </a:p>
@@ -11940,7 +12047,7 @@
                 <a:ea typeface="Arial" pitchFamily="34" charset="-122"/>
                 <a:cs typeface="Arial" pitchFamily="34" charset="-120"/>
               </a:rPr>
-              <a:t>Probably — and it doesn't matter. Billing is $2,000 monthly, locked forever: keep it and we pay $500/mo under sticker for life; cancel at day 90 and we're out $6,000 — half of one job's gross profit. Only dealbreaker: cancellation terms that aren't clean.</a:t>
+              <a:t>Probably — and it doesn't matter. Billing is $2,000 monthly, locked forever: keep it and we pay $500/mo under sticker for life; cancel at day 90 and we're out $6,000 — T-Rock's net on about one job. Only dealbreaker: cancellation terms that aren't clean.</a:t>
             </a:r>
             <a:endParaRPr lang="en-US" sz="1200" dirty="0"/>
           </a:p>

</xml_diff>

<commit_message>
Neutralize audience tells, add upside slide, add commission plan deck
Storm Scout deck: brand corrected to T^Rock throughout, personalized
title and audience references replaced with neutral leadership wording,
rep economics reframed for a 50/50 commission model, and a new
revenue-upside slide with three incremental-roof scenarios plus a
competitive-urgency callout. Demo checklist adds lead-data-export terms.

New Commission-Plan.pptx (+ generator): performance pay plan for the
scope-writing/lead-ops seat - close-rate slider (2%-10% of RCV), cost
per job and per-100-leads math, RCV-vs-profit basis options, risk
comparison vs staff estimator and supplement services, next steps.

Co-Authored-By: Claude Fable 5 <noreply@anthropic.com>
Claude-Session: https://claude.ai/code/session_01Qj1b2D7LVH4xves4mfA9FY
</commit_message>
<xml_diff>
--- a/pitch/Storm-Scout-Pitch.pptx
+++ b/pitch/Storm-Scout-Pitch.pptx
@@ -15,9 +15,10 @@
     <p:sldId id="263" r:id="rId9"/>
     <p:sldId id="264" r:id="rId10"/>
     <p:sldId id="265" r:id="rId11"/>
+    <p:sldId id="266" r:id="rId12"/>
   </p:sldIdLst>
   <p:notesMasterIdLst>
-    <p:notesMasterId r:id="rId12"/>
+    <p:notesMasterId r:id="rId13"/>
   </p:notesMasterIdLst>
   <p:sldSz cx="12192000" cy="6858000"/>
   <p:notesSz cx="6858000" cy="12192000"/>
@@ -905,6 +906,94 @@
             <a:fld id="{F7021451-1387-4CA6-816F-3879F97B5CBC}" type="slidenum">
               <a:rPr lang="en-US"/>
               <a:t>10</a:t>
+            </a:fld>
+            <a:endParaRPr lang="en-US"/>
+          </a:p>
+        </p:txBody>
+      </p:sp>
+    </p:spTree>
+    <p:extLst>
+      <p:ext uri="{BB962C8B-B14F-4D97-AF65-F5344CB8AC3E}">
+        <p14:creationId xmlns:p14="http://schemas.microsoft.com/office/powerpoint/2010/main" val="1024086991"/>
+      </p:ext>
+    </p:extLst>
+  </p:cSld>
+  <p:clrMapOvr>
+    <a:masterClrMapping/>
+  </p:clrMapOvr>
+</p:notes>
+</file>
+
+<file path=ppt/notesSlides/notesSlide11.xml><?xml version="1.0" encoding="utf-8"?>
+<p:notes xmlns:a="http://schemas.openxmlformats.org/drawingml/2006/main" xmlns:r="http://schemas.openxmlformats.org/officeDocument/2006/relationships" xmlns:p="http://schemas.openxmlformats.org/presentationml/2006/main">
+  <p:cSld>
+    <p:spTree>
+      <p:nvGrpSpPr>
+        <p:cNvPr id="1" name=""/>
+        <p:cNvGrpSpPr/>
+        <p:nvPr/>
+      </p:nvGrpSpPr>
+      <p:grpSpPr>
+        <a:xfrm>
+          <a:off x="0" y="0"/>
+          <a:ext cx="0" cy="0"/>
+          <a:chOff x="0" y="0"/>
+          <a:chExt cx="0" cy="0"/>
+        </a:xfrm>
+      </p:grpSpPr>
+      <p:sp>
+        <p:nvSpPr>
+          <p:cNvPr id="2" name="Slide Image Placeholder 1"/>
+          <p:cNvSpPr>
+            <a:spLocks noGrp="1" noRot="1" noChangeAspect="1"/>
+          </p:cNvSpPr>
+          <p:nvPr>
+            <p:ph type="sldImg"/>
+          </p:nvPr>
+        </p:nvSpPr>
+        <p:spPr/>
+      </p:sp>
+      <p:sp>
+        <p:nvSpPr>
+          <p:cNvPr id="3" name="Notes Placeholder 2"/>
+          <p:cNvSpPr>
+            <a:spLocks noGrp="1"/>
+          </p:cNvSpPr>
+          <p:nvPr>
+            <p:ph type="body" idx="1"/>
+          </p:nvPr>
+        </p:nvSpPr>
+        <p:spPr/>
+        <p:txBody>
+          <a:bodyPr/>
+          <a:lstStyle/>
+          <a:p>
+            <a:r>
+              <a:rPr lang="en-US" dirty="0"/>
+              <a:t/>
+            </a:r>
+            <a:endParaRPr lang="en-US" dirty="0"/>
+          </a:p>
+        </p:txBody>
+      </p:sp>
+      <p:sp>
+        <p:nvSpPr>
+          <p:cNvPr id="4" name="Slide Number Placeholder 3"/>
+          <p:cNvSpPr>
+            <a:spLocks noGrp="1"/>
+          </p:cNvSpPr>
+          <p:nvPr>
+            <p:ph type="sldNum" sz="quarter" idx="10"/>
+          </p:nvPr>
+        </p:nvSpPr>
+        <p:spPr/>
+        <p:txBody>
+          <a:bodyPr/>
+          <a:lstStyle/>
+          <a:p>
+            <a:fld id="{F7021451-1387-4CA6-816F-3879F97B5CBC}" type="slidenum">
+              <a:rPr lang="en-US"/>
+              <a:t>11</a:t>
             </a:fld>
             <a:endParaRPr lang="en-US"/>
           </a:p>
@@ -2035,7 +2124,7 @@
                 <a:ea typeface="Arial" pitchFamily="34" charset="-122"/>
                 <a:cs typeface="Arial" pitchFamily="34" charset="-120"/>
               </a:rPr>
-              <a:t>STORM SCOUT  ×  T-ROCK</a:t>
+              <a:t>STORM SCOUT  ×  T^ROCK</a:t>
             </a:r>
             <a:endParaRPr lang="en-US" sz="5400" dirty="0"/>
           </a:p>
@@ -2113,7 +2202,7 @@
                 <a:ea typeface="Arial" pitchFamily="34" charset="-122"/>
                 <a:cs typeface="Arial" pitchFamily="34" charset="-120"/>
               </a:rPr>
-              <a:t>Prepared for Aaron &amp; Alan</a:t>
+              <a:t>T^Rock Contracting</a:t>
             </a:r>
             <a:pPr indent="0" marL="0">
               <a:buNone/>
@@ -2166,7 +2255,7 @@
                 <a:ea typeface="Arial" pitchFamily="34" charset="-122"/>
                 <a:cs typeface="Arial" pitchFamily="34" charset="-120"/>
               </a:rPr>
-              <a:t>No fluff. Website facts, break-even math, and a 90-day test with kill criteria.</a:t>
+              <a:t>Published pricing, break-even math, and a 90-day test with kill criteria.</a:t>
             </a:r>
             <a:endParaRPr lang="en-US" sz="1400" dirty="0"/>
           </a:p>
@@ -2183,6 +2272,720 @@
 <file path=ppt/slides/slide10.xml><?xml version="1.0" encoding="utf-8"?>
 <p:sld xmlns:a="http://schemas.openxmlformats.org/drawingml/2006/main" xmlns:r="http://schemas.openxmlformats.org/officeDocument/2006/relationships" xmlns:p="http://schemas.openxmlformats.org/presentationml/2006/main">
   <p:cSld name="Slide 10">
+    <p:bg>
+      <p:bgPr>
+        <a:solidFill>
+          <a:srgbClr val="FFFFFF"/>
+        </a:solidFill>
+      </p:bgPr>
+    </p:bg>
+    <p:spTree>
+      <p:nvGrpSpPr>
+        <p:cNvPr id="1" name=""/>
+        <p:cNvGrpSpPr/>
+        <p:nvPr/>
+      </p:nvGrpSpPr>
+      <p:grpSpPr>
+        <a:xfrm>
+          <a:off x="0" y="0"/>
+          <a:ext cx="0" cy="0"/>
+          <a:chOff x="0" y="0"/>
+          <a:chExt cx="0" cy="0"/>
+        </a:xfrm>
+      </p:grpSpPr>
+      <p:sp>
+        <p:nvSpPr>
+          <p:cNvPr id="2" name="Text 0"/>
+          <p:cNvSpPr/>
+          <p:nvPr/>
+        </p:nvSpPr>
+        <p:spPr>
+          <a:xfrm>
+            <a:off x="548640" y="411480"/>
+            <a:ext cx="11064240" cy="640080"/>
+          </a:xfrm>
+          <a:prstGeom prst="rect">
+            <a:avLst/>
+          </a:prstGeom>
+          <a:noFill/>
+          <a:ln/>
+        </p:spPr>
+        <p:txBody>
+          <a:bodyPr wrap="square" lIns="0" tIns="0" rIns="0" bIns="0" rtlCol="0" anchor="ctr"/>
+          <a:lstStyle/>
+          <a:p>
+            <a:pPr indent="0" marL="0">
+              <a:buNone/>
+            </a:pPr>
+            <a:r>
+              <a:rPr lang="en-US" sz="3200" b="1" dirty="0">
+                <a:solidFill>
+                  <a:srgbClr val="111111"/>
+                </a:solidFill>
+                <a:latin typeface="Arial" pitchFamily="34" charset="0"/>
+                <a:ea typeface="Arial" pitchFamily="34" charset="-122"/>
+                <a:cs typeface="Arial" pitchFamily="34" charset="-120"/>
+              </a:rPr>
+              <a:t>Straight answers before you ask</a:t>
+            </a:r>
+            <a:endParaRPr lang="en-US" sz="3200" dirty="0"/>
+          </a:p>
+        </p:txBody>
+      </p:sp>
+      <p:sp>
+        <p:nvSpPr>
+          <p:cNvPr id="3" name="Shape 1"/>
+          <p:cNvSpPr/>
+          <p:nvPr/>
+        </p:nvSpPr>
+        <p:spPr>
+          <a:xfrm>
+            <a:off x="548640" y="1371600"/>
+            <a:ext cx="5394960" cy="2194560"/>
+          </a:xfrm>
+          <a:prstGeom prst="roundRect">
+            <a:avLst>
+              <a:gd name="adj" fmla="val 3333"/>
+            </a:avLst>
+          </a:prstGeom>
+          <a:solidFill>
+            <a:srgbClr val="F5F5F5"/>
+          </a:solidFill>
+          <a:ln/>
+        </p:spPr>
+      </p:sp>
+      <p:sp>
+        <p:nvSpPr>
+          <p:cNvPr id="4" name="Shape 2"/>
+          <p:cNvSpPr/>
+          <p:nvPr/>
+        </p:nvSpPr>
+        <p:spPr>
+          <a:xfrm>
+            <a:off x="822960" y="1645920"/>
+            <a:ext cx="594360" cy="594360"/>
+          </a:xfrm>
+          <a:prstGeom prst="ellipse">
+            <a:avLst/>
+          </a:prstGeom>
+          <a:solidFill>
+            <a:srgbClr val="C8102E"/>
+          </a:solidFill>
+          <a:ln/>
+        </p:spPr>
+      </p:sp>
+      <p:pic>
+        <p:nvPicPr>
+          <p:cNvPr id="5" name="Image 0" descr="preencoded.png">    </p:cNvPr>
+          <p:cNvPicPr>
+            <a:picLocks noChangeAspect="1"/>
+          </p:cNvPicPr>
+          <p:nvPr/>
+        </p:nvPicPr>
+        <p:blipFill>
+          <a:blip r:embed="rId1"/>
+          <a:stretch>
+            <a:fillRect/>
+          </a:stretch>
+        </p:blipFill>
+        <p:spPr>
+          <a:xfrm>
+            <a:off x="977494" y="1800454"/>
+            <a:ext cx="285293" cy="285293"/>
+          </a:xfrm>
+          <a:prstGeom prst="rect">
+            <a:avLst/>
+          </a:prstGeom>
+        </p:spPr>
+      </p:pic>
+      <p:sp>
+        <p:nvSpPr>
+          <p:cNvPr id="6" name="Text 3"/>
+          <p:cNvSpPr/>
+          <p:nvPr/>
+        </p:nvSpPr>
+        <p:spPr>
+          <a:xfrm>
+            <a:off x="1600200" y="1627632"/>
+            <a:ext cx="4160520" cy="365760"/>
+          </a:xfrm>
+          <a:prstGeom prst="rect">
+            <a:avLst/>
+          </a:prstGeom>
+          <a:noFill/>
+          <a:ln/>
+        </p:spPr>
+        <p:txBody>
+          <a:bodyPr wrap="square" lIns="0" tIns="0" rIns="0" bIns="0" rtlCol="0" anchor="ctr"/>
+          <a:lstStyle/>
+          <a:p>
+            <a:pPr indent="0" marL="0">
+              <a:buNone/>
+            </a:pPr>
+            <a:r>
+              <a:rPr lang="en-US" sz="1600" b="1" dirty="0">
+                <a:solidFill>
+                  <a:srgbClr val="C8102E"/>
+                </a:solidFill>
+                <a:latin typeface="Arial" pitchFamily="34" charset="0"/>
+                <a:ea typeface="Arial" pitchFamily="34" charset="-122"/>
+                <a:cs typeface="Arial" pitchFamily="34" charset="-120"/>
+              </a:rPr>
+              <a:t>“Isn't the ‘limited offer’ a sales tactic?”</a:t>
+            </a:r>
+            <a:endParaRPr lang="en-US" sz="1600" dirty="0"/>
+          </a:p>
+        </p:txBody>
+      </p:sp>
+      <p:sp>
+        <p:nvSpPr>
+          <p:cNvPr id="7" name="Text 4"/>
+          <p:cNvSpPr/>
+          <p:nvPr/>
+        </p:nvSpPr>
+        <p:spPr>
+          <a:xfrm>
+            <a:off x="1600200" y="2029968"/>
+            <a:ext cx="4160520" cy="1463040"/>
+          </a:xfrm>
+          <a:prstGeom prst="rect">
+            <a:avLst/>
+          </a:prstGeom>
+          <a:noFill/>
+          <a:ln/>
+        </p:spPr>
+        <p:txBody>
+          <a:bodyPr wrap="square" lIns="0" tIns="0" rIns="0" bIns="0" rtlCol="0" anchor="ctr"/>
+          <a:lstStyle/>
+          <a:p>
+            <a:pPr indent="0" marL="0">
+              <a:buNone/>
+            </a:pPr>
+            <a:r>
+              <a:rPr lang="en-US" sz="1200" dirty="0">
+                <a:solidFill>
+                  <a:srgbClr val="2A2A2A"/>
+                </a:solidFill>
+                <a:latin typeface="Arial" pitchFamily="34" charset="0"/>
+                <a:ea typeface="Arial" pitchFamily="34" charset="-122"/>
+                <a:cs typeface="Arial" pitchFamily="34" charset="-120"/>
+              </a:rPr>
+              <a:t>Probably — and it doesn't matter. Billing is $2,000 monthly, locked forever: keep it and we pay $500/mo under sticker for life; cancel at day 90 and we're out $6,000 — T^Rock's net on about one job. Only dealbreaker: cancellation terms that aren't clean.</a:t>
+            </a:r>
+            <a:endParaRPr lang="en-US" sz="1200" dirty="0"/>
+          </a:p>
+        </p:txBody>
+      </p:sp>
+      <p:sp>
+        <p:nvSpPr>
+          <p:cNvPr id="8" name="Shape 5"/>
+          <p:cNvSpPr/>
+          <p:nvPr/>
+        </p:nvSpPr>
+        <p:spPr>
+          <a:xfrm>
+            <a:off x="6217920" y="1371600"/>
+            <a:ext cx="5394960" cy="2194560"/>
+          </a:xfrm>
+          <a:prstGeom prst="roundRect">
+            <a:avLst>
+              <a:gd name="adj" fmla="val 3333"/>
+            </a:avLst>
+          </a:prstGeom>
+          <a:solidFill>
+            <a:srgbClr val="F5F5F5"/>
+          </a:solidFill>
+          <a:ln/>
+        </p:spPr>
+      </p:sp>
+      <p:sp>
+        <p:nvSpPr>
+          <p:cNvPr id="9" name="Shape 6"/>
+          <p:cNvSpPr/>
+          <p:nvPr/>
+        </p:nvSpPr>
+        <p:spPr>
+          <a:xfrm>
+            <a:off x="6492240" y="1645920"/>
+            <a:ext cx="594360" cy="594360"/>
+          </a:xfrm>
+          <a:prstGeom prst="ellipse">
+            <a:avLst/>
+          </a:prstGeom>
+          <a:solidFill>
+            <a:srgbClr val="C8102E"/>
+          </a:solidFill>
+          <a:ln/>
+        </p:spPr>
+      </p:sp>
+      <p:pic>
+        <p:nvPicPr>
+          <p:cNvPr id="10" name="Image 1" descr="preencoded.png">    </p:cNvPr>
+          <p:cNvPicPr>
+            <a:picLocks noChangeAspect="1"/>
+          </p:cNvPicPr>
+          <p:nvPr/>
+        </p:nvPicPr>
+        <p:blipFill>
+          <a:blip r:embed="rId2"/>
+          <a:stretch>
+            <a:fillRect/>
+          </a:stretch>
+        </p:blipFill>
+        <p:spPr>
+          <a:xfrm>
+            <a:off x="6646774" y="1800454"/>
+            <a:ext cx="285293" cy="285293"/>
+          </a:xfrm>
+          <a:prstGeom prst="rect">
+            <a:avLst/>
+          </a:prstGeom>
+        </p:spPr>
+      </p:pic>
+      <p:sp>
+        <p:nvSpPr>
+          <p:cNvPr id="11" name="Text 7"/>
+          <p:cNvSpPr/>
+          <p:nvPr/>
+        </p:nvSpPr>
+        <p:spPr>
+          <a:xfrm>
+            <a:off x="7269480" y="1627632"/>
+            <a:ext cx="4160520" cy="365760"/>
+          </a:xfrm>
+          <a:prstGeom prst="rect">
+            <a:avLst/>
+          </a:prstGeom>
+          <a:noFill/>
+          <a:ln/>
+        </p:spPr>
+        <p:txBody>
+          <a:bodyPr wrap="square" lIns="0" tIns="0" rIns="0" bIns="0" rtlCol="0" anchor="ctr"/>
+          <a:lstStyle/>
+          <a:p>
+            <a:pPr indent="0" marL="0">
+              <a:buNone/>
+            </a:pPr>
+            <a:r>
+              <a:rPr lang="en-US" sz="1600" b="1" dirty="0">
+                <a:solidFill>
+                  <a:srgbClr val="C8102E"/>
+                </a:solidFill>
+                <a:latin typeface="Arial" pitchFamily="34" charset="0"/>
+                <a:ea typeface="Arial" pitchFamily="34" charset="-122"/>
+                <a:cs typeface="Arial" pitchFamily="34" charset="-120"/>
+              </a:rPr>
+              <a:t>“Their case studies are marketing.”</a:t>
+            </a:r>
+            <a:endParaRPr lang="en-US" sz="1600" dirty="0"/>
+          </a:p>
+        </p:txBody>
+      </p:sp>
+      <p:sp>
+        <p:nvSpPr>
+          <p:cNvPr id="12" name="Text 8"/>
+          <p:cNvSpPr/>
+          <p:nvPr/>
+        </p:nvSpPr>
+        <p:spPr>
+          <a:xfrm>
+            <a:off x="7269480" y="2029968"/>
+            <a:ext cx="4160520" cy="1463040"/>
+          </a:xfrm>
+          <a:prstGeom prst="rect">
+            <a:avLst/>
+          </a:prstGeom>
+          <a:noFill/>
+          <a:ln/>
+        </p:spPr>
+        <p:txBody>
+          <a:bodyPr wrap="square" lIns="0" tIns="0" rIns="0" bIns="0" rtlCol="0" anchor="ctr"/>
+          <a:lstStyle/>
+          <a:p>
+            <a:pPr indent="0" marL="0">
+              <a:buNone/>
+            </a:pPr>
+            <a:r>
+              <a:rPr lang="en-US" sz="1200" dirty="0">
+                <a:solidFill>
+                  <a:srgbClr val="2A2A2A"/>
+                </a:solidFill>
+                <a:latin typeface="Arial" pitchFamily="34" charset="0"/>
+                <a:ea typeface="Arial" pitchFamily="34" charset="-122"/>
+                <a:cs typeface="Arial" pitchFamily="34" charset="-120"/>
+              </a:rPr>
+              <a:t>Correct. Titan Roofing &amp; Restoration and others on their site are vendor-published, no audited numbers. That's exactly why the pilot has our own scorecard — we trust our data, not theirs.</a:t>
+            </a:r>
+            <a:endParaRPr lang="en-US" sz="1200" dirty="0"/>
+          </a:p>
+        </p:txBody>
+      </p:sp>
+      <p:sp>
+        <p:nvSpPr>
+          <p:cNvPr id="13" name="Shape 9"/>
+          <p:cNvSpPr/>
+          <p:nvPr/>
+        </p:nvSpPr>
+        <p:spPr>
+          <a:xfrm>
+            <a:off x="548640" y="3794760"/>
+            <a:ext cx="5394960" cy="2194560"/>
+          </a:xfrm>
+          <a:prstGeom prst="roundRect">
+            <a:avLst>
+              <a:gd name="adj" fmla="val 3333"/>
+            </a:avLst>
+          </a:prstGeom>
+          <a:solidFill>
+            <a:srgbClr val="F5F5F5"/>
+          </a:solidFill>
+          <a:ln/>
+        </p:spPr>
+      </p:sp>
+      <p:sp>
+        <p:nvSpPr>
+          <p:cNvPr id="14" name="Shape 10"/>
+          <p:cNvSpPr/>
+          <p:nvPr/>
+        </p:nvSpPr>
+        <p:spPr>
+          <a:xfrm>
+            <a:off x="822960" y="4069080"/>
+            <a:ext cx="594360" cy="594360"/>
+          </a:xfrm>
+          <a:prstGeom prst="ellipse">
+            <a:avLst/>
+          </a:prstGeom>
+          <a:solidFill>
+            <a:srgbClr val="C8102E"/>
+          </a:solidFill>
+          <a:ln/>
+        </p:spPr>
+      </p:sp>
+      <p:pic>
+        <p:nvPicPr>
+          <p:cNvPr id="15" name="Image 2" descr="preencoded.png">    </p:cNvPr>
+          <p:cNvPicPr>
+            <a:picLocks noChangeAspect="1"/>
+          </p:cNvPicPr>
+          <p:nvPr/>
+        </p:nvPicPr>
+        <p:blipFill>
+          <a:blip r:embed="rId3"/>
+          <a:stretch>
+            <a:fillRect/>
+          </a:stretch>
+        </p:blipFill>
+        <p:spPr>
+          <a:xfrm>
+            <a:off x="977494" y="4223614"/>
+            <a:ext cx="285293" cy="285293"/>
+          </a:xfrm>
+          <a:prstGeom prst="rect">
+            <a:avLst/>
+          </a:prstGeom>
+        </p:spPr>
+      </p:pic>
+      <p:sp>
+        <p:nvSpPr>
+          <p:cNvPr id="16" name="Text 11"/>
+          <p:cNvSpPr/>
+          <p:nvPr/>
+        </p:nvSpPr>
+        <p:spPr>
+          <a:xfrm>
+            <a:off x="1600200" y="4050792"/>
+            <a:ext cx="4160520" cy="365760"/>
+          </a:xfrm>
+          <a:prstGeom prst="rect">
+            <a:avLst/>
+          </a:prstGeom>
+          <a:noFill/>
+          <a:ln/>
+        </p:spPr>
+        <p:txBody>
+          <a:bodyPr wrap="square" lIns="0" tIns="0" rIns="0" bIns="0" rtlCol="0" anchor="ctr"/>
+          <a:lstStyle/>
+          <a:p>
+            <a:pPr indent="0" marL="0">
+              <a:buNone/>
+            </a:pPr>
+            <a:r>
+              <a:rPr lang="en-US" sz="1600" b="1" dirty="0">
+                <a:solidFill>
+                  <a:srgbClr val="C8102E"/>
+                </a:solidFill>
+                <a:latin typeface="Arial" pitchFamily="34" charset="0"/>
+                <a:ea typeface="Arial" pitchFamily="34" charset="-122"/>
+                <a:cs typeface="Arial" pitchFamily="34" charset="-120"/>
+              </a:rPr>
+              <a:t>“Is the damage data real?”</a:t>
+            </a:r>
+            <a:endParaRPr lang="en-US" sz="1600" dirty="0"/>
+          </a:p>
+        </p:txBody>
+      </p:sp>
+      <p:sp>
+        <p:nvSpPr>
+          <p:cNvPr id="17" name="Text 12"/>
+          <p:cNvSpPr/>
+          <p:nvPr/>
+        </p:nvSpPr>
+        <p:spPr>
+          <a:xfrm>
+            <a:off x="1600200" y="4453128"/>
+            <a:ext cx="4160520" cy="1463040"/>
+          </a:xfrm>
+          <a:prstGeom prst="rect">
+            <a:avLst/>
+          </a:prstGeom>
+          <a:noFill/>
+          <a:ln/>
+        </p:spPr>
+        <p:txBody>
+          <a:bodyPr wrap="square" lIns="0" tIns="0" rIns="0" bIns="0" rtlCol="0" anchor="ctr"/>
+          <a:lstStyle/>
+          <a:p>
+            <a:pPr indent="0" marL="0">
+              <a:buNone/>
+            </a:pPr>
+            <a:r>
+              <a:rPr lang="en-US" sz="1200" dirty="0">
+                <a:solidFill>
+                  <a:srgbClr val="2A2A2A"/>
+                </a:solidFill>
+                <a:latin typeface="Arial" pitchFamily="34" charset="0"/>
+                <a:ea typeface="Arial" pitchFamily="34" charset="-122"/>
+                <a:cs typeface="Arial" pitchFamily="34" charset="-120"/>
+              </a:rPr>
+              <a:t>We verify it ourselves: weeks 1–2, every map-flagged roof a rep inspects gets logged confirmed/not confirmed. Below 70% accuracy, the tool dies on that metric alone.</a:t>
+            </a:r>
+            <a:endParaRPr lang="en-US" sz="1200" dirty="0"/>
+          </a:p>
+        </p:txBody>
+      </p:sp>
+      <p:sp>
+        <p:nvSpPr>
+          <p:cNvPr id="18" name="Shape 13"/>
+          <p:cNvSpPr/>
+          <p:nvPr/>
+        </p:nvSpPr>
+        <p:spPr>
+          <a:xfrm>
+            <a:off x="6217920" y="3794760"/>
+            <a:ext cx="5394960" cy="2194560"/>
+          </a:xfrm>
+          <a:prstGeom prst="roundRect">
+            <a:avLst>
+              <a:gd name="adj" fmla="val 3333"/>
+            </a:avLst>
+          </a:prstGeom>
+          <a:solidFill>
+            <a:srgbClr val="F5F5F5"/>
+          </a:solidFill>
+          <a:ln/>
+        </p:spPr>
+      </p:sp>
+      <p:sp>
+        <p:nvSpPr>
+          <p:cNvPr id="19" name="Shape 14"/>
+          <p:cNvSpPr/>
+          <p:nvPr/>
+        </p:nvSpPr>
+        <p:spPr>
+          <a:xfrm>
+            <a:off x="6492240" y="4069080"/>
+            <a:ext cx="594360" cy="594360"/>
+          </a:xfrm>
+          <a:prstGeom prst="ellipse">
+            <a:avLst/>
+          </a:prstGeom>
+          <a:solidFill>
+            <a:srgbClr val="C8102E"/>
+          </a:solidFill>
+          <a:ln/>
+        </p:spPr>
+      </p:sp>
+      <p:pic>
+        <p:nvPicPr>
+          <p:cNvPr id="20" name="Image 3" descr="preencoded.png">    </p:cNvPr>
+          <p:cNvPicPr>
+            <a:picLocks noChangeAspect="1"/>
+          </p:cNvPicPr>
+          <p:nvPr/>
+        </p:nvPicPr>
+        <p:blipFill>
+          <a:blip r:embed="rId4"/>
+          <a:stretch>
+            <a:fillRect/>
+          </a:stretch>
+        </p:blipFill>
+        <p:spPr>
+          <a:xfrm>
+            <a:off x="6646774" y="4223614"/>
+            <a:ext cx="285293" cy="285293"/>
+          </a:xfrm>
+          <a:prstGeom prst="rect">
+            <a:avLst/>
+          </a:prstGeom>
+        </p:spPr>
+      </p:pic>
+      <p:sp>
+        <p:nvSpPr>
+          <p:cNvPr id="21" name="Text 15"/>
+          <p:cNvSpPr/>
+          <p:nvPr/>
+        </p:nvSpPr>
+        <p:spPr>
+          <a:xfrm>
+            <a:off x="7269480" y="4050792"/>
+            <a:ext cx="4160520" cy="365760"/>
+          </a:xfrm>
+          <a:prstGeom prst="rect">
+            <a:avLst/>
+          </a:prstGeom>
+          <a:noFill/>
+          <a:ln/>
+        </p:spPr>
+        <p:txBody>
+          <a:bodyPr wrap="square" lIns="0" tIns="0" rIns="0" bIns="0" rtlCol="0" anchor="ctr"/>
+          <a:lstStyle/>
+          <a:p>
+            <a:pPr indent="0" marL="0">
+              <a:buNone/>
+            </a:pPr>
+            <a:r>
+              <a:rPr lang="en-US" sz="1600" b="1" dirty="0">
+                <a:solidFill>
+                  <a:srgbClr val="C8102E"/>
+                </a:solidFill>
+                <a:latin typeface="Arial" pitchFamily="34" charset="0"/>
+                <a:ea typeface="Arial" pitchFamily="34" charset="-122"/>
+                <a:cs typeface="Arial" pitchFamily="34" charset="-120"/>
+              </a:rPr>
+              <a:t>“Will the reps actually use it?”</a:t>
+            </a:r>
+            <a:endParaRPr lang="en-US" sz="1600" dirty="0"/>
+          </a:p>
+        </p:txBody>
+      </p:sp>
+      <p:sp>
+        <p:nvSpPr>
+          <p:cNvPr id="22" name="Text 16"/>
+          <p:cNvSpPr/>
+          <p:nvPr/>
+        </p:nvSpPr>
+        <p:spPr>
+          <a:xfrm>
+            <a:off x="7269480" y="4453128"/>
+            <a:ext cx="4160520" cy="1463040"/>
+          </a:xfrm>
+          <a:prstGeom prst="rect">
+            <a:avLst/>
+          </a:prstGeom>
+          <a:noFill/>
+          <a:ln/>
+        </p:spPr>
+        <p:txBody>
+          <a:bodyPr wrap="square" lIns="0" tIns="0" rIns="0" bIns="0" rtlCol="0" anchor="ctr"/>
+          <a:lstStyle/>
+          <a:p>
+            <a:pPr indent="0" marL="0">
+              <a:buNone/>
+            </a:pPr>
+            <a:r>
+              <a:rPr lang="en-US" sz="1200" dirty="0">
+                <a:solidFill>
+                  <a:srgbClr val="2A2A2A"/>
+                </a:solidFill>
+                <a:latin typeface="Arial" pitchFamily="34" charset="0"/>
+                <a:ea typeface="Arial" pitchFamily="34" charset="-122"/>
+                <a:cs typeface="Arial" pitchFamily="34" charset="-120"/>
+              </a:rPr>
+              <a:t>Adoption is the real risk with any tool. So it gets a named owner (Dom), the whole team trains on it day 1, and usage shows up in the weekly scorecard. Reps not working the lists is visible in the numbers within two weeks.</a:t>
+            </a:r>
+            <a:endParaRPr lang="en-US" sz="1200" dirty="0"/>
+          </a:p>
+        </p:txBody>
+      </p:sp>
+      <p:sp>
+        <p:nvSpPr>
+          <p:cNvPr id="23" name="Text 17"/>
+          <p:cNvSpPr/>
+          <p:nvPr/>
+        </p:nvSpPr>
+        <p:spPr>
+          <a:xfrm>
+            <a:off x="548640" y="6473952"/>
+            <a:ext cx="9601200" cy="274320"/>
+          </a:xfrm>
+          <a:prstGeom prst="rect">
+            <a:avLst/>
+          </a:prstGeom>
+          <a:noFill/>
+          <a:ln/>
+        </p:spPr>
+        <p:txBody>
+          <a:bodyPr wrap="square" lIns="0" tIns="0" rIns="0" bIns="0" rtlCol="0" anchor="ctr"/>
+          <a:lstStyle/>
+          <a:p>
+            <a:pPr indent="0" marL="0">
+              <a:buNone/>
+            </a:pPr>
+            <a:endParaRPr lang="en-US" sz="900" dirty="0"/>
+          </a:p>
+        </p:txBody>
+      </p:sp>
+      <p:sp>
+        <p:nvSpPr>
+          <p:cNvPr id="24" name="Text 18"/>
+          <p:cNvSpPr/>
+          <p:nvPr/>
+        </p:nvSpPr>
+        <p:spPr>
+          <a:xfrm>
+            <a:off x="11274552" y="6473952"/>
+            <a:ext cx="457200" cy="274320"/>
+          </a:xfrm>
+          <a:prstGeom prst="rect">
+            <a:avLst/>
+          </a:prstGeom>
+          <a:noFill/>
+          <a:ln/>
+        </p:spPr>
+        <p:txBody>
+          <a:bodyPr wrap="square" lIns="0" tIns="0" rIns="0" bIns="0" rtlCol="0" anchor="ctr"/>
+          <a:lstStyle/>
+          <a:p>
+            <a:pPr algn="r" indent="0" marL="0">
+              <a:buNone/>
+            </a:pPr>
+            <a:r>
+              <a:rPr lang="en-US" sz="1000" dirty="0">
+                <a:solidFill>
+                  <a:srgbClr val="6E6E6E"/>
+                </a:solidFill>
+                <a:latin typeface="Arial" pitchFamily="34" charset="0"/>
+                <a:ea typeface="Arial" pitchFamily="34" charset="-122"/>
+                <a:cs typeface="Arial" pitchFamily="34" charset="-120"/>
+              </a:rPr>
+              <a:t>10</a:t>
+            </a:r>
+            <a:endParaRPr lang="en-US" sz="1000" dirty="0"/>
+          </a:p>
+        </p:txBody>
+      </p:sp>
+    </p:spTree>
+  </p:cSld>
+  <p:clrMapOvr>
+    <a:masterClrMapping/>
+  </p:clrMapOvr>
+</p:sld>
+</file>
+
+<file path=ppt/slides/slide11.xml><?xml version="1.0" encoding="utf-8"?>
+<p:sld xmlns:a="http://schemas.openxmlformats.org/drawingml/2006/main" xmlns:r="http://schemas.openxmlformats.org/officeDocument/2006/relationships" xmlns:p="http://schemas.openxmlformats.org/presentationml/2006/main">
+  <p:cSld name="Slide 11">
     <p:bg>
       <p:bgPr>
         <a:solidFill>
@@ -2420,7 +3223,7 @@
                 <a:ea typeface="Arial" pitchFamily="34" charset="-122"/>
                 <a:cs typeface="Arial" pitchFamily="34" charset="-120"/>
               </a:rPr>
-              <a:t>30 minutes. Confirm the Founding offer is still open, get cancellation terms in writing, and ask how automated calls/texts handle DNC &amp; TCPA compliance.</a:t>
+              <a:t>30 min. Confirm the Founding offer is still open; get cancellation and lead-data-export terms in writing; ask how automated calls/texts handle DNC &amp; TCPA.</a:t>
             </a:r>
             <a:endParaRPr lang="en-US" sz="1250" dirty="0"/>
           </a:p>
@@ -2603,7 +3406,7 @@
                 <a:ea typeface="Arial" pitchFamily="34" charset="-122"/>
                 <a:cs typeface="Arial" pitchFamily="34" charset="-120"/>
               </a:rPr>
-              <a:t>$2,000/mo, every Platinum feature, price locked for life. Full team live day 1; 2 control reps keep the old playbook.</a:t>
+              <a:t>$2,000/mo, every Platinum feature, price locked for life. Full team live day 1; 2 control reps keep the old playbook. Weekly scorecard to leadership.</a:t>
             </a:r>
             <a:endParaRPr lang="en-US" sz="1250" dirty="0"/>
           </a:p>
@@ -3481,7 +4284,7 @@
                 <a:ea typeface="Arial" pitchFamily="34" charset="-122"/>
                 <a:cs typeface="Arial" pitchFamily="34" charset="-120"/>
               </a:rPr>
-              <a:t>rep-hours per signed contract. Every knock on an undamaged roof is payroll spent producing $0.</a:t>
+              <a:t>sold jobs per rep per storm. On a 50/50 split, wasted knocks starve the rep and the company alike — and reps who can't close, quit.</a:t>
             </a:r>
             <a:endParaRPr lang="en-US" sz="1500" dirty="0"/>
           </a:p>
@@ -10024,7 +10827,7 @@
                 <a:ea typeface="Arial" pitchFamily="34" charset="-122"/>
                 <a:cs typeface="Arial" pitchFamily="34" charset="-120"/>
               </a:rPr>
-              <a:t>Their published prices against T-Rock's actual job economics.</a:t>
+              <a:t>Their published prices against T^Rock's actual job economics.</a:t>
             </a:r>
             <a:endParaRPr lang="en-US" sz="1500" dirty="0"/>
           </a:p>
@@ -10085,7 +10888,7 @@
                 <a:ea typeface="Arial" pitchFamily="34" charset="-122"/>
                 <a:cs typeface="Arial" pitchFamily="34" charset="-120"/>
               </a:rPr>
-              <a:t>T-Rock net per job</a:t>
+              <a:t>T^Rock net per job</a:t>
             </a:r>
             <a:endParaRPr lang="en-US" sz="1600" dirty="0"/>
           </a:p>
@@ -10265,7 +11068,7 @@
                 <a:ea typeface="Arial" pitchFamily="34" charset="-122"/>
                 <a:cs typeface="Arial" pitchFamily="34" charset="-120"/>
               </a:rPr>
-              <a:t>T-Rock net / job:  </a:t>
+              <a:t>T^Rock net / job:  </a:t>
             </a:r>
             <a:pPr indent="0" marL="0">
               <a:spcAft>
@@ -10353,7 +11156,7 @@
                 <a:ea typeface="Arial" pitchFamily="34" charset="-122"/>
                 <a:cs typeface="Arial" pitchFamily="34" charset="-120"/>
               </a:rPr>
-              <a:t>Subscription is overhead (not job-attributable), so it's measured against T-Rock's share — the conservative view.</a:t>
+              <a:t>Subscription is overhead (not job-attributable), so it's measured against T^Rock's share — the conservative view.</a:t>
             </a:r>
             <a:endParaRPr lang="en-US" sz="1050" dirty="0"/>
           </a:p>
@@ -10430,7 +11233,7 @@
                 <a:ea typeface="Arial" pitchFamily="34" charset="-122"/>
                 <a:cs typeface="Arial" pitchFamily="34" charset="-120"/>
               </a:rPr>
-              <a:t>Founding breaks even at 4.8 jobs a year — one incremental roof every ~11 weeks — on T-Rock's share alone. </a:t>
+              <a:t>Founding breaks even at 4.8 jobs a year — one incremental roof every ~11 weeks — on T^Rock's share alone. </a:t>
             </a:r>
             <a:pPr indent="0" marL="0">
               <a:buNone/>
@@ -10483,7 +11286,7 @@
                 <a:ea typeface="Arial" pitchFamily="34" charset="-122"/>
                 <a:cs typeface="Arial" pitchFamily="34" charset="-120"/>
               </a:rPr>
-              <a:t>Per job: $30,000 × 35% = $10,500, less 2% RCV scope fee ($600) = $9,900, split 50/50 with the PM → $4,950 to T-Rock.</a:t>
+              <a:t>Per job: $30,000 × 35% = $10,500, less 2% RCV scope fee ($600) = $9,900, split 50/50 with the PM → $4,950 to T^Rock.</a:t>
             </a:r>
             <a:endParaRPr lang="en-US" sz="900" dirty="0"/>
           </a:p>
@@ -10593,6 +11396,1169 @@
                 <a:ea typeface="Arial" pitchFamily="34" charset="-122"/>
                 <a:cs typeface="Arial" pitchFamily="34" charset="-120"/>
               </a:rPr>
+              <a:t>The upside, sized for a hail market</a:t>
+            </a:r>
+            <a:endParaRPr lang="en-US" sz="3200" dirty="0"/>
+          </a:p>
+        </p:txBody>
+      </p:sp>
+      <p:sp>
+        <p:nvSpPr>
+          <p:cNvPr id="3" name="Text 1"/>
+          <p:cNvSpPr/>
+          <p:nvPr/>
+        </p:nvSpPr>
+        <p:spPr>
+          <a:xfrm>
+            <a:off x="548640" y="1097280"/>
+            <a:ext cx="10881360" cy="502920"/>
+          </a:xfrm>
+          <a:prstGeom prst="rect">
+            <a:avLst/>
+          </a:prstGeom>
+          <a:noFill/>
+          <a:ln/>
+        </p:spPr>
+        <p:txBody>
+          <a:bodyPr wrap="square" lIns="0" tIns="0" rIns="0" bIns="0" rtlCol="0" anchor="ctr"/>
+          <a:lstStyle/>
+          <a:p>
+            <a:pPr indent="0" marL="0">
+              <a:buNone/>
+            </a:pPr>
+            <a:r>
+              <a:rPr lang="en-US" sz="1500" dirty="0">
+                <a:solidFill>
+                  <a:srgbClr val="6E6E6E"/>
+                </a:solidFill>
+                <a:latin typeface="Arial" pitchFamily="34" charset="0"/>
+                <a:ea typeface="Arial" pitchFamily="34" charset="-122"/>
+                <a:cs typeface="Arial" pitchFamily="34" charset="-120"/>
+              </a:rPr>
+              <a:t>DFW sits in one of the most hail-active corridors in the country. Scenarios for incremental roofs — jobs from verified-damage targeting we wouldn't have knocked otherwise:</a:t>
+            </a:r>
+            <a:endParaRPr lang="en-US" sz="1500" dirty="0"/>
+          </a:p>
+        </p:txBody>
+      </p:sp>
+      <p:sp>
+        <p:nvSpPr>
+          <p:cNvPr id="4" name="Shape 2"/>
+          <p:cNvSpPr/>
+          <p:nvPr/>
+        </p:nvSpPr>
+        <p:spPr>
+          <a:xfrm>
+            <a:off x="548640" y="1783080"/>
+            <a:ext cx="3520440" cy="3429000"/>
+          </a:xfrm>
+          <a:prstGeom prst="roundRect">
+            <a:avLst>
+              <a:gd name="adj" fmla="val 2133"/>
+            </a:avLst>
+          </a:prstGeom>
+          <a:solidFill>
+            <a:srgbClr val="F5F5F5"/>
+          </a:solidFill>
+          <a:ln/>
+        </p:spPr>
+      </p:sp>
+      <p:sp>
+        <p:nvSpPr>
+          <p:cNvPr id="5" name="Shape 3"/>
+          <p:cNvSpPr/>
+          <p:nvPr/>
+        </p:nvSpPr>
+        <p:spPr>
+          <a:xfrm>
+            <a:off x="868680" y="2057400"/>
+            <a:ext cx="640080" cy="640080"/>
+          </a:xfrm>
+          <a:prstGeom prst="ellipse">
+            <a:avLst/>
+          </a:prstGeom>
+          <a:solidFill>
+            <a:srgbClr val="C8102E"/>
+          </a:solidFill>
+          <a:ln/>
+        </p:spPr>
+      </p:sp>
+      <p:pic>
+        <p:nvPicPr>
+          <p:cNvPr id="6" name="Image 0" descr="preencoded.png">    </p:cNvPr>
+          <p:cNvPicPr>
+            <a:picLocks noChangeAspect="1"/>
+          </p:cNvPicPr>
+          <p:nvPr/>
+        </p:nvPicPr>
+        <p:blipFill>
+          <a:blip r:embed="rId1"/>
+          <a:stretch>
+            <a:fillRect/>
+          </a:stretch>
+        </p:blipFill>
+        <p:spPr>
+          <a:xfrm>
+            <a:off x="1035101" y="2223821"/>
+            <a:ext cx="307238" cy="307238"/>
+          </a:xfrm>
+          <a:prstGeom prst="rect">
+            <a:avLst/>
+          </a:prstGeom>
+        </p:spPr>
+      </p:pic>
+      <p:sp>
+        <p:nvSpPr>
+          <p:cNvPr id="7" name="Text 4"/>
+          <p:cNvSpPr/>
+          <p:nvPr/>
+        </p:nvSpPr>
+        <p:spPr>
+          <a:xfrm>
+            <a:off x="1691640" y="2212848"/>
+            <a:ext cx="2286000" cy="320040"/>
+          </a:xfrm>
+          <a:prstGeom prst="rect">
+            <a:avLst/>
+          </a:prstGeom>
+          <a:noFill/>
+          <a:ln/>
+        </p:spPr>
+        <p:txBody>
+          <a:bodyPr wrap="square" lIns="0" tIns="0" rIns="0" bIns="0" rtlCol="0" anchor="ctr"/>
+          <a:lstStyle/>
+          <a:p>
+            <a:pPr indent="0" marL="0">
+              <a:buNone/>
+            </a:pPr>
+            <a:r>
+              <a:rPr lang="en-US" sz="1200" b="1" dirty="0">
+                <a:solidFill>
+                  <a:srgbClr val="C8102E"/>
+                </a:solidFill>
+                <a:latin typeface="Arial" pitchFamily="34" charset="0"/>
+                <a:ea typeface="Arial" pitchFamily="34" charset="-122"/>
+                <a:cs typeface="Arial" pitchFamily="34" charset="-120"/>
+              </a:rPr>
+              <a:t>CONSERVATIVE</a:t>
+            </a:r>
+            <a:endParaRPr lang="en-US" sz="1200" dirty="0"/>
+          </a:p>
+        </p:txBody>
+      </p:sp>
+      <p:sp>
+        <p:nvSpPr>
+          <p:cNvPr id="8" name="Text 5"/>
+          <p:cNvSpPr/>
+          <p:nvPr/>
+        </p:nvSpPr>
+        <p:spPr>
+          <a:xfrm>
+            <a:off x="868680" y="2743200"/>
+            <a:ext cx="2926080" cy="868680"/>
+          </a:xfrm>
+          <a:prstGeom prst="rect">
+            <a:avLst/>
+          </a:prstGeom>
+          <a:noFill/>
+          <a:ln/>
+        </p:spPr>
+        <p:txBody>
+          <a:bodyPr wrap="square" lIns="0" tIns="0" rIns="0" bIns="0" rtlCol="0" anchor="ctr"/>
+          <a:lstStyle/>
+          <a:p>
+            <a:pPr indent="0" marL="0">
+              <a:buNone/>
+            </a:pPr>
+            <a:r>
+              <a:rPr lang="en-US" sz="5400" b="1" dirty="0">
+                <a:solidFill>
+                  <a:srgbClr val="111111"/>
+                </a:solidFill>
+                <a:latin typeface="Arial" pitchFamily="34" charset="0"/>
+                <a:ea typeface="Arial" pitchFamily="34" charset="-122"/>
+                <a:cs typeface="Arial" pitchFamily="34" charset="-120"/>
+              </a:rPr>
+              <a:t>8</a:t>
+            </a:r>
+            <a:endParaRPr lang="en-US" sz="5400" dirty="0"/>
+          </a:p>
+        </p:txBody>
+      </p:sp>
+      <p:sp>
+        <p:nvSpPr>
+          <p:cNvPr id="9" name="Text 6"/>
+          <p:cNvSpPr/>
+          <p:nvPr/>
+        </p:nvSpPr>
+        <p:spPr>
+          <a:xfrm>
+            <a:off x="868680" y="3611880"/>
+            <a:ext cx="2926080" cy="274320"/>
+          </a:xfrm>
+          <a:prstGeom prst="rect">
+            <a:avLst/>
+          </a:prstGeom>
+          <a:noFill/>
+          <a:ln/>
+        </p:spPr>
+        <p:txBody>
+          <a:bodyPr wrap="square" lIns="0" tIns="0" rIns="0" bIns="0" rtlCol="0" anchor="ctr"/>
+          <a:lstStyle/>
+          <a:p>
+            <a:pPr indent="0" marL="0">
+              <a:buNone/>
+            </a:pPr>
+            <a:r>
+              <a:rPr lang="en-US" sz="1200" dirty="0">
+                <a:solidFill>
+                  <a:srgbClr val="6E6E6E"/>
+                </a:solidFill>
+                <a:latin typeface="Arial" pitchFamily="34" charset="0"/>
+                <a:ea typeface="Arial" pitchFamily="34" charset="-122"/>
+                <a:cs typeface="Arial" pitchFamily="34" charset="-120"/>
+              </a:rPr>
+              <a:t>incremental roofs / yr</a:t>
+            </a:r>
+            <a:endParaRPr lang="en-US" sz="1200" dirty="0"/>
+          </a:p>
+        </p:txBody>
+      </p:sp>
+      <p:sp>
+        <p:nvSpPr>
+          <p:cNvPr id="10" name="Text 7"/>
+          <p:cNvSpPr/>
+          <p:nvPr/>
+        </p:nvSpPr>
+        <p:spPr>
+          <a:xfrm>
+            <a:off x="868680" y="3977640"/>
+            <a:ext cx="2926080" cy="365760"/>
+          </a:xfrm>
+          <a:prstGeom prst="rect">
+            <a:avLst/>
+          </a:prstGeom>
+          <a:noFill/>
+          <a:ln/>
+        </p:spPr>
+        <p:txBody>
+          <a:bodyPr wrap="square" lIns="0" tIns="0" rIns="0" bIns="0" rtlCol="0" anchor="ctr"/>
+          <a:lstStyle/>
+          <a:p>
+            <a:pPr indent="0" marL="0">
+              <a:buNone/>
+            </a:pPr>
+            <a:r>
+              <a:rPr lang="en-US" sz="1800" b="1" dirty="0">
+                <a:solidFill>
+                  <a:srgbClr val="111111"/>
+                </a:solidFill>
+                <a:latin typeface="Arial" pitchFamily="34" charset="0"/>
+                <a:ea typeface="Arial" pitchFamily="34" charset="-122"/>
+                <a:cs typeface="Arial" pitchFamily="34" charset="-120"/>
+              </a:rPr>
+              <a:t>$240,000 revenue</a:t>
+            </a:r>
+            <a:endParaRPr lang="en-US" sz="1800" dirty="0"/>
+          </a:p>
+        </p:txBody>
+      </p:sp>
+      <p:sp>
+        <p:nvSpPr>
+          <p:cNvPr id="11" name="Text 8"/>
+          <p:cNvSpPr/>
+          <p:nvPr/>
+        </p:nvSpPr>
+        <p:spPr>
+          <a:xfrm>
+            <a:off x="868680" y="4370832"/>
+            <a:ext cx="2926080" cy="320040"/>
+          </a:xfrm>
+          <a:prstGeom prst="rect">
+            <a:avLst/>
+          </a:prstGeom>
+          <a:noFill/>
+          <a:ln/>
+        </p:spPr>
+        <p:txBody>
+          <a:bodyPr wrap="square" lIns="0" tIns="0" rIns="0" bIns="0" rtlCol="0" anchor="ctr"/>
+          <a:lstStyle/>
+          <a:p>
+            <a:pPr indent="0" marL="0">
+              <a:buNone/>
+            </a:pPr>
+            <a:r>
+              <a:rPr lang="en-US" sz="1500" b="1" dirty="0">
+                <a:solidFill>
+                  <a:srgbClr val="C8102E"/>
+                </a:solidFill>
+                <a:latin typeface="Arial" pitchFamily="34" charset="0"/>
+                <a:ea typeface="Arial" pitchFamily="34" charset="-122"/>
+                <a:cs typeface="Arial" pitchFamily="34" charset="-120"/>
+              </a:rPr>
+              <a:t>+$15,600 net to T^Rock</a:t>
+            </a:r>
+            <a:endParaRPr lang="en-US" sz="1500" dirty="0"/>
+          </a:p>
+        </p:txBody>
+      </p:sp>
+      <p:sp>
+        <p:nvSpPr>
+          <p:cNvPr id="12" name="Text 9"/>
+          <p:cNvSpPr/>
+          <p:nvPr/>
+        </p:nvSpPr>
+        <p:spPr>
+          <a:xfrm>
+            <a:off x="868680" y="4736592"/>
+            <a:ext cx="2926080" cy="320040"/>
+          </a:xfrm>
+          <a:prstGeom prst="rect">
+            <a:avLst/>
+          </a:prstGeom>
+          <a:noFill/>
+          <a:ln/>
+        </p:spPr>
+        <p:txBody>
+          <a:bodyPr wrap="square" lIns="0" tIns="0" rIns="0" bIns="0" rtlCol="0" anchor="ctr"/>
+          <a:lstStyle/>
+          <a:p>
+            <a:pPr indent="0" marL="0">
+              <a:buNone/>
+            </a:pPr>
+            <a:r>
+              <a:rPr lang="en-US" sz="1000" i="1" dirty="0">
+                <a:solidFill>
+                  <a:srgbClr val="6E6E6E"/>
+                </a:solidFill>
+                <a:latin typeface="Arial" pitchFamily="34" charset="0"/>
+                <a:ea typeface="Arial" pitchFamily="34" charset="-122"/>
+                <a:cs typeface="Arial" pitchFamily="34" charset="-120"/>
+              </a:rPr>
+              <a:t>after scope fee, PM split &amp; subscription</a:t>
+            </a:r>
+            <a:endParaRPr lang="en-US" sz="1000" dirty="0"/>
+          </a:p>
+        </p:txBody>
+      </p:sp>
+      <p:sp>
+        <p:nvSpPr>
+          <p:cNvPr id="13" name="Shape 10"/>
+          <p:cNvSpPr/>
+          <p:nvPr/>
+        </p:nvSpPr>
+        <p:spPr>
+          <a:xfrm>
+            <a:off x="4343400" y="1783080"/>
+            <a:ext cx="3520440" cy="3429000"/>
+          </a:xfrm>
+          <a:prstGeom prst="roundRect">
+            <a:avLst>
+              <a:gd name="adj" fmla="val 2133"/>
+            </a:avLst>
+          </a:prstGeom>
+          <a:solidFill>
+            <a:srgbClr val="F5F5F5"/>
+          </a:solidFill>
+          <a:ln/>
+        </p:spPr>
+      </p:sp>
+      <p:sp>
+        <p:nvSpPr>
+          <p:cNvPr id="14" name="Shape 11"/>
+          <p:cNvSpPr/>
+          <p:nvPr/>
+        </p:nvSpPr>
+        <p:spPr>
+          <a:xfrm>
+            <a:off x="4663440" y="2057400"/>
+            <a:ext cx="640080" cy="640080"/>
+          </a:xfrm>
+          <a:prstGeom prst="ellipse">
+            <a:avLst/>
+          </a:prstGeom>
+          <a:solidFill>
+            <a:srgbClr val="C8102E"/>
+          </a:solidFill>
+          <a:ln/>
+        </p:spPr>
+      </p:sp>
+      <p:pic>
+        <p:nvPicPr>
+          <p:cNvPr id="15" name="Image 1" descr="preencoded.png">    </p:cNvPr>
+          <p:cNvPicPr>
+            <a:picLocks noChangeAspect="1"/>
+          </p:cNvPicPr>
+          <p:nvPr/>
+        </p:nvPicPr>
+        <p:blipFill>
+          <a:blip r:embed="rId2"/>
+          <a:stretch>
+            <a:fillRect/>
+          </a:stretch>
+        </p:blipFill>
+        <p:spPr>
+          <a:xfrm>
+            <a:off x="4829861" y="2223821"/>
+            <a:ext cx="307238" cy="307238"/>
+          </a:xfrm>
+          <a:prstGeom prst="rect">
+            <a:avLst/>
+          </a:prstGeom>
+        </p:spPr>
+      </p:pic>
+      <p:sp>
+        <p:nvSpPr>
+          <p:cNvPr id="16" name="Text 12"/>
+          <p:cNvSpPr/>
+          <p:nvPr/>
+        </p:nvSpPr>
+        <p:spPr>
+          <a:xfrm>
+            <a:off x="5486400" y="2212848"/>
+            <a:ext cx="2286000" cy="320040"/>
+          </a:xfrm>
+          <a:prstGeom prst="rect">
+            <a:avLst/>
+          </a:prstGeom>
+          <a:noFill/>
+          <a:ln/>
+        </p:spPr>
+        <p:txBody>
+          <a:bodyPr wrap="square" lIns="0" tIns="0" rIns="0" bIns="0" rtlCol="0" anchor="ctr"/>
+          <a:lstStyle/>
+          <a:p>
+            <a:pPr indent="0" marL="0">
+              <a:buNone/>
+            </a:pPr>
+            <a:r>
+              <a:rPr lang="en-US" sz="1200" b="1" dirty="0">
+                <a:solidFill>
+                  <a:srgbClr val="C8102E"/>
+                </a:solidFill>
+                <a:latin typeface="Arial" pitchFamily="34" charset="0"/>
+                <a:ea typeface="Arial" pitchFamily="34" charset="-122"/>
+                <a:cs typeface="Arial" pitchFamily="34" charset="-120"/>
+              </a:rPr>
+              <a:t>BASE CASE</a:t>
+            </a:r>
+            <a:endParaRPr lang="en-US" sz="1200" dirty="0"/>
+          </a:p>
+        </p:txBody>
+      </p:sp>
+      <p:sp>
+        <p:nvSpPr>
+          <p:cNvPr id="17" name="Text 13"/>
+          <p:cNvSpPr/>
+          <p:nvPr/>
+        </p:nvSpPr>
+        <p:spPr>
+          <a:xfrm>
+            <a:off x="4663440" y="2743200"/>
+            <a:ext cx="2926080" cy="868680"/>
+          </a:xfrm>
+          <a:prstGeom prst="rect">
+            <a:avLst/>
+          </a:prstGeom>
+          <a:noFill/>
+          <a:ln/>
+        </p:spPr>
+        <p:txBody>
+          <a:bodyPr wrap="square" lIns="0" tIns="0" rIns="0" bIns="0" rtlCol="0" anchor="ctr"/>
+          <a:lstStyle/>
+          <a:p>
+            <a:pPr indent="0" marL="0">
+              <a:buNone/>
+            </a:pPr>
+            <a:r>
+              <a:rPr lang="en-US" sz="5400" b="1" dirty="0">
+                <a:solidFill>
+                  <a:srgbClr val="111111"/>
+                </a:solidFill>
+                <a:latin typeface="Arial" pitchFamily="34" charset="0"/>
+                <a:ea typeface="Arial" pitchFamily="34" charset="-122"/>
+                <a:cs typeface="Arial" pitchFamily="34" charset="-120"/>
+              </a:rPr>
+              <a:t>18</a:t>
+            </a:r>
+            <a:endParaRPr lang="en-US" sz="5400" dirty="0"/>
+          </a:p>
+        </p:txBody>
+      </p:sp>
+      <p:sp>
+        <p:nvSpPr>
+          <p:cNvPr id="18" name="Text 14"/>
+          <p:cNvSpPr/>
+          <p:nvPr/>
+        </p:nvSpPr>
+        <p:spPr>
+          <a:xfrm>
+            <a:off x="4663440" y="3611880"/>
+            <a:ext cx="2926080" cy="274320"/>
+          </a:xfrm>
+          <a:prstGeom prst="rect">
+            <a:avLst/>
+          </a:prstGeom>
+          <a:noFill/>
+          <a:ln/>
+        </p:spPr>
+        <p:txBody>
+          <a:bodyPr wrap="square" lIns="0" tIns="0" rIns="0" bIns="0" rtlCol="0" anchor="ctr"/>
+          <a:lstStyle/>
+          <a:p>
+            <a:pPr indent="0" marL="0">
+              <a:buNone/>
+            </a:pPr>
+            <a:r>
+              <a:rPr lang="en-US" sz="1200" dirty="0">
+                <a:solidFill>
+                  <a:srgbClr val="6E6E6E"/>
+                </a:solidFill>
+                <a:latin typeface="Arial" pitchFamily="34" charset="0"/>
+                <a:ea typeface="Arial" pitchFamily="34" charset="-122"/>
+                <a:cs typeface="Arial" pitchFamily="34" charset="-120"/>
+              </a:rPr>
+              <a:t>incremental roofs / yr</a:t>
+            </a:r>
+            <a:endParaRPr lang="en-US" sz="1200" dirty="0"/>
+          </a:p>
+        </p:txBody>
+      </p:sp>
+      <p:sp>
+        <p:nvSpPr>
+          <p:cNvPr id="19" name="Text 15"/>
+          <p:cNvSpPr/>
+          <p:nvPr/>
+        </p:nvSpPr>
+        <p:spPr>
+          <a:xfrm>
+            <a:off x="4663440" y="3977640"/>
+            <a:ext cx="2926080" cy="365760"/>
+          </a:xfrm>
+          <a:prstGeom prst="rect">
+            <a:avLst/>
+          </a:prstGeom>
+          <a:noFill/>
+          <a:ln/>
+        </p:spPr>
+        <p:txBody>
+          <a:bodyPr wrap="square" lIns="0" tIns="0" rIns="0" bIns="0" rtlCol="0" anchor="ctr"/>
+          <a:lstStyle/>
+          <a:p>
+            <a:pPr indent="0" marL="0">
+              <a:buNone/>
+            </a:pPr>
+            <a:r>
+              <a:rPr lang="en-US" sz="1800" b="1" dirty="0">
+                <a:solidFill>
+                  <a:srgbClr val="111111"/>
+                </a:solidFill>
+                <a:latin typeface="Arial" pitchFamily="34" charset="0"/>
+                <a:ea typeface="Arial" pitchFamily="34" charset="-122"/>
+                <a:cs typeface="Arial" pitchFamily="34" charset="-120"/>
+              </a:rPr>
+              <a:t>$540,000 revenue</a:t>
+            </a:r>
+            <a:endParaRPr lang="en-US" sz="1800" dirty="0"/>
+          </a:p>
+        </p:txBody>
+      </p:sp>
+      <p:sp>
+        <p:nvSpPr>
+          <p:cNvPr id="20" name="Text 16"/>
+          <p:cNvSpPr/>
+          <p:nvPr/>
+        </p:nvSpPr>
+        <p:spPr>
+          <a:xfrm>
+            <a:off x="4663440" y="4370832"/>
+            <a:ext cx="2926080" cy="320040"/>
+          </a:xfrm>
+          <a:prstGeom prst="rect">
+            <a:avLst/>
+          </a:prstGeom>
+          <a:noFill/>
+          <a:ln/>
+        </p:spPr>
+        <p:txBody>
+          <a:bodyPr wrap="square" lIns="0" tIns="0" rIns="0" bIns="0" rtlCol="0" anchor="ctr"/>
+          <a:lstStyle/>
+          <a:p>
+            <a:pPr indent="0" marL="0">
+              <a:buNone/>
+            </a:pPr>
+            <a:r>
+              <a:rPr lang="en-US" sz="1500" b="1" dirty="0">
+                <a:solidFill>
+                  <a:srgbClr val="C8102E"/>
+                </a:solidFill>
+                <a:latin typeface="Arial" pitchFamily="34" charset="0"/>
+                <a:ea typeface="Arial" pitchFamily="34" charset="-122"/>
+                <a:cs typeface="Arial" pitchFamily="34" charset="-120"/>
+              </a:rPr>
+              <a:t>+$65,100 net to T^Rock</a:t>
+            </a:r>
+            <a:endParaRPr lang="en-US" sz="1500" dirty="0"/>
+          </a:p>
+        </p:txBody>
+      </p:sp>
+      <p:sp>
+        <p:nvSpPr>
+          <p:cNvPr id="21" name="Text 17"/>
+          <p:cNvSpPr/>
+          <p:nvPr/>
+        </p:nvSpPr>
+        <p:spPr>
+          <a:xfrm>
+            <a:off x="4663440" y="4736592"/>
+            <a:ext cx="2926080" cy="320040"/>
+          </a:xfrm>
+          <a:prstGeom prst="rect">
+            <a:avLst/>
+          </a:prstGeom>
+          <a:noFill/>
+          <a:ln/>
+        </p:spPr>
+        <p:txBody>
+          <a:bodyPr wrap="square" lIns="0" tIns="0" rIns="0" bIns="0" rtlCol="0" anchor="ctr"/>
+          <a:lstStyle/>
+          <a:p>
+            <a:pPr indent="0" marL="0">
+              <a:buNone/>
+            </a:pPr>
+            <a:r>
+              <a:rPr lang="en-US" sz="1000" i="1" dirty="0">
+                <a:solidFill>
+                  <a:srgbClr val="6E6E6E"/>
+                </a:solidFill>
+                <a:latin typeface="Arial" pitchFamily="34" charset="0"/>
+                <a:ea typeface="Arial" pitchFamily="34" charset="-122"/>
+                <a:cs typeface="Arial" pitchFamily="34" charset="-120"/>
+              </a:rPr>
+              <a:t>after scope fee, PM split &amp; subscription</a:t>
+            </a:r>
+            <a:endParaRPr lang="en-US" sz="1000" dirty="0"/>
+          </a:p>
+        </p:txBody>
+      </p:sp>
+      <p:sp>
+        <p:nvSpPr>
+          <p:cNvPr id="22" name="Shape 18"/>
+          <p:cNvSpPr/>
+          <p:nvPr/>
+        </p:nvSpPr>
+        <p:spPr>
+          <a:xfrm>
+            <a:off x="8138160" y="1783080"/>
+            <a:ext cx="3520440" cy="3429000"/>
+          </a:xfrm>
+          <a:prstGeom prst="roundRect">
+            <a:avLst>
+              <a:gd name="adj" fmla="val 2133"/>
+            </a:avLst>
+          </a:prstGeom>
+          <a:solidFill>
+            <a:srgbClr val="F5F5F5"/>
+          </a:solidFill>
+          <a:ln/>
+        </p:spPr>
+      </p:sp>
+      <p:sp>
+        <p:nvSpPr>
+          <p:cNvPr id="23" name="Shape 19"/>
+          <p:cNvSpPr/>
+          <p:nvPr/>
+        </p:nvSpPr>
+        <p:spPr>
+          <a:xfrm>
+            <a:off x="8458200" y="2057400"/>
+            <a:ext cx="640080" cy="640080"/>
+          </a:xfrm>
+          <a:prstGeom prst="ellipse">
+            <a:avLst/>
+          </a:prstGeom>
+          <a:solidFill>
+            <a:srgbClr val="C8102E"/>
+          </a:solidFill>
+          <a:ln/>
+        </p:spPr>
+      </p:sp>
+      <p:pic>
+        <p:nvPicPr>
+          <p:cNvPr id="24" name="Image 2" descr="preencoded.png">    </p:cNvPr>
+          <p:cNvPicPr>
+            <a:picLocks noChangeAspect="1"/>
+          </p:cNvPicPr>
+          <p:nvPr/>
+        </p:nvPicPr>
+        <p:blipFill>
+          <a:blip r:embed="rId3"/>
+          <a:stretch>
+            <a:fillRect/>
+          </a:stretch>
+        </p:blipFill>
+        <p:spPr>
+          <a:xfrm>
+            <a:off x="8624621" y="2223821"/>
+            <a:ext cx="307238" cy="307238"/>
+          </a:xfrm>
+          <a:prstGeom prst="rect">
+            <a:avLst/>
+          </a:prstGeom>
+        </p:spPr>
+      </p:pic>
+      <p:sp>
+        <p:nvSpPr>
+          <p:cNvPr id="25" name="Text 20"/>
+          <p:cNvSpPr/>
+          <p:nvPr/>
+        </p:nvSpPr>
+        <p:spPr>
+          <a:xfrm>
+            <a:off x="9281160" y="2212848"/>
+            <a:ext cx="2286000" cy="320040"/>
+          </a:xfrm>
+          <a:prstGeom prst="rect">
+            <a:avLst/>
+          </a:prstGeom>
+          <a:noFill/>
+          <a:ln/>
+        </p:spPr>
+        <p:txBody>
+          <a:bodyPr wrap="square" lIns="0" tIns="0" rIns="0" bIns="0" rtlCol="0" anchor="ctr"/>
+          <a:lstStyle/>
+          <a:p>
+            <a:pPr indent="0" marL="0">
+              <a:buNone/>
+            </a:pPr>
+            <a:r>
+              <a:rPr lang="en-US" sz="1200" b="1" dirty="0">
+                <a:solidFill>
+                  <a:srgbClr val="C8102E"/>
+                </a:solidFill>
+                <a:latin typeface="Arial" pitchFamily="34" charset="0"/>
+                <a:ea typeface="Arial" pitchFamily="34" charset="-122"/>
+                <a:cs typeface="Arial" pitchFamily="34" charset="-120"/>
+              </a:rPr>
+              <a:t>STRONG STORM YEAR</a:t>
+            </a:r>
+            <a:endParaRPr lang="en-US" sz="1200" dirty="0"/>
+          </a:p>
+        </p:txBody>
+      </p:sp>
+      <p:sp>
+        <p:nvSpPr>
+          <p:cNvPr id="26" name="Text 21"/>
+          <p:cNvSpPr/>
+          <p:nvPr/>
+        </p:nvSpPr>
+        <p:spPr>
+          <a:xfrm>
+            <a:off x="8458200" y="2743200"/>
+            <a:ext cx="2926080" cy="868680"/>
+          </a:xfrm>
+          <a:prstGeom prst="rect">
+            <a:avLst/>
+          </a:prstGeom>
+          <a:noFill/>
+          <a:ln/>
+        </p:spPr>
+        <p:txBody>
+          <a:bodyPr wrap="square" lIns="0" tIns="0" rIns="0" bIns="0" rtlCol="0" anchor="ctr"/>
+          <a:lstStyle/>
+          <a:p>
+            <a:pPr indent="0" marL="0">
+              <a:buNone/>
+            </a:pPr>
+            <a:r>
+              <a:rPr lang="en-US" sz="5400" b="1" dirty="0">
+                <a:solidFill>
+                  <a:srgbClr val="111111"/>
+                </a:solidFill>
+                <a:latin typeface="Arial" pitchFamily="34" charset="0"/>
+                <a:ea typeface="Arial" pitchFamily="34" charset="-122"/>
+                <a:cs typeface="Arial" pitchFamily="34" charset="-120"/>
+              </a:rPr>
+              <a:t>30</a:t>
+            </a:r>
+            <a:endParaRPr lang="en-US" sz="5400" dirty="0"/>
+          </a:p>
+        </p:txBody>
+      </p:sp>
+      <p:sp>
+        <p:nvSpPr>
+          <p:cNvPr id="27" name="Text 22"/>
+          <p:cNvSpPr/>
+          <p:nvPr/>
+        </p:nvSpPr>
+        <p:spPr>
+          <a:xfrm>
+            <a:off x="8458200" y="3611880"/>
+            <a:ext cx="2926080" cy="274320"/>
+          </a:xfrm>
+          <a:prstGeom prst="rect">
+            <a:avLst/>
+          </a:prstGeom>
+          <a:noFill/>
+          <a:ln/>
+        </p:spPr>
+        <p:txBody>
+          <a:bodyPr wrap="square" lIns="0" tIns="0" rIns="0" bIns="0" rtlCol="0" anchor="ctr"/>
+          <a:lstStyle/>
+          <a:p>
+            <a:pPr indent="0" marL="0">
+              <a:buNone/>
+            </a:pPr>
+            <a:r>
+              <a:rPr lang="en-US" sz="1200" dirty="0">
+                <a:solidFill>
+                  <a:srgbClr val="6E6E6E"/>
+                </a:solidFill>
+                <a:latin typeface="Arial" pitchFamily="34" charset="0"/>
+                <a:ea typeface="Arial" pitchFamily="34" charset="-122"/>
+                <a:cs typeface="Arial" pitchFamily="34" charset="-120"/>
+              </a:rPr>
+              <a:t>incremental roofs / yr</a:t>
+            </a:r>
+            <a:endParaRPr lang="en-US" sz="1200" dirty="0"/>
+          </a:p>
+        </p:txBody>
+      </p:sp>
+      <p:sp>
+        <p:nvSpPr>
+          <p:cNvPr id="28" name="Text 23"/>
+          <p:cNvSpPr/>
+          <p:nvPr/>
+        </p:nvSpPr>
+        <p:spPr>
+          <a:xfrm>
+            <a:off x="8458200" y="3977640"/>
+            <a:ext cx="2926080" cy="365760"/>
+          </a:xfrm>
+          <a:prstGeom prst="rect">
+            <a:avLst/>
+          </a:prstGeom>
+          <a:noFill/>
+          <a:ln/>
+        </p:spPr>
+        <p:txBody>
+          <a:bodyPr wrap="square" lIns="0" tIns="0" rIns="0" bIns="0" rtlCol="0" anchor="ctr"/>
+          <a:lstStyle/>
+          <a:p>
+            <a:pPr indent="0" marL="0">
+              <a:buNone/>
+            </a:pPr>
+            <a:r>
+              <a:rPr lang="en-US" sz="1800" b="1" dirty="0">
+                <a:solidFill>
+                  <a:srgbClr val="111111"/>
+                </a:solidFill>
+                <a:latin typeface="Arial" pitchFamily="34" charset="0"/>
+                <a:ea typeface="Arial" pitchFamily="34" charset="-122"/>
+                <a:cs typeface="Arial" pitchFamily="34" charset="-120"/>
+              </a:rPr>
+              <a:t>$900,000 revenue</a:t>
+            </a:r>
+            <a:endParaRPr lang="en-US" sz="1800" dirty="0"/>
+          </a:p>
+        </p:txBody>
+      </p:sp>
+      <p:sp>
+        <p:nvSpPr>
+          <p:cNvPr id="29" name="Text 24"/>
+          <p:cNvSpPr/>
+          <p:nvPr/>
+        </p:nvSpPr>
+        <p:spPr>
+          <a:xfrm>
+            <a:off x="8458200" y="4370832"/>
+            <a:ext cx="2926080" cy="320040"/>
+          </a:xfrm>
+          <a:prstGeom prst="rect">
+            <a:avLst/>
+          </a:prstGeom>
+          <a:noFill/>
+          <a:ln/>
+        </p:spPr>
+        <p:txBody>
+          <a:bodyPr wrap="square" lIns="0" tIns="0" rIns="0" bIns="0" rtlCol="0" anchor="ctr"/>
+          <a:lstStyle/>
+          <a:p>
+            <a:pPr indent="0" marL="0">
+              <a:buNone/>
+            </a:pPr>
+            <a:r>
+              <a:rPr lang="en-US" sz="1500" b="1" dirty="0">
+                <a:solidFill>
+                  <a:srgbClr val="C8102E"/>
+                </a:solidFill>
+                <a:latin typeface="Arial" pitchFamily="34" charset="0"/>
+                <a:ea typeface="Arial" pitchFamily="34" charset="-122"/>
+                <a:cs typeface="Arial" pitchFamily="34" charset="-120"/>
+              </a:rPr>
+              <a:t>+$124,500 net to T^Rock</a:t>
+            </a:r>
+            <a:endParaRPr lang="en-US" sz="1500" dirty="0"/>
+          </a:p>
+        </p:txBody>
+      </p:sp>
+      <p:sp>
+        <p:nvSpPr>
+          <p:cNvPr id="30" name="Text 25"/>
+          <p:cNvSpPr/>
+          <p:nvPr/>
+        </p:nvSpPr>
+        <p:spPr>
+          <a:xfrm>
+            <a:off x="8458200" y="4736592"/>
+            <a:ext cx="2926080" cy="320040"/>
+          </a:xfrm>
+          <a:prstGeom prst="rect">
+            <a:avLst/>
+          </a:prstGeom>
+          <a:noFill/>
+          <a:ln/>
+        </p:spPr>
+        <p:txBody>
+          <a:bodyPr wrap="square" lIns="0" tIns="0" rIns="0" bIns="0" rtlCol="0" anchor="ctr"/>
+          <a:lstStyle/>
+          <a:p>
+            <a:pPr indent="0" marL="0">
+              <a:buNone/>
+            </a:pPr>
+            <a:r>
+              <a:rPr lang="en-US" sz="1000" i="1" dirty="0">
+                <a:solidFill>
+                  <a:srgbClr val="6E6E6E"/>
+                </a:solidFill>
+                <a:latin typeface="Arial" pitchFamily="34" charset="0"/>
+                <a:ea typeface="Arial" pitchFamily="34" charset="-122"/>
+                <a:cs typeface="Arial" pitchFamily="34" charset="-120"/>
+              </a:rPr>
+              <a:t>after scope fee, PM split &amp; subscription</a:t>
+            </a:r>
+            <a:endParaRPr lang="en-US" sz="1000" dirty="0"/>
+          </a:p>
+        </p:txBody>
+      </p:sp>
+      <p:sp>
+        <p:nvSpPr>
+          <p:cNvPr id="31" name="Shape 26"/>
+          <p:cNvSpPr/>
+          <p:nvPr/>
+        </p:nvSpPr>
+        <p:spPr>
+          <a:xfrm>
+            <a:off x="548640" y="5486400"/>
+            <a:ext cx="11064240" cy="731520"/>
+          </a:xfrm>
+          <a:prstGeom prst="roundRect">
+            <a:avLst>
+              <a:gd name="adj" fmla="val 7500"/>
+            </a:avLst>
+          </a:prstGeom>
+          <a:solidFill>
+            <a:srgbClr val="111111"/>
+          </a:solidFill>
+          <a:ln/>
+        </p:spPr>
+      </p:sp>
+      <p:sp>
+        <p:nvSpPr>
+          <p:cNvPr id="32" name="Text 27"/>
+          <p:cNvSpPr/>
+          <p:nvPr/>
+        </p:nvSpPr>
+        <p:spPr>
+          <a:xfrm>
+            <a:off x="868680" y="5605272"/>
+            <a:ext cx="10515600" cy="502920"/>
+          </a:xfrm>
+          <a:prstGeom prst="rect">
+            <a:avLst/>
+          </a:prstGeom>
+          <a:noFill/>
+          <a:ln/>
+        </p:spPr>
+        <p:txBody>
+          <a:bodyPr wrap="square" lIns="0" tIns="0" rIns="0" bIns="0" rtlCol="0" anchor="ctr"/>
+          <a:lstStyle/>
+          <a:p>
+            <a:pPr indent="0" marL="0">
+              <a:buNone/>
+            </a:pPr>
+            <a:r>
+              <a:rPr lang="en-US" sz="1500" b="1" dirty="0">
+                <a:solidFill>
+                  <a:srgbClr val="FFFFFF"/>
+                </a:solidFill>
+                <a:latin typeface="Arial" pitchFamily="34" charset="0"/>
+                <a:ea typeface="Arial" pitchFamily="34" charset="-122"/>
+                <a:cs typeface="Arial" pitchFamily="34" charset="-120"/>
+              </a:rPr>
+              <a:t>The maps exist either way. </a:t>
+            </a:r>
+            <a:pPr indent="0" marL="0">
+              <a:buNone/>
+            </a:pPr>
+            <a:r>
+              <a:rPr lang="en-US" sz="1500" dirty="0">
+                <a:solidFill>
+                  <a:srgbClr val="E6E6E6"/>
+                </a:solidFill>
+                <a:latin typeface="Arial" pitchFamily="34" charset="0"/>
+                <a:ea typeface="Arial" pitchFamily="34" charset="-122"/>
+                <a:cs typeface="Arial" pitchFamily="34" charset="-120"/>
+              </a:rPr>
+              <a:t>The only question is whether T^Rock or a competitor is holding them when the next storm hits.</a:t>
+            </a:r>
+            <a:endParaRPr lang="en-US" sz="1500" dirty="0"/>
+          </a:p>
+        </p:txBody>
+      </p:sp>
+      <p:sp>
+        <p:nvSpPr>
+          <p:cNvPr id="33" name="Text 28"/>
+          <p:cNvSpPr/>
+          <p:nvPr/>
+        </p:nvSpPr>
+        <p:spPr>
+          <a:xfrm>
+            <a:off x="548640" y="6473952"/>
+            <a:ext cx="9601200" cy="274320"/>
+          </a:xfrm>
+          <a:prstGeom prst="rect">
+            <a:avLst/>
+          </a:prstGeom>
+          <a:noFill/>
+          <a:ln/>
+        </p:spPr>
+        <p:txBody>
+          <a:bodyPr wrap="square" lIns="0" tIns="0" rIns="0" bIns="0" rtlCol="0" anchor="ctr"/>
+          <a:lstStyle/>
+          <a:p>
+            <a:pPr indent="0" marL="0">
+              <a:buNone/>
+            </a:pPr>
+            <a:r>
+              <a:rPr lang="en-US" sz="900" dirty="0">
+                <a:solidFill>
+                  <a:srgbClr val="6E6E6E"/>
+                </a:solidFill>
+                <a:latin typeface="Arial" pitchFamily="34" charset="0"/>
+                <a:ea typeface="Arial" pitchFamily="34" charset="-122"/>
+                <a:cs typeface="Arial" pitchFamily="34" charset="-120"/>
+              </a:rPr>
+              <a:t>Net = (RCV × 35% − 2% scope fee) ÷ 2 − $24,000/yr subscription. Any shared-lead or list spend this replaces is a direct offset on top.</a:t>
+            </a:r>
+            <a:endParaRPr lang="en-US" sz="900" dirty="0"/>
+          </a:p>
+        </p:txBody>
+      </p:sp>
+      <p:sp>
+        <p:nvSpPr>
+          <p:cNvPr id="34" name="Text 29"/>
+          <p:cNvSpPr/>
+          <p:nvPr/>
+        </p:nvSpPr>
+        <p:spPr>
+          <a:xfrm>
+            <a:off x="11274552" y="6473952"/>
+            <a:ext cx="457200" cy="274320"/>
+          </a:xfrm>
+          <a:prstGeom prst="rect">
+            <a:avLst/>
+          </a:prstGeom>
+          <a:noFill/>
+          <a:ln/>
+        </p:spPr>
+        <p:txBody>
+          <a:bodyPr wrap="square" lIns="0" tIns="0" rIns="0" bIns="0" rtlCol="0" anchor="ctr"/>
+          <a:lstStyle/>
+          <a:p>
+            <a:pPr algn="r" indent="0" marL="0">
+              <a:buNone/>
+            </a:pPr>
+            <a:r>
+              <a:rPr lang="en-US" sz="1000" dirty="0">
+                <a:solidFill>
+                  <a:srgbClr val="6E6E6E"/>
+                </a:solidFill>
+                <a:latin typeface="Arial" pitchFamily="34" charset="0"/>
+                <a:ea typeface="Arial" pitchFamily="34" charset="-122"/>
+                <a:cs typeface="Arial" pitchFamily="34" charset="-120"/>
+              </a:rPr>
+              <a:t>8</a:t>
+            </a:r>
+            <a:endParaRPr lang="en-US" sz="1000" dirty="0"/>
+          </a:p>
+        </p:txBody>
+      </p:sp>
+    </p:spTree>
+  </p:cSld>
+  <p:clrMapOvr>
+    <a:masterClrMapping/>
+  </p:clrMapOvr>
+</p:sld>
+</file>
+
+<file path=ppt/slides/slide9.xml><?xml version="1.0" encoding="utf-8"?>
+<p:sld xmlns:a="http://schemas.openxmlformats.org/drawingml/2006/main" xmlns:r="http://schemas.openxmlformats.org/officeDocument/2006/relationships" xmlns:p="http://schemas.openxmlformats.org/presentationml/2006/main">
+  <p:cSld name="Slide 9">
+    <p:bg>
+      <p:bgPr>
+        <a:solidFill>
+          <a:srgbClr val="FFFFFF"/>
+        </a:solidFill>
+      </p:bgPr>
+    </p:bg>
+    <p:spTree>
+      <p:nvGrpSpPr>
+        <p:cNvPr id="1" name=""/>
+        <p:cNvGrpSpPr/>
+        <p:nvPr/>
+      </p:nvGrpSpPr>
+      <p:grpSpPr>
+        <a:xfrm>
+          <a:off x="0" y="0"/>
+          <a:ext cx="0" cy="0"/>
+          <a:chOff x="0" y="0"/>
+          <a:chExt cx="0" cy="0"/>
+        </a:xfrm>
+      </p:grpSpPr>
+      <p:sp>
+        <p:nvSpPr>
+          <p:cNvPr id="2" name="Text 0"/>
+          <p:cNvSpPr/>
+          <p:nvPr/>
+        </p:nvSpPr>
+        <p:spPr>
+          <a:xfrm>
+            <a:off x="548640" y="411480"/>
+            <a:ext cx="11064240" cy="640080"/>
+          </a:xfrm>
+          <a:prstGeom prst="rect">
+            <a:avLst/>
+          </a:prstGeom>
+          <a:noFill/>
+          <a:ln/>
+        </p:spPr>
+        <p:txBody>
+          <a:bodyPr wrap="square" lIns="0" tIns="0" rIns="0" bIns="0" rtlCol="0" anchor="ctr"/>
+          <a:lstStyle/>
+          <a:p>
+            <a:pPr indent="0" marL="0">
+              <a:buNone/>
+            </a:pPr>
+            <a:r>
+              <a:rPr lang="en-US" sz="3200" b="1" dirty="0">
+                <a:solidFill>
+                  <a:srgbClr val="111111"/>
+                </a:solidFill>
+                <a:latin typeface="Arial" pitchFamily="34" charset="0"/>
+                <a:ea typeface="Arial" pitchFamily="34" charset="-122"/>
+                <a:cs typeface="Arial" pitchFamily="34" charset="-120"/>
+              </a:rPr>
               <a:t>The 90-day proof period: scored, capped, killable</a:t>
             </a:r>
             <a:endParaRPr lang="en-US" sz="3200" dirty="0"/>
@@ -10640,7 +12606,7 @@
       </p:sp>
       <p:graphicFrame>
         <p:nvGraphicFramePr>
-          <p:cNvPr id="9" name="Table 0"/>
+          <p:cNvPr id="10" name="Table 0"/>
           <p:cNvGraphicFramePr>
             <a:graphicFrameLocks noGrp="1"/>
           </p:cNvGraphicFramePr>
@@ -11754,7 +13720,7 @@
                 <a:ea typeface="Arial" pitchFamily="34" charset="-122"/>
                 <a:cs typeface="Arial" pitchFamily="34" charset="-120"/>
               </a:rPr>
-              <a:t>if all-in cost per sold job isn't beating our current baseline at day 90, we cancel. Spend at risk: $6,000 — T-Rock's net on about 1.2 jobs. Founding bills $2,000 monthly; we get clean cancellation terms in writing before signing.</a:t>
+              <a:t>if all-in cost per sold job isn't beating our current baseline at day 90, we cancel. Spend at risk: $6,000 — T^Rock's net on about 1.2 jobs. Founding bills $2,000 monthly; we get clean cancellation terms in writing before signing.</a:t>
             </a:r>
             <a:endParaRPr lang="en-US" sz="1450" dirty="0"/>
           </a:p>
@@ -11793,7 +13759,7 @@
                 <a:ea typeface="Arial" pitchFamily="34" charset="-122"/>
                 <a:cs typeface="Arial" pitchFamily="34" charset="-120"/>
               </a:rPr>
-              <a:t>Targets are proposals — Aaron/Alan set final thresholds before we start.</a:t>
+              <a:t>Start the 90-day clock on the first mapped storm, not a calendar date. Leadership sets final thresholds up front.</a:t>
             </a:r>
             <a:endParaRPr lang="en-US" sz="900" dirty="0"/>
           </a:p>
@@ -11802,720 +13768,6 @@
       <p:sp>
         <p:nvSpPr>
           <p:cNvPr id="9" name="Text 5"/>
-          <p:cNvSpPr/>
-          <p:nvPr/>
-        </p:nvSpPr>
-        <p:spPr>
-          <a:xfrm>
-            <a:off x="11274552" y="6473952"/>
-            <a:ext cx="457200" cy="274320"/>
-          </a:xfrm>
-          <a:prstGeom prst="rect">
-            <a:avLst/>
-          </a:prstGeom>
-          <a:noFill/>
-          <a:ln/>
-        </p:spPr>
-        <p:txBody>
-          <a:bodyPr wrap="square" lIns="0" tIns="0" rIns="0" bIns="0" rtlCol="0" anchor="ctr"/>
-          <a:lstStyle/>
-          <a:p>
-            <a:pPr algn="r" indent="0" marL="0">
-              <a:buNone/>
-            </a:pPr>
-            <a:r>
-              <a:rPr lang="en-US" sz="1000" dirty="0">
-                <a:solidFill>
-                  <a:srgbClr val="6E6E6E"/>
-                </a:solidFill>
-                <a:latin typeface="Arial" pitchFamily="34" charset="0"/>
-                <a:ea typeface="Arial" pitchFamily="34" charset="-122"/>
-                <a:cs typeface="Arial" pitchFamily="34" charset="-120"/>
-              </a:rPr>
-              <a:t>8</a:t>
-            </a:r>
-            <a:endParaRPr lang="en-US" sz="1000" dirty="0"/>
-          </a:p>
-        </p:txBody>
-      </p:sp>
-    </p:spTree>
-  </p:cSld>
-  <p:clrMapOvr>
-    <a:masterClrMapping/>
-  </p:clrMapOvr>
-</p:sld>
-</file>
-
-<file path=ppt/slides/slide9.xml><?xml version="1.0" encoding="utf-8"?>
-<p:sld xmlns:a="http://schemas.openxmlformats.org/drawingml/2006/main" xmlns:r="http://schemas.openxmlformats.org/officeDocument/2006/relationships" xmlns:p="http://schemas.openxmlformats.org/presentationml/2006/main">
-  <p:cSld name="Slide 9">
-    <p:bg>
-      <p:bgPr>
-        <a:solidFill>
-          <a:srgbClr val="FFFFFF"/>
-        </a:solidFill>
-      </p:bgPr>
-    </p:bg>
-    <p:spTree>
-      <p:nvGrpSpPr>
-        <p:cNvPr id="1" name=""/>
-        <p:cNvGrpSpPr/>
-        <p:nvPr/>
-      </p:nvGrpSpPr>
-      <p:grpSpPr>
-        <a:xfrm>
-          <a:off x="0" y="0"/>
-          <a:ext cx="0" cy="0"/>
-          <a:chOff x="0" y="0"/>
-          <a:chExt cx="0" cy="0"/>
-        </a:xfrm>
-      </p:grpSpPr>
-      <p:sp>
-        <p:nvSpPr>
-          <p:cNvPr id="2" name="Text 0"/>
-          <p:cNvSpPr/>
-          <p:nvPr/>
-        </p:nvSpPr>
-        <p:spPr>
-          <a:xfrm>
-            <a:off x="548640" y="411480"/>
-            <a:ext cx="11064240" cy="640080"/>
-          </a:xfrm>
-          <a:prstGeom prst="rect">
-            <a:avLst/>
-          </a:prstGeom>
-          <a:noFill/>
-          <a:ln/>
-        </p:spPr>
-        <p:txBody>
-          <a:bodyPr wrap="square" lIns="0" tIns="0" rIns="0" bIns="0" rtlCol="0" anchor="ctr"/>
-          <a:lstStyle/>
-          <a:p>
-            <a:pPr indent="0" marL="0">
-              <a:buNone/>
-            </a:pPr>
-            <a:r>
-              <a:rPr lang="en-US" sz="3200" b="1" dirty="0">
-                <a:solidFill>
-                  <a:srgbClr val="111111"/>
-                </a:solidFill>
-                <a:latin typeface="Arial" pitchFamily="34" charset="0"/>
-                <a:ea typeface="Arial" pitchFamily="34" charset="-122"/>
-                <a:cs typeface="Arial" pitchFamily="34" charset="-120"/>
-              </a:rPr>
-              <a:t>Straight answers before you ask</a:t>
-            </a:r>
-            <a:endParaRPr lang="en-US" sz="3200" dirty="0"/>
-          </a:p>
-        </p:txBody>
-      </p:sp>
-      <p:sp>
-        <p:nvSpPr>
-          <p:cNvPr id="3" name="Shape 1"/>
-          <p:cNvSpPr/>
-          <p:nvPr/>
-        </p:nvSpPr>
-        <p:spPr>
-          <a:xfrm>
-            <a:off x="548640" y="1371600"/>
-            <a:ext cx="5394960" cy="2194560"/>
-          </a:xfrm>
-          <a:prstGeom prst="roundRect">
-            <a:avLst>
-              <a:gd name="adj" fmla="val 3333"/>
-            </a:avLst>
-          </a:prstGeom>
-          <a:solidFill>
-            <a:srgbClr val="F5F5F5"/>
-          </a:solidFill>
-          <a:ln/>
-        </p:spPr>
-      </p:sp>
-      <p:sp>
-        <p:nvSpPr>
-          <p:cNvPr id="4" name="Shape 2"/>
-          <p:cNvSpPr/>
-          <p:nvPr/>
-        </p:nvSpPr>
-        <p:spPr>
-          <a:xfrm>
-            <a:off x="822960" y="1645920"/>
-            <a:ext cx="594360" cy="594360"/>
-          </a:xfrm>
-          <a:prstGeom prst="ellipse">
-            <a:avLst/>
-          </a:prstGeom>
-          <a:solidFill>
-            <a:srgbClr val="C8102E"/>
-          </a:solidFill>
-          <a:ln/>
-        </p:spPr>
-      </p:sp>
-      <p:pic>
-        <p:nvPicPr>
-          <p:cNvPr id="5" name="Image 0" descr="preencoded.png">    </p:cNvPr>
-          <p:cNvPicPr>
-            <a:picLocks noChangeAspect="1"/>
-          </p:cNvPicPr>
-          <p:nvPr/>
-        </p:nvPicPr>
-        <p:blipFill>
-          <a:blip r:embed="rId1"/>
-          <a:stretch>
-            <a:fillRect/>
-          </a:stretch>
-        </p:blipFill>
-        <p:spPr>
-          <a:xfrm>
-            <a:off x="977494" y="1800454"/>
-            <a:ext cx="285293" cy="285293"/>
-          </a:xfrm>
-          <a:prstGeom prst="rect">
-            <a:avLst/>
-          </a:prstGeom>
-        </p:spPr>
-      </p:pic>
-      <p:sp>
-        <p:nvSpPr>
-          <p:cNvPr id="6" name="Text 3"/>
-          <p:cNvSpPr/>
-          <p:nvPr/>
-        </p:nvSpPr>
-        <p:spPr>
-          <a:xfrm>
-            <a:off x="1600200" y="1627632"/>
-            <a:ext cx="4160520" cy="365760"/>
-          </a:xfrm>
-          <a:prstGeom prst="rect">
-            <a:avLst/>
-          </a:prstGeom>
-          <a:noFill/>
-          <a:ln/>
-        </p:spPr>
-        <p:txBody>
-          <a:bodyPr wrap="square" lIns="0" tIns="0" rIns="0" bIns="0" rtlCol="0" anchor="ctr"/>
-          <a:lstStyle/>
-          <a:p>
-            <a:pPr indent="0" marL="0">
-              <a:buNone/>
-            </a:pPr>
-            <a:r>
-              <a:rPr lang="en-US" sz="1600" b="1" dirty="0">
-                <a:solidFill>
-                  <a:srgbClr val="C8102E"/>
-                </a:solidFill>
-                <a:latin typeface="Arial" pitchFamily="34" charset="0"/>
-                <a:ea typeface="Arial" pitchFamily="34" charset="-122"/>
-                <a:cs typeface="Arial" pitchFamily="34" charset="-120"/>
-              </a:rPr>
-              <a:t>“Isn't the ‘limited offer’ a sales tactic?”</a:t>
-            </a:r>
-            <a:endParaRPr lang="en-US" sz="1600" dirty="0"/>
-          </a:p>
-        </p:txBody>
-      </p:sp>
-      <p:sp>
-        <p:nvSpPr>
-          <p:cNvPr id="7" name="Text 4"/>
-          <p:cNvSpPr/>
-          <p:nvPr/>
-        </p:nvSpPr>
-        <p:spPr>
-          <a:xfrm>
-            <a:off x="1600200" y="2029968"/>
-            <a:ext cx="4160520" cy="1463040"/>
-          </a:xfrm>
-          <a:prstGeom prst="rect">
-            <a:avLst/>
-          </a:prstGeom>
-          <a:noFill/>
-          <a:ln/>
-        </p:spPr>
-        <p:txBody>
-          <a:bodyPr wrap="square" lIns="0" tIns="0" rIns="0" bIns="0" rtlCol="0" anchor="ctr"/>
-          <a:lstStyle/>
-          <a:p>
-            <a:pPr indent="0" marL="0">
-              <a:buNone/>
-            </a:pPr>
-            <a:r>
-              <a:rPr lang="en-US" sz="1200" dirty="0">
-                <a:solidFill>
-                  <a:srgbClr val="2A2A2A"/>
-                </a:solidFill>
-                <a:latin typeface="Arial" pitchFamily="34" charset="0"/>
-                <a:ea typeface="Arial" pitchFamily="34" charset="-122"/>
-                <a:cs typeface="Arial" pitchFamily="34" charset="-120"/>
-              </a:rPr>
-              <a:t>Probably — and it doesn't matter. Billing is $2,000 monthly, locked forever: keep it and we pay $500/mo under sticker for life; cancel at day 90 and we're out $6,000 — T-Rock's net on about one job. Only dealbreaker: cancellation terms that aren't clean.</a:t>
-            </a:r>
-            <a:endParaRPr lang="en-US" sz="1200" dirty="0"/>
-          </a:p>
-        </p:txBody>
-      </p:sp>
-      <p:sp>
-        <p:nvSpPr>
-          <p:cNvPr id="8" name="Shape 5"/>
-          <p:cNvSpPr/>
-          <p:nvPr/>
-        </p:nvSpPr>
-        <p:spPr>
-          <a:xfrm>
-            <a:off x="6217920" y="1371600"/>
-            <a:ext cx="5394960" cy="2194560"/>
-          </a:xfrm>
-          <a:prstGeom prst="roundRect">
-            <a:avLst>
-              <a:gd name="adj" fmla="val 3333"/>
-            </a:avLst>
-          </a:prstGeom>
-          <a:solidFill>
-            <a:srgbClr val="F5F5F5"/>
-          </a:solidFill>
-          <a:ln/>
-        </p:spPr>
-      </p:sp>
-      <p:sp>
-        <p:nvSpPr>
-          <p:cNvPr id="9" name="Shape 6"/>
-          <p:cNvSpPr/>
-          <p:nvPr/>
-        </p:nvSpPr>
-        <p:spPr>
-          <a:xfrm>
-            <a:off x="6492240" y="1645920"/>
-            <a:ext cx="594360" cy="594360"/>
-          </a:xfrm>
-          <a:prstGeom prst="ellipse">
-            <a:avLst/>
-          </a:prstGeom>
-          <a:solidFill>
-            <a:srgbClr val="C8102E"/>
-          </a:solidFill>
-          <a:ln/>
-        </p:spPr>
-      </p:sp>
-      <p:pic>
-        <p:nvPicPr>
-          <p:cNvPr id="10" name="Image 1" descr="preencoded.png">    </p:cNvPr>
-          <p:cNvPicPr>
-            <a:picLocks noChangeAspect="1"/>
-          </p:cNvPicPr>
-          <p:nvPr/>
-        </p:nvPicPr>
-        <p:blipFill>
-          <a:blip r:embed="rId2"/>
-          <a:stretch>
-            <a:fillRect/>
-          </a:stretch>
-        </p:blipFill>
-        <p:spPr>
-          <a:xfrm>
-            <a:off x="6646774" y="1800454"/>
-            <a:ext cx="285293" cy="285293"/>
-          </a:xfrm>
-          <a:prstGeom prst="rect">
-            <a:avLst/>
-          </a:prstGeom>
-        </p:spPr>
-      </p:pic>
-      <p:sp>
-        <p:nvSpPr>
-          <p:cNvPr id="11" name="Text 7"/>
-          <p:cNvSpPr/>
-          <p:nvPr/>
-        </p:nvSpPr>
-        <p:spPr>
-          <a:xfrm>
-            <a:off x="7269480" y="1627632"/>
-            <a:ext cx="4160520" cy="365760"/>
-          </a:xfrm>
-          <a:prstGeom prst="rect">
-            <a:avLst/>
-          </a:prstGeom>
-          <a:noFill/>
-          <a:ln/>
-        </p:spPr>
-        <p:txBody>
-          <a:bodyPr wrap="square" lIns="0" tIns="0" rIns="0" bIns="0" rtlCol="0" anchor="ctr"/>
-          <a:lstStyle/>
-          <a:p>
-            <a:pPr indent="0" marL="0">
-              <a:buNone/>
-            </a:pPr>
-            <a:r>
-              <a:rPr lang="en-US" sz="1600" b="1" dirty="0">
-                <a:solidFill>
-                  <a:srgbClr val="C8102E"/>
-                </a:solidFill>
-                <a:latin typeface="Arial" pitchFamily="34" charset="0"/>
-                <a:ea typeface="Arial" pitchFamily="34" charset="-122"/>
-                <a:cs typeface="Arial" pitchFamily="34" charset="-120"/>
-              </a:rPr>
-              <a:t>“Their case studies are marketing.”</a:t>
-            </a:r>
-            <a:endParaRPr lang="en-US" sz="1600" dirty="0"/>
-          </a:p>
-        </p:txBody>
-      </p:sp>
-      <p:sp>
-        <p:nvSpPr>
-          <p:cNvPr id="12" name="Text 8"/>
-          <p:cNvSpPr/>
-          <p:nvPr/>
-        </p:nvSpPr>
-        <p:spPr>
-          <a:xfrm>
-            <a:off x="7269480" y="2029968"/>
-            <a:ext cx="4160520" cy="1463040"/>
-          </a:xfrm>
-          <a:prstGeom prst="rect">
-            <a:avLst/>
-          </a:prstGeom>
-          <a:noFill/>
-          <a:ln/>
-        </p:spPr>
-        <p:txBody>
-          <a:bodyPr wrap="square" lIns="0" tIns="0" rIns="0" bIns="0" rtlCol="0" anchor="ctr"/>
-          <a:lstStyle/>
-          <a:p>
-            <a:pPr indent="0" marL="0">
-              <a:buNone/>
-            </a:pPr>
-            <a:r>
-              <a:rPr lang="en-US" sz="1200" dirty="0">
-                <a:solidFill>
-                  <a:srgbClr val="2A2A2A"/>
-                </a:solidFill>
-                <a:latin typeface="Arial" pitchFamily="34" charset="0"/>
-                <a:ea typeface="Arial" pitchFamily="34" charset="-122"/>
-                <a:cs typeface="Arial" pitchFamily="34" charset="-120"/>
-              </a:rPr>
-              <a:t>Correct. Titan Roofing &amp; Restoration and others on their site are vendor-published, no audited numbers. That's exactly why the pilot has our own scorecard — we trust our data, not theirs.</a:t>
-            </a:r>
-            <a:endParaRPr lang="en-US" sz="1200" dirty="0"/>
-          </a:p>
-        </p:txBody>
-      </p:sp>
-      <p:sp>
-        <p:nvSpPr>
-          <p:cNvPr id="13" name="Shape 9"/>
-          <p:cNvSpPr/>
-          <p:nvPr/>
-        </p:nvSpPr>
-        <p:spPr>
-          <a:xfrm>
-            <a:off x="548640" y="3794760"/>
-            <a:ext cx="5394960" cy="2194560"/>
-          </a:xfrm>
-          <a:prstGeom prst="roundRect">
-            <a:avLst>
-              <a:gd name="adj" fmla="val 3333"/>
-            </a:avLst>
-          </a:prstGeom>
-          <a:solidFill>
-            <a:srgbClr val="F5F5F5"/>
-          </a:solidFill>
-          <a:ln/>
-        </p:spPr>
-      </p:sp>
-      <p:sp>
-        <p:nvSpPr>
-          <p:cNvPr id="14" name="Shape 10"/>
-          <p:cNvSpPr/>
-          <p:nvPr/>
-        </p:nvSpPr>
-        <p:spPr>
-          <a:xfrm>
-            <a:off x="822960" y="4069080"/>
-            <a:ext cx="594360" cy="594360"/>
-          </a:xfrm>
-          <a:prstGeom prst="ellipse">
-            <a:avLst/>
-          </a:prstGeom>
-          <a:solidFill>
-            <a:srgbClr val="C8102E"/>
-          </a:solidFill>
-          <a:ln/>
-        </p:spPr>
-      </p:sp>
-      <p:pic>
-        <p:nvPicPr>
-          <p:cNvPr id="15" name="Image 2" descr="preencoded.png">    </p:cNvPr>
-          <p:cNvPicPr>
-            <a:picLocks noChangeAspect="1"/>
-          </p:cNvPicPr>
-          <p:nvPr/>
-        </p:nvPicPr>
-        <p:blipFill>
-          <a:blip r:embed="rId3"/>
-          <a:stretch>
-            <a:fillRect/>
-          </a:stretch>
-        </p:blipFill>
-        <p:spPr>
-          <a:xfrm>
-            <a:off x="977494" y="4223614"/>
-            <a:ext cx="285293" cy="285293"/>
-          </a:xfrm>
-          <a:prstGeom prst="rect">
-            <a:avLst/>
-          </a:prstGeom>
-        </p:spPr>
-      </p:pic>
-      <p:sp>
-        <p:nvSpPr>
-          <p:cNvPr id="16" name="Text 11"/>
-          <p:cNvSpPr/>
-          <p:nvPr/>
-        </p:nvSpPr>
-        <p:spPr>
-          <a:xfrm>
-            <a:off x="1600200" y="4050792"/>
-            <a:ext cx="4160520" cy="365760"/>
-          </a:xfrm>
-          <a:prstGeom prst="rect">
-            <a:avLst/>
-          </a:prstGeom>
-          <a:noFill/>
-          <a:ln/>
-        </p:spPr>
-        <p:txBody>
-          <a:bodyPr wrap="square" lIns="0" tIns="0" rIns="0" bIns="0" rtlCol="0" anchor="ctr"/>
-          <a:lstStyle/>
-          <a:p>
-            <a:pPr indent="0" marL="0">
-              <a:buNone/>
-            </a:pPr>
-            <a:r>
-              <a:rPr lang="en-US" sz="1600" b="1" dirty="0">
-                <a:solidFill>
-                  <a:srgbClr val="C8102E"/>
-                </a:solidFill>
-                <a:latin typeface="Arial" pitchFamily="34" charset="0"/>
-                <a:ea typeface="Arial" pitchFamily="34" charset="-122"/>
-                <a:cs typeface="Arial" pitchFamily="34" charset="-120"/>
-              </a:rPr>
-              <a:t>“Is the damage data real?”</a:t>
-            </a:r>
-            <a:endParaRPr lang="en-US" sz="1600" dirty="0"/>
-          </a:p>
-        </p:txBody>
-      </p:sp>
-      <p:sp>
-        <p:nvSpPr>
-          <p:cNvPr id="17" name="Text 12"/>
-          <p:cNvSpPr/>
-          <p:nvPr/>
-        </p:nvSpPr>
-        <p:spPr>
-          <a:xfrm>
-            <a:off x="1600200" y="4453128"/>
-            <a:ext cx="4160520" cy="1463040"/>
-          </a:xfrm>
-          <a:prstGeom prst="rect">
-            <a:avLst/>
-          </a:prstGeom>
-          <a:noFill/>
-          <a:ln/>
-        </p:spPr>
-        <p:txBody>
-          <a:bodyPr wrap="square" lIns="0" tIns="0" rIns="0" bIns="0" rtlCol="0" anchor="ctr"/>
-          <a:lstStyle/>
-          <a:p>
-            <a:pPr indent="0" marL="0">
-              <a:buNone/>
-            </a:pPr>
-            <a:r>
-              <a:rPr lang="en-US" sz="1200" dirty="0">
-                <a:solidFill>
-                  <a:srgbClr val="2A2A2A"/>
-                </a:solidFill>
-                <a:latin typeface="Arial" pitchFamily="34" charset="0"/>
-                <a:ea typeface="Arial" pitchFamily="34" charset="-122"/>
-                <a:cs typeface="Arial" pitchFamily="34" charset="-120"/>
-              </a:rPr>
-              <a:t>We verify it ourselves: weeks 1–2, every map-flagged roof a rep inspects gets logged confirmed/not confirmed. Below 70% accuracy, the tool dies on that metric alone.</a:t>
-            </a:r>
-            <a:endParaRPr lang="en-US" sz="1200" dirty="0"/>
-          </a:p>
-        </p:txBody>
-      </p:sp>
-      <p:sp>
-        <p:nvSpPr>
-          <p:cNvPr id="18" name="Shape 13"/>
-          <p:cNvSpPr/>
-          <p:nvPr/>
-        </p:nvSpPr>
-        <p:spPr>
-          <a:xfrm>
-            <a:off x="6217920" y="3794760"/>
-            <a:ext cx="5394960" cy="2194560"/>
-          </a:xfrm>
-          <a:prstGeom prst="roundRect">
-            <a:avLst>
-              <a:gd name="adj" fmla="val 3333"/>
-            </a:avLst>
-          </a:prstGeom>
-          <a:solidFill>
-            <a:srgbClr val="F5F5F5"/>
-          </a:solidFill>
-          <a:ln/>
-        </p:spPr>
-      </p:sp>
-      <p:sp>
-        <p:nvSpPr>
-          <p:cNvPr id="19" name="Shape 14"/>
-          <p:cNvSpPr/>
-          <p:nvPr/>
-        </p:nvSpPr>
-        <p:spPr>
-          <a:xfrm>
-            <a:off x="6492240" y="4069080"/>
-            <a:ext cx="594360" cy="594360"/>
-          </a:xfrm>
-          <a:prstGeom prst="ellipse">
-            <a:avLst/>
-          </a:prstGeom>
-          <a:solidFill>
-            <a:srgbClr val="C8102E"/>
-          </a:solidFill>
-          <a:ln/>
-        </p:spPr>
-      </p:sp>
-      <p:pic>
-        <p:nvPicPr>
-          <p:cNvPr id="20" name="Image 3" descr="preencoded.png">    </p:cNvPr>
-          <p:cNvPicPr>
-            <a:picLocks noChangeAspect="1"/>
-          </p:cNvPicPr>
-          <p:nvPr/>
-        </p:nvPicPr>
-        <p:blipFill>
-          <a:blip r:embed="rId4"/>
-          <a:stretch>
-            <a:fillRect/>
-          </a:stretch>
-        </p:blipFill>
-        <p:spPr>
-          <a:xfrm>
-            <a:off x="6646774" y="4223614"/>
-            <a:ext cx="285293" cy="285293"/>
-          </a:xfrm>
-          <a:prstGeom prst="rect">
-            <a:avLst/>
-          </a:prstGeom>
-        </p:spPr>
-      </p:pic>
-      <p:sp>
-        <p:nvSpPr>
-          <p:cNvPr id="21" name="Text 15"/>
-          <p:cNvSpPr/>
-          <p:nvPr/>
-        </p:nvSpPr>
-        <p:spPr>
-          <a:xfrm>
-            <a:off x="7269480" y="4050792"/>
-            <a:ext cx="4160520" cy="365760"/>
-          </a:xfrm>
-          <a:prstGeom prst="rect">
-            <a:avLst/>
-          </a:prstGeom>
-          <a:noFill/>
-          <a:ln/>
-        </p:spPr>
-        <p:txBody>
-          <a:bodyPr wrap="square" lIns="0" tIns="0" rIns="0" bIns="0" rtlCol="0" anchor="ctr"/>
-          <a:lstStyle/>
-          <a:p>
-            <a:pPr indent="0" marL="0">
-              <a:buNone/>
-            </a:pPr>
-            <a:r>
-              <a:rPr lang="en-US" sz="1600" b="1" dirty="0">
-                <a:solidFill>
-                  <a:srgbClr val="C8102E"/>
-                </a:solidFill>
-                <a:latin typeface="Arial" pitchFamily="34" charset="0"/>
-                <a:ea typeface="Arial" pitchFamily="34" charset="-122"/>
-                <a:cs typeface="Arial" pitchFamily="34" charset="-120"/>
-              </a:rPr>
-              <a:t>“Will the reps actually use it?”</a:t>
-            </a:r>
-            <a:endParaRPr lang="en-US" sz="1600" dirty="0"/>
-          </a:p>
-        </p:txBody>
-      </p:sp>
-      <p:sp>
-        <p:nvSpPr>
-          <p:cNvPr id="22" name="Text 16"/>
-          <p:cNvSpPr/>
-          <p:nvPr/>
-        </p:nvSpPr>
-        <p:spPr>
-          <a:xfrm>
-            <a:off x="7269480" y="4453128"/>
-            <a:ext cx="4160520" cy="1463040"/>
-          </a:xfrm>
-          <a:prstGeom prst="rect">
-            <a:avLst/>
-          </a:prstGeom>
-          <a:noFill/>
-          <a:ln/>
-        </p:spPr>
-        <p:txBody>
-          <a:bodyPr wrap="square" lIns="0" tIns="0" rIns="0" bIns="0" rtlCol="0" anchor="ctr"/>
-          <a:lstStyle/>
-          <a:p>
-            <a:pPr indent="0" marL="0">
-              <a:buNone/>
-            </a:pPr>
-            <a:r>
-              <a:rPr lang="en-US" sz="1200" dirty="0">
-                <a:solidFill>
-                  <a:srgbClr val="2A2A2A"/>
-                </a:solidFill>
-                <a:latin typeface="Arial" pitchFamily="34" charset="0"/>
-                <a:ea typeface="Arial" pitchFamily="34" charset="-122"/>
-                <a:cs typeface="Arial" pitchFamily="34" charset="-120"/>
-              </a:rPr>
-              <a:t>Adoption is the real risk with any tool. So it gets a named owner (Dom), the whole team trains on it day 1, and usage shows up in the weekly scorecard. Reps not working the lists is visible in the numbers within two weeks.</a:t>
-            </a:r>
-            <a:endParaRPr lang="en-US" sz="1200" dirty="0"/>
-          </a:p>
-        </p:txBody>
-      </p:sp>
-      <p:sp>
-        <p:nvSpPr>
-          <p:cNvPr id="23" name="Text 17"/>
-          <p:cNvSpPr/>
-          <p:nvPr/>
-        </p:nvSpPr>
-        <p:spPr>
-          <a:xfrm>
-            <a:off x="548640" y="6473952"/>
-            <a:ext cx="9601200" cy="274320"/>
-          </a:xfrm>
-          <a:prstGeom prst="rect">
-            <a:avLst/>
-          </a:prstGeom>
-          <a:noFill/>
-          <a:ln/>
-        </p:spPr>
-        <p:txBody>
-          <a:bodyPr wrap="square" lIns="0" tIns="0" rIns="0" bIns="0" rtlCol="0" anchor="ctr"/>
-          <a:lstStyle/>
-          <a:p>
-            <a:pPr indent="0" marL="0">
-              <a:buNone/>
-            </a:pPr>
-            <a:endParaRPr lang="en-US" sz="900" dirty="0"/>
-          </a:p>
-        </p:txBody>
-      </p:sp>
-      <p:sp>
-        <p:nvSpPr>
-          <p:cNvPr id="24" name="Text 18"/>
           <p:cNvSpPr/>
           <p:nvPr/>
         </p:nvSpPr>

</xml_diff>

<commit_message>
Replace hypothetical upside with anonymized Company A case study
The upside slide now shows real operator-reported results (name
withheld): 31 extra roofs and $627,000 revenue on $7,100 of data +
outreach over 128 selling days after a 30-day ramp, with the funnel
(3,177 called, 105 inspected, 31 signed), context (6-month-old
company, 2 dialers), the $229 cost per signed roof / 88x return, and
a T^Rock-ticket translation. Objections card updated to distinguish
operator-reported data from vendor-published case studies.

Co-Authored-By: Claude Fable 5 <noreply@anthropic.com>
Claude-Session: https://claude.ai/code/session_01Qj1b2D7LVH4xves4mfA9FY
</commit_message>
<xml_diff>
--- a/pitch/Storm-Scout-Pitch.pptx
+++ b/pitch/Storm-Scout-Pitch.pptx
@@ -3651,7 +3651,7 @@
                 <a:ea typeface="Arial" pitchFamily="34" charset="-122"/>
                 <a:cs typeface="Arial" pitchFamily="34" charset="-120"/>
               </a:rPr>
-              <a:t>Correct. Titan Roofing &amp; Restoration and others on their site are vendor-published, no audited numbers. That's exactly why the pilot has our own scorecard — we trust our data, not theirs.</a:t>
+              <a:t>The ones on their website, yes — vendor-published, no audits. Company A is different: an operator's own numbers shared with us directly. Still unaudited, which is why the proof period keeps our own scorecard.</a:t>
             </a:r>
             <a:endParaRPr lang="en-US" sz="1200" dirty="0"/>
           </a:p>
@@ -13848,7 +13848,7 @@
                 <a:ea typeface="Arial" pitchFamily="34" charset="-122"/>
                 <a:cs typeface="Arial" pitchFamily="34" charset="-120"/>
               </a:rPr>
-              <a:t>The upside, sized for a hail market</a:t>
+              <a:t>Company A: real numbers, 128 days on the system</a:t>
             </a:r>
             <a:endParaRPr lang="en-US" sz="3200" dirty="0"/>
           </a:p>
@@ -13862,7 +13862,7 @@
         </p:nvSpPr>
         <p:spPr>
           <a:xfrm>
-            <a:off x="548640" y="1097280"/>
+            <a:off x="548640" y="1078992"/>
             <a:ext cx="10881360" cy="502920"/>
           </a:xfrm>
           <a:prstGeom prst="rect">
@@ -13887,7 +13887,7 @@
                 <a:ea typeface="Arial" pitchFamily="34" charset="-122"/>
                 <a:cs typeface="Arial" pitchFamily="34" charset="-120"/>
               </a:rPr>
-              <a:t>DFW sits in one of the most hail-active corridors in the country. Scenarios for incremental roofs — jobs from verified-damage targeting we wouldn't have knocked otherwise:</a:t>
+              <a:t>A roofing company just 6 months old, running 2 dialers (a mix of VA callers and in-house), after a 30-day ramp-up. Their numbers, shared with us directly:</a:t>
             </a:r>
             <a:endParaRPr lang="en-US" sz="1500" dirty="0"/>
           </a:p>
@@ -13901,7 +13901,7 @@
         </p:nvSpPr>
         <p:spPr>
           <a:xfrm>
-            <a:off x="548640" y="1691640"/>
+            <a:off x="548640" y="1737360"/>
             <a:ext cx="3520440" cy="1691640"/>
           </a:xfrm>
           <a:prstGeom prst="roundRect">
@@ -13931,8 +13931,8 @@
         </p:blipFill>
         <p:spPr>
           <a:xfrm>
-            <a:off x="822960" y="1920240"/>
-            <a:ext cx="502920" cy="502920"/>
+            <a:off x="822960" y="1938528"/>
+            <a:ext cx="457200" cy="457200"/>
           </a:xfrm>
           <a:prstGeom prst="rect">
             <a:avLst/>
@@ -13947,8 +13947,8 @@
         </p:nvSpPr>
         <p:spPr>
           <a:xfrm>
-            <a:off x="1463040" y="2011680"/>
-            <a:ext cx="2468880" cy="320040"/>
+            <a:off x="1463040" y="1810512"/>
+            <a:ext cx="2514600" cy="731520"/>
           </a:xfrm>
           <a:prstGeom prst="rect">
             <a:avLst/>
@@ -13964,7 +13964,7 @@
               <a:buNone/>
             </a:pPr>
             <a:r>
-              <a:rPr lang="en-US" sz="1200" b="1" dirty="0">
+              <a:rPr lang="en-US" sz="3400" b="1" dirty="0">
                 <a:solidFill>
                   <a:srgbClr val="C8102E"/>
                 </a:solidFill>
@@ -13972,9 +13972,9 @@
                 <a:ea typeface="Arial" pitchFamily="34" charset="-122"/>
                 <a:cs typeface="Arial" pitchFamily="34" charset="-120"/>
               </a:rPr>
-              <a:t>CONSERVATIVE</a:t>
-            </a:r>
-            <a:endParaRPr lang="en-US" sz="1200" dirty="0"/>
+              <a:t>31</a:t>
+            </a:r>
+            <a:endParaRPr lang="en-US" sz="3400" dirty="0"/>
           </a:p>
         </p:txBody>
       </p:sp>
@@ -13986,8 +13986,8 @@
         </p:nvSpPr>
         <p:spPr>
           <a:xfrm>
-            <a:off x="822960" y="2377440"/>
-            <a:ext cx="1188720" cy="685800"/>
+            <a:off x="822960" y="2606040"/>
+            <a:ext cx="2971800" cy="731520"/>
           </a:xfrm>
           <a:prstGeom prst="rect">
             <a:avLst/>
@@ -14003,68 +14003,29 @@
               <a:buNone/>
             </a:pPr>
             <a:r>
-              <a:rPr lang="en-US" sz="4000" b="1" dirty="0">
-                <a:solidFill>
-                  <a:srgbClr val="111111"/>
-                </a:solidFill>
-                <a:latin typeface="Arial" pitchFamily="34" charset="0"/>
-                <a:ea typeface="Arial" pitchFamily="34" charset="-122"/>
-                <a:cs typeface="Arial" pitchFamily="34" charset="-120"/>
-              </a:rPr>
-              <a:t>8</a:t>
-            </a:r>
-            <a:endParaRPr lang="en-US" sz="4000" dirty="0"/>
-          </a:p>
-        </p:txBody>
-      </p:sp>
-      <p:sp>
-        <p:nvSpPr>
-          <p:cNvPr id="8" name="Text 5"/>
-          <p:cNvSpPr/>
-          <p:nvPr/>
-        </p:nvSpPr>
-        <p:spPr>
-          <a:xfrm>
-            <a:off x="2011680" y="2697480"/>
-            <a:ext cx="1920240" cy="274320"/>
-          </a:xfrm>
-          <a:prstGeom prst="rect">
-            <a:avLst/>
-          </a:prstGeom>
-          <a:noFill/>
-          <a:ln/>
-        </p:spPr>
-        <p:txBody>
-          <a:bodyPr wrap="square" lIns="0" tIns="0" rIns="0" bIns="0" rtlCol="0" anchor="ctr"/>
-          <a:lstStyle/>
-          <a:p>
-            <a:pPr indent="0" marL="0">
-              <a:buNone/>
-            </a:pPr>
-            <a:r>
-              <a:rPr lang="en-US" sz="1200" dirty="0">
-                <a:solidFill>
-                  <a:srgbClr val="6E6E6E"/>
-                </a:solidFill>
-                <a:latin typeface="Arial" pitchFamily="34" charset="0"/>
-                <a:ea typeface="Arial" pitchFamily="34" charset="-122"/>
-                <a:cs typeface="Arial" pitchFamily="34" charset="-120"/>
-              </a:rPr>
-              <a:t>incremental roofs / yr</a:t>
-            </a:r>
-            <a:endParaRPr lang="en-US" sz="1200" dirty="0"/>
-          </a:p>
-        </p:txBody>
-      </p:sp>
-      <p:sp>
-        <p:nvSpPr>
-          <p:cNvPr id="9" name="Shape 6"/>
-          <p:cNvSpPr/>
-          <p:nvPr/>
-        </p:nvSpPr>
-        <p:spPr>
-          <a:xfrm>
-            <a:off x="4343400" y="1691640"/>
+              <a:rPr lang="en-US" sz="1150" dirty="0">
+                <a:solidFill>
+                  <a:srgbClr val="2A2A2A"/>
+                </a:solidFill>
+                <a:latin typeface="Arial" pitchFamily="34" charset="0"/>
+                <a:ea typeface="Arial" pitchFamily="34" charset="-122"/>
+                <a:cs typeface="Arial" pitchFamily="34" charset="-120"/>
+              </a:rPr>
+              <a:t>extra roofs signed in 128 selling days</a:t>
+            </a:r>
+            <a:endParaRPr lang="en-US" sz="1150" dirty="0"/>
+          </a:p>
+        </p:txBody>
+      </p:sp>
+      <p:sp>
+        <p:nvSpPr>
+          <p:cNvPr id="8" name="Shape 5"/>
+          <p:cNvSpPr/>
+          <p:nvPr/>
+        </p:nvSpPr>
+        <p:spPr>
+          <a:xfrm>
+            <a:off x="4343400" y="1737360"/>
             <a:ext cx="3520440" cy="1691640"/>
           </a:xfrm>
           <a:prstGeom prst="roundRect">
@@ -14080,7 +14041,7 @@
       </p:sp>
       <p:pic>
         <p:nvPicPr>
-          <p:cNvPr id="10" name="Image 1" descr="preencoded.png">    </p:cNvPr>
+          <p:cNvPr id="9" name="Image 1" descr="preencoded.png">    </p:cNvPr>
           <p:cNvPicPr>
             <a:picLocks noChangeAspect="1"/>
           </p:cNvPicPr>
@@ -14094,8 +14055,8 @@
         </p:blipFill>
         <p:spPr>
           <a:xfrm>
-            <a:off x="4617720" y="1920240"/>
-            <a:ext cx="502920" cy="502920"/>
+            <a:off x="4617720" y="1938528"/>
+            <a:ext cx="457200" cy="457200"/>
           </a:xfrm>
           <a:prstGeom prst="rect">
             <a:avLst/>
@@ -14104,14 +14065,53 @@
       </p:pic>
       <p:sp>
         <p:nvSpPr>
+          <p:cNvPr id="10" name="Text 6"/>
+          <p:cNvSpPr/>
+          <p:nvPr/>
+        </p:nvSpPr>
+        <p:spPr>
+          <a:xfrm>
+            <a:off x="5257800" y="1810512"/>
+            <a:ext cx="2514600" cy="731520"/>
+          </a:xfrm>
+          <a:prstGeom prst="rect">
+            <a:avLst/>
+          </a:prstGeom>
+          <a:noFill/>
+          <a:ln/>
+        </p:spPr>
+        <p:txBody>
+          <a:bodyPr wrap="square" lIns="0" tIns="0" rIns="0" bIns="0" rtlCol="0" anchor="ctr"/>
+          <a:lstStyle/>
+          <a:p>
+            <a:pPr indent="0" marL="0">
+              <a:buNone/>
+            </a:pPr>
+            <a:r>
+              <a:rPr lang="en-US" sz="3400" b="1" dirty="0">
+                <a:solidFill>
+                  <a:srgbClr val="C8102E"/>
+                </a:solidFill>
+                <a:latin typeface="Arial" pitchFamily="34" charset="0"/>
+                <a:ea typeface="Arial" pitchFamily="34" charset="-122"/>
+                <a:cs typeface="Arial" pitchFamily="34" charset="-120"/>
+              </a:rPr>
+              <a:t>$627,000</a:t>
+            </a:r>
+            <a:endParaRPr lang="en-US" sz="3400" dirty="0"/>
+          </a:p>
+        </p:txBody>
+      </p:sp>
+      <p:sp>
+        <p:nvSpPr>
           <p:cNvPr id="11" name="Text 7"/>
           <p:cNvSpPr/>
           <p:nvPr/>
         </p:nvSpPr>
         <p:spPr>
           <a:xfrm>
-            <a:off x="5257800" y="2011680"/>
-            <a:ext cx="2468880" cy="320040"/>
+            <a:off x="4617720" y="2606040"/>
+            <a:ext cx="2971800" cy="731520"/>
           </a:xfrm>
           <a:prstGeom prst="rect">
             <a:avLst/>
@@ -14127,107 +14127,29 @@
               <a:buNone/>
             </a:pPr>
             <a:r>
-              <a:rPr lang="en-US" sz="1200" b="1" dirty="0">
-                <a:solidFill>
-                  <a:srgbClr val="C8102E"/>
-                </a:solidFill>
-                <a:latin typeface="Arial" pitchFamily="34" charset="0"/>
-                <a:ea typeface="Arial" pitchFamily="34" charset="-122"/>
-                <a:cs typeface="Arial" pitchFamily="34" charset="-120"/>
-              </a:rPr>
-              <a:t>BASE CASE</a:t>
-            </a:r>
-            <a:endParaRPr lang="en-US" sz="1200" dirty="0"/>
-          </a:p>
-        </p:txBody>
-      </p:sp>
-      <p:sp>
-        <p:nvSpPr>
-          <p:cNvPr id="12" name="Text 8"/>
-          <p:cNvSpPr/>
-          <p:nvPr/>
-        </p:nvSpPr>
-        <p:spPr>
-          <a:xfrm>
-            <a:off x="4617720" y="2377440"/>
-            <a:ext cx="1188720" cy="685800"/>
-          </a:xfrm>
-          <a:prstGeom prst="rect">
-            <a:avLst/>
-          </a:prstGeom>
-          <a:noFill/>
-          <a:ln/>
-        </p:spPr>
-        <p:txBody>
-          <a:bodyPr wrap="square" lIns="0" tIns="0" rIns="0" bIns="0" rtlCol="0" anchor="ctr"/>
-          <a:lstStyle/>
-          <a:p>
-            <a:pPr indent="0" marL="0">
-              <a:buNone/>
-            </a:pPr>
-            <a:r>
-              <a:rPr lang="en-US" sz="4000" b="1" dirty="0">
-                <a:solidFill>
-                  <a:srgbClr val="111111"/>
-                </a:solidFill>
-                <a:latin typeface="Arial" pitchFamily="34" charset="0"/>
-                <a:ea typeface="Arial" pitchFamily="34" charset="-122"/>
-                <a:cs typeface="Arial" pitchFamily="34" charset="-120"/>
-              </a:rPr>
-              <a:t>18</a:t>
-            </a:r>
-            <a:endParaRPr lang="en-US" sz="4000" dirty="0"/>
-          </a:p>
-        </p:txBody>
-      </p:sp>
-      <p:sp>
-        <p:nvSpPr>
-          <p:cNvPr id="13" name="Text 9"/>
-          <p:cNvSpPr/>
-          <p:nvPr/>
-        </p:nvSpPr>
-        <p:spPr>
-          <a:xfrm>
-            <a:off x="5806440" y="2697480"/>
-            <a:ext cx="1920240" cy="274320"/>
-          </a:xfrm>
-          <a:prstGeom prst="rect">
-            <a:avLst/>
-          </a:prstGeom>
-          <a:noFill/>
-          <a:ln/>
-        </p:spPr>
-        <p:txBody>
-          <a:bodyPr wrap="square" lIns="0" tIns="0" rIns="0" bIns="0" rtlCol="0" anchor="ctr"/>
-          <a:lstStyle/>
-          <a:p>
-            <a:pPr indent="0" marL="0">
-              <a:buNone/>
-            </a:pPr>
-            <a:r>
-              <a:rPr lang="en-US" sz="1200" dirty="0">
-                <a:solidFill>
-                  <a:srgbClr val="6E6E6E"/>
-                </a:solidFill>
-                <a:latin typeface="Arial" pitchFamily="34" charset="0"/>
-                <a:ea typeface="Arial" pitchFamily="34" charset="-122"/>
-                <a:cs typeface="Arial" pitchFamily="34" charset="-120"/>
-              </a:rPr>
-              <a:t>incremental roofs / yr</a:t>
-            </a:r>
-            <a:endParaRPr lang="en-US" sz="1200" dirty="0"/>
-          </a:p>
-        </p:txBody>
-      </p:sp>
-      <p:sp>
-        <p:nvSpPr>
-          <p:cNvPr id="14" name="Shape 10"/>
-          <p:cNvSpPr/>
-          <p:nvPr/>
-        </p:nvSpPr>
-        <p:spPr>
-          <a:xfrm>
-            <a:off x="8138160" y="1691640"/>
+              <a:rPr lang="en-US" sz="1150" dirty="0">
+                <a:solidFill>
+                  <a:srgbClr val="2A2A2A"/>
+                </a:solidFill>
+                <a:latin typeface="Arial" pitchFamily="34" charset="0"/>
+                <a:ea typeface="Arial" pitchFamily="34" charset="-122"/>
+                <a:cs typeface="Arial" pitchFamily="34" charset="-120"/>
+              </a:rPr>
+              <a:t>in extra revenue those roofs produced</a:t>
+            </a:r>
+            <a:endParaRPr lang="en-US" sz="1150" dirty="0"/>
+          </a:p>
+        </p:txBody>
+      </p:sp>
+      <p:sp>
+        <p:nvSpPr>
+          <p:cNvPr id="12" name="Shape 8"/>
+          <p:cNvSpPr/>
+          <p:nvPr/>
+        </p:nvSpPr>
+        <p:spPr>
+          <a:xfrm>
+            <a:off x="8138160" y="1737360"/>
             <a:ext cx="3520440" cy="1691640"/>
           </a:xfrm>
           <a:prstGeom prst="roundRect">
@@ -14243,7 +14165,7 @@
       </p:sp>
       <p:pic>
         <p:nvPicPr>
-          <p:cNvPr id="15" name="Image 2" descr="preencoded.png">    </p:cNvPr>
+          <p:cNvPr id="13" name="Image 2" descr="preencoded.png">    </p:cNvPr>
           <p:cNvPicPr>
             <a:picLocks noChangeAspect="1"/>
           </p:cNvPicPr>
@@ -14257,8 +14179,8 @@
         </p:blipFill>
         <p:spPr>
           <a:xfrm>
-            <a:off x="8412480" y="1920240"/>
-            <a:ext cx="502920" cy="502920"/>
+            <a:off x="8412480" y="1938528"/>
+            <a:ext cx="457200" cy="457200"/>
           </a:xfrm>
           <a:prstGeom prst="rect">
             <a:avLst/>
@@ -14267,14 +14189,14 @@
       </p:pic>
       <p:sp>
         <p:nvSpPr>
-          <p:cNvPr id="16" name="Text 11"/>
-          <p:cNvSpPr/>
-          <p:nvPr/>
-        </p:nvSpPr>
-        <p:spPr>
-          <a:xfrm>
-            <a:off x="9052560" y="2011680"/>
-            <a:ext cx="2468880" cy="320040"/>
+          <p:cNvPr id="14" name="Text 9"/>
+          <p:cNvSpPr/>
+          <p:nvPr/>
+        </p:nvSpPr>
+        <p:spPr>
+          <a:xfrm>
+            <a:off x="9052560" y="1810512"/>
+            <a:ext cx="2514600" cy="731520"/>
           </a:xfrm>
           <a:prstGeom prst="rect">
             <a:avLst/>
@@ -14290,7 +14212,7 @@
               <a:buNone/>
             </a:pPr>
             <a:r>
-              <a:rPr lang="en-US" sz="1200" b="1" dirty="0">
+              <a:rPr lang="en-US" sz="3400" b="1" dirty="0">
                 <a:solidFill>
                   <a:srgbClr val="C8102E"/>
                 </a:solidFill>
@@ -14298,7 +14220,580 @@
                 <a:ea typeface="Arial" pitchFamily="34" charset="-122"/>
                 <a:cs typeface="Arial" pitchFamily="34" charset="-120"/>
               </a:rPr>
-              <a:t>STRONG STORM YEAR</a:t>
+              <a:t>$7,100</a:t>
+            </a:r>
+            <a:endParaRPr lang="en-US" sz="3400" dirty="0"/>
+          </a:p>
+        </p:txBody>
+      </p:sp>
+      <p:sp>
+        <p:nvSpPr>
+          <p:cNvPr id="15" name="Text 10"/>
+          <p:cNvSpPr/>
+          <p:nvPr/>
+        </p:nvSpPr>
+        <p:spPr>
+          <a:xfrm>
+            <a:off x="8412480" y="2606040"/>
+            <a:ext cx="2971800" cy="731520"/>
+          </a:xfrm>
+          <a:prstGeom prst="rect">
+            <a:avLst/>
+          </a:prstGeom>
+          <a:noFill/>
+          <a:ln/>
+        </p:spPr>
+        <p:txBody>
+          <a:bodyPr wrap="square" lIns="0" tIns="0" rIns="0" bIns="0" rtlCol="0" anchor="ctr"/>
+          <a:lstStyle/>
+          <a:p>
+            <a:pPr indent="0" marL="0">
+              <a:buNone/>
+            </a:pPr>
+            <a:r>
+              <a:rPr lang="en-US" sz="1150" dirty="0">
+                <a:solidFill>
+                  <a:srgbClr val="2A2A2A"/>
+                </a:solidFill>
+                <a:latin typeface="Arial" pitchFamily="34" charset="0"/>
+                <a:ea typeface="Arial" pitchFamily="34" charset="-122"/>
+                <a:cs typeface="Arial" pitchFamily="34" charset="-120"/>
+              </a:rPr>
+              <a:t>total data + outreach cost — 1.1% of the revenue it generated</a:t>
+            </a:r>
+            <a:endParaRPr lang="en-US" sz="1150" dirty="0"/>
+          </a:p>
+        </p:txBody>
+      </p:sp>
+      <p:sp>
+        <p:nvSpPr>
+          <p:cNvPr id="16" name="Shape 11"/>
+          <p:cNvSpPr/>
+          <p:nvPr/>
+        </p:nvSpPr>
+        <p:spPr>
+          <a:xfrm>
+            <a:off x="548640" y="3657600"/>
+            <a:ext cx="3291840" cy="1325880"/>
+          </a:xfrm>
+          <a:prstGeom prst="roundRect">
+            <a:avLst>
+              <a:gd name="adj" fmla="val 5517"/>
+            </a:avLst>
+          </a:prstGeom>
+          <a:solidFill>
+            <a:srgbClr val="F5F5F5"/>
+          </a:solidFill>
+          <a:ln/>
+        </p:spPr>
+      </p:sp>
+      <p:sp>
+        <p:nvSpPr>
+          <p:cNvPr id="17" name="Text 12"/>
+          <p:cNvSpPr/>
+          <p:nvPr/>
+        </p:nvSpPr>
+        <p:spPr>
+          <a:xfrm>
+            <a:off x="822960" y="3767328"/>
+            <a:ext cx="2743200" cy="548640"/>
+          </a:xfrm>
+          <a:prstGeom prst="rect">
+            <a:avLst/>
+          </a:prstGeom>
+          <a:noFill/>
+          <a:ln/>
+        </p:spPr>
+        <p:txBody>
+          <a:bodyPr wrap="square" lIns="0" tIns="0" rIns="0" bIns="0" rtlCol="0" anchor="ctr"/>
+          <a:lstStyle/>
+          <a:p>
+            <a:pPr indent="0" marL="0">
+              <a:buNone/>
+            </a:pPr>
+            <a:r>
+              <a:rPr lang="en-US" sz="2800" b="1" dirty="0">
+                <a:solidFill>
+                  <a:srgbClr val="C8102E"/>
+                </a:solidFill>
+                <a:latin typeface="Arial" pitchFamily="34" charset="0"/>
+                <a:ea typeface="Arial" pitchFamily="34" charset="-122"/>
+                <a:cs typeface="Arial" pitchFamily="34" charset="-120"/>
+              </a:rPr>
+              <a:t>3,177</a:t>
+            </a:r>
+            <a:endParaRPr lang="en-US" sz="2800" dirty="0"/>
+          </a:p>
+        </p:txBody>
+      </p:sp>
+      <p:sp>
+        <p:nvSpPr>
+          <p:cNvPr id="18" name="Text 13"/>
+          <p:cNvSpPr/>
+          <p:nvPr/>
+        </p:nvSpPr>
+        <p:spPr>
+          <a:xfrm>
+            <a:off x="822960" y="4315968"/>
+            <a:ext cx="2743200" cy="292608"/>
+          </a:xfrm>
+          <a:prstGeom prst="rect">
+            <a:avLst/>
+          </a:prstGeom>
+          <a:noFill/>
+          <a:ln/>
+        </p:spPr>
+        <p:txBody>
+          <a:bodyPr wrap="square" lIns="0" tIns="0" rIns="0" bIns="0" rtlCol="0" anchor="ctr"/>
+          <a:lstStyle/>
+          <a:p>
+            <a:pPr indent="0" marL="0">
+              <a:buNone/>
+            </a:pPr>
+            <a:r>
+              <a:rPr lang="en-US" sz="1250" b="1" dirty="0">
+                <a:solidFill>
+                  <a:srgbClr val="111111"/>
+                </a:solidFill>
+                <a:latin typeface="Arial" pitchFamily="34" charset="0"/>
+                <a:ea typeface="Arial" pitchFamily="34" charset="-122"/>
+                <a:cs typeface="Arial" pitchFamily="34" charset="-120"/>
+              </a:rPr>
+              <a:t>homeowners called</a:t>
+            </a:r>
+            <a:endParaRPr lang="en-US" sz="1250" dirty="0"/>
+          </a:p>
+        </p:txBody>
+      </p:sp>
+      <p:sp>
+        <p:nvSpPr>
+          <p:cNvPr id="19" name="Text 14"/>
+          <p:cNvSpPr/>
+          <p:nvPr/>
+        </p:nvSpPr>
+        <p:spPr>
+          <a:xfrm>
+            <a:off x="822960" y="4617720"/>
+            <a:ext cx="2743200" cy="292608"/>
+          </a:xfrm>
+          <a:prstGeom prst="rect">
+            <a:avLst/>
+          </a:prstGeom>
+          <a:noFill/>
+          <a:ln/>
+        </p:spPr>
+        <p:txBody>
+          <a:bodyPr wrap="square" lIns="0" tIns="0" rIns="0" bIns="0" rtlCol="0" anchor="ctr"/>
+          <a:lstStyle/>
+          <a:p>
+            <a:pPr indent="0" marL="0">
+              <a:buNone/>
+            </a:pPr>
+            <a:r>
+              <a:rPr lang="en-US" sz="1050" dirty="0">
+                <a:solidFill>
+                  <a:srgbClr val="6E6E6E"/>
+                </a:solidFill>
+                <a:latin typeface="Arial" pitchFamily="34" charset="0"/>
+                <a:ea typeface="Arial" pitchFamily="34" charset="-122"/>
+                <a:cs typeface="Arial" pitchFamily="34" charset="-120"/>
+              </a:rPr>
+              <a:t>2 dialers, verified-damage lists</a:t>
+            </a:r>
+            <a:endParaRPr lang="en-US" sz="1050" dirty="0"/>
+          </a:p>
+        </p:txBody>
+      </p:sp>
+      <p:sp>
+        <p:nvSpPr>
+          <p:cNvPr id="20" name="Text 15"/>
+          <p:cNvSpPr/>
+          <p:nvPr/>
+        </p:nvSpPr>
+        <p:spPr>
+          <a:xfrm>
+            <a:off x="3858768" y="4069080"/>
+            <a:ext cx="457200" cy="457200"/>
+          </a:xfrm>
+          <a:prstGeom prst="rect">
+            <a:avLst/>
+          </a:prstGeom>
+          <a:noFill/>
+          <a:ln/>
+        </p:spPr>
+        <p:txBody>
+          <a:bodyPr wrap="square" lIns="0" tIns="0" rIns="0" bIns="0" rtlCol="0" anchor="ctr"/>
+          <a:lstStyle/>
+          <a:p>
+            <a:pPr algn="ctr" indent="0" marL="0">
+              <a:buNone/>
+            </a:pPr>
+            <a:r>
+              <a:rPr lang="en-US" sz="2200" b="1" dirty="0">
+                <a:solidFill>
+                  <a:srgbClr val="C8102E"/>
+                </a:solidFill>
+                <a:latin typeface="Arial" pitchFamily="34" charset="0"/>
+                <a:ea typeface="Arial" pitchFamily="34" charset="-122"/>
+                <a:cs typeface="Arial" pitchFamily="34" charset="-120"/>
+              </a:rPr>
+              <a:t>→</a:t>
+            </a:r>
+            <a:endParaRPr lang="en-US" sz="2200" dirty="0"/>
+          </a:p>
+        </p:txBody>
+      </p:sp>
+      <p:sp>
+        <p:nvSpPr>
+          <p:cNvPr id="21" name="Shape 16"/>
+          <p:cNvSpPr/>
+          <p:nvPr/>
+        </p:nvSpPr>
+        <p:spPr>
+          <a:xfrm>
+            <a:off x="4343400" y="3657600"/>
+            <a:ext cx="3291840" cy="1325880"/>
+          </a:xfrm>
+          <a:prstGeom prst="roundRect">
+            <a:avLst>
+              <a:gd name="adj" fmla="val 5517"/>
+            </a:avLst>
+          </a:prstGeom>
+          <a:solidFill>
+            <a:srgbClr val="F5F5F5"/>
+          </a:solidFill>
+          <a:ln/>
+        </p:spPr>
+      </p:sp>
+      <p:sp>
+        <p:nvSpPr>
+          <p:cNvPr id="22" name="Text 17"/>
+          <p:cNvSpPr/>
+          <p:nvPr/>
+        </p:nvSpPr>
+        <p:spPr>
+          <a:xfrm>
+            <a:off x="4617720" y="3767328"/>
+            <a:ext cx="2743200" cy="548640"/>
+          </a:xfrm>
+          <a:prstGeom prst="rect">
+            <a:avLst/>
+          </a:prstGeom>
+          <a:noFill/>
+          <a:ln/>
+        </p:spPr>
+        <p:txBody>
+          <a:bodyPr wrap="square" lIns="0" tIns="0" rIns="0" bIns="0" rtlCol="0" anchor="ctr"/>
+          <a:lstStyle/>
+          <a:p>
+            <a:pPr indent="0" marL="0">
+              <a:buNone/>
+            </a:pPr>
+            <a:r>
+              <a:rPr lang="en-US" sz="2800" b="1" dirty="0">
+                <a:solidFill>
+                  <a:srgbClr val="C8102E"/>
+                </a:solidFill>
+                <a:latin typeface="Arial" pitchFamily="34" charset="0"/>
+                <a:ea typeface="Arial" pitchFamily="34" charset="-122"/>
+                <a:cs typeface="Arial" pitchFamily="34" charset="-120"/>
+              </a:rPr>
+              <a:t>105</a:t>
+            </a:r>
+            <a:endParaRPr lang="en-US" sz="2800" dirty="0"/>
+          </a:p>
+        </p:txBody>
+      </p:sp>
+      <p:sp>
+        <p:nvSpPr>
+          <p:cNvPr id="23" name="Text 18"/>
+          <p:cNvSpPr/>
+          <p:nvPr/>
+        </p:nvSpPr>
+        <p:spPr>
+          <a:xfrm>
+            <a:off x="4617720" y="4315968"/>
+            <a:ext cx="2743200" cy="292608"/>
+          </a:xfrm>
+          <a:prstGeom prst="rect">
+            <a:avLst/>
+          </a:prstGeom>
+          <a:noFill/>
+          <a:ln/>
+        </p:spPr>
+        <p:txBody>
+          <a:bodyPr wrap="square" lIns="0" tIns="0" rIns="0" bIns="0" rtlCol="0" anchor="ctr"/>
+          <a:lstStyle/>
+          <a:p>
+            <a:pPr indent="0" marL="0">
+              <a:buNone/>
+            </a:pPr>
+            <a:r>
+              <a:rPr lang="en-US" sz="1250" b="1" dirty="0">
+                <a:solidFill>
+                  <a:srgbClr val="111111"/>
+                </a:solidFill>
+                <a:latin typeface="Arial" pitchFamily="34" charset="0"/>
+                <a:ea typeface="Arial" pitchFamily="34" charset="-122"/>
+                <a:cs typeface="Arial" pitchFamily="34" charset="-120"/>
+              </a:rPr>
+              <a:t>inspections booked</a:t>
+            </a:r>
+            <a:endParaRPr lang="en-US" sz="1250" dirty="0"/>
+          </a:p>
+        </p:txBody>
+      </p:sp>
+      <p:sp>
+        <p:nvSpPr>
+          <p:cNvPr id="24" name="Text 19"/>
+          <p:cNvSpPr/>
+          <p:nvPr/>
+        </p:nvSpPr>
+        <p:spPr>
+          <a:xfrm>
+            <a:off x="4617720" y="4617720"/>
+            <a:ext cx="2743200" cy="292608"/>
+          </a:xfrm>
+          <a:prstGeom prst="rect">
+            <a:avLst/>
+          </a:prstGeom>
+          <a:noFill/>
+          <a:ln/>
+        </p:spPr>
+        <p:txBody>
+          <a:bodyPr wrap="square" lIns="0" tIns="0" rIns="0" bIns="0" rtlCol="0" anchor="ctr"/>
+          <a:lstStyle/>
+          <a:p>
+            <a:pPr indent="0" marL="0">
+              <a:buNone/>
+            </a:pPr>
+            <a:r>
+              <a:rPr lang="en-US" sz="1050" dirty="0">
+                <a:solidFill>
+                  <a:srgbClr val="6E6E6E"/>
+                </a:solidFill>
+                <a:latin typeface="Arial" pitchFamily="34" charset="0"/>
+                <a:ea typeface="Arial" pitchFamily="34" charset="-122"/>
+                <a:cs typeface="Arial" pitchFamily="34" charset="-120"/>
+              </a:rPr>
+              <a:t>3.3% of calls</a:t>
+            </a:r>
+            <a:endParaRPr lang="en-US" sz="1050" dirty="0"/>
+          </a:p>
+        </p:txBody>
+      </p:sp>
+      <p:sp>
+        <p:nvSpPr>
+          <p:cNvPr id="25" name="Text 20"/>
+          <p:cNvSpPr/>
+          <p:nvPr/>
+        </p:nvSpPr>
+        <p:spPr>
+          <a:xfrm>
+            <a:off x="7653528" y="4069080"/>
+            <a:ext cx="457200" cy="457200"/>
+          </a:xfrm>
+          <a:prstGeom prst="rect">
+            <a:avLst/>
+          </a:prstGeom>
+          <a:noFill/>
+          <a:ln/>
+        </p:spPr>
+        <p:txBody>
+          <a:bodyPr wrap="square" lIns="0" tIns="0" rIns="0" bIns="0" rtlCol="0" anchor="ctr"/>
+          <a:lstStyle/>
+          <a:p>
+            <a:pPr algn="ctr" indent="0" marL="0">
+              <a:buNone/>
+            </a:pPr>
+            <a:r>
+              <a:rPr lang="en-US" sz="2200" b="1" dirty="0">
+                <a:solidFill>
+                  <a:srgbClr val="C8102E"/>
+                </a:solidFill>
+                <a:latin typeface="Arial" pitchFamily="34" charset="0"/>
+                <a:ea typeface="Arial" pitchFamily="34" charset="-122"/>
+                <a:cs typeface="Arial" pitchFamily="34" charset="-120"/>
+              </a:rPr>
+              <a:t>→</a:t>
+            </a:r>
+            <a:endParaRPr lang="en-US" sz="2200" dirty="0"/>
+          </a:p>
+        </p:txBody>
+      </p:sp>
+      <p:sp>
+        <p:nvSpPr>
+          <p:cNvPr id="26" name="Shape 21"/>
+          <p:cNvSpPr/>
+          <p:nvPr/>
+        </p:nvSpPr>
+        <p:spPr>
+          <a:xfrm>
+            <a:off x="8138160" y="3657600"/>
+            <a:ext cx="3291840" cy="1325880"/>
+          </a:xfrm>
+          <a:prstGeom prst="roundRect">
+            <a:avLst>
+              <a:gd name="adj" fmla="val 5517"/>
+            </a:avLst>
+          </a:prstGeom>
+          <a:solidFill>
+            <a:srgbClr val="111111"/>
+          </a:solidFill>
+          <a:ln/>
+        </p:spPr>
+      </p:sp>
+      <p:sp>
+        <p:nvSpPr>
+          <p:cNvPr id="27" name="Text 22"/>
+          <p:cNvSpPr/>
+          <p:nvPr/>
+        </p:nvSpPr>
+        <p:spPr>
+          <a:xfrm>
+            <a:off x="8412480" y="3767328"/>
+            <a:ext cx="2743200" cy="548640"/>
+          </a:xfrm>
+          <a:prstGeom prst="rect">
+            <a:avLst/>
+          </a:prstGeom>
+          <a:noFill/>
+          <a:ln/>
+        </p:spPr>
+        <p:txBody>
+          <a:bodyPr wrap="square" lIns="0" tIns="0" rIns="0" bIns="0" rtlCol="0" anchor="ctr"/>
+          <a:lstStyle/>
+          <a:p>
+            <a:pPr indent="0" marL="0">
+              <a:buNone/>
+            </a:pPr>
+            <a:r>
+              <a:rPr lang="en-US" sz="2800" b="1" dirty="0">
+                <a:solidFill>
+                  <a:srgbClr val="C8102E"/>
+                </a:solidFill>
+                <a:latin typeface="Arial" pitchFamily="34" charset="0"/>
+                <a:ea typeface="Arial" pitchFamily="34" charset="-122"/>
+                <a:cs typeface="Arial" pitchFamily="34" charset="-120"/>
+              </a:rPr>
+              <a:t>31</a:t>
+            </a:r>
+            <a:endParaRPr lang="en-US" sz="2800" dirty="0"/>
+          </a:p>
+        </p:txBody>
+      </p:sp>
+      <p:sp>
+        <p:nvSpPr>
+          <p:cNvPr id="28" name="Text 23"/>
+          <p:cNvSpPr/>
+          <p:nvPr/>
+        </p:nvSpPr>
+        <p:spPr>
+          <a:xfrm>
+            <a:off x="8412480" y="4315968"/>
+            <a:ext cx="2743200" cy="292608"/>
+          </a:xfrm>
+          <a:prstGeom prst="rect">
+            <a:avLst/>
+          </a:prstGeom>
+          <a:noFill/>
+          <a:ln/>
+        </p:spPr>
+        <p:txBody>
+          <a:bodyPr wrap="square" lIns="0" tIns="0" rIns="0" bIns="0" rtlCol="0" anchor="ctr"/>
+          <a:lstStyle/>
+          <a:p>
+            <a:pPr indent="0" marL="0">
+              <a:buNone/>
+            </a:pPr>
+            <a:r>
+              <a:rPr lang="en-US" sz="1250" b="1" dirty="0">
+                <a:solidFill>
+                  <a:srgbClr val="FFFFFF"/>
+                </a:solidFill>
+                <a:latin typeface="Arial" pitchFamily="34" charset="0"/>
+                <a:ea typeface="Arial" pitchFamily="34" charset="-122"/>
+                <a:cs typeface="Arial" pitchFamily="34" charset="-120"/>
+              </a:rPr>
+              <a:t>contracts signed</a:t>
+            </a:r>
+            <a:endParaRPr lang="en-US" sz="1250" dirty="0"/>
+          </a:p>
+        </p:txBody>
+      </p:sp>
+      <p:sp>
+        <p:nvSpPr>
+          <p:cNvPr id="29" name="Text 24"/>
+          <p:cNvSpPr/>
+          <p:nvPr/>
+        </p:nvSpPr>
+        <p:spPr>
+          <a:xfrm>
+            <a:off x="8412480" y="4617720"/>
+            <a:ext cx="2743200" cy="292608"/>
+          </a:xfrm>
+          <a:prstGeom prst="rect">
+            <a:avLst/>
+          </a:prstGeom>
+          <a:noFill/>
+          <a:ln/>
+        </p:spPr>
+        <p:txBody>
+          <a:bodyPr wrap="square" lIns="0" tIns="0" rIns="0" bIns="0" rtlCol="0" anchor="ctr"/>
+          <a:lstStyle/>
+          <a:p>
+            <a:pPr indent="0" marL="0">
+              <a:buNone/>
+            </a:pPr>
+            <a:r>
+              <a:rPr lang="en-US" sz="1050" dirty="0">
+                <a:solidFill>
+                  <a:srgbClr val="CFCFCF"/>
+                </a:solidFill>
+                <a:latin typeface="Arial" pitchFamily="34" charset="0"/>
+                <a:ea typeface="Arial" pitchFamily="34" charset="-122"/>
+                <a:cs typeface="Arial" pitchFamily="34" charset="-120"/>
+              </a:rPr>
+              <a:t>29.5% of inspections</a:t>
+            </a:r>
+            <a:endParaRPr lang="en-US" sz="1050" dirty="0"/>
+          </a:p>
+        </p:txBody>
+      </p:sp>
+      <p:sp>
+        <p:nvSpPr>
+          <p:cNvPr id="30" name="Text 25"/>
+          <p:cNvSpPr/>
+          <p:nvPr/>
+        </p:nvSpPr>
+        <p:spPr>
+          <a:xfrm>
+            <a:off x="548640" y="5047488"/>
+            <a:ext cx="11064240" cy="438912"/>
+          </a:xfrm>
+          <a:prstGeom prst="rect">
+            <a:avLst/>
+          </a:prstGeom>
+          <a:noFill/>
+          <a:ln/>
+        </p:spPr>
+        <p:txBody>
+          <a:bodyPr wrap="square" lIns="0" tIns="0" rIns="0" bIns="0" rtlCol="0" anchor="ctr"/>
+          <a:lstStyle/>
+          <a:p>
+            <a:pPr indent="0" marL="0">
+              <a:buNone/>
+            </a:pPr>
+            <a:r>
+              <a:rPr lang="en-US" sz="1200" i="1" dirty="0">
+                <a:solidFill>
+                  <a:srgbClr val="2A2A2A"/>
+                </a:solidFill>
+                <a:latin typeface="Arial" pitchFamily="34" charset="0"/>
+                <a:ea typeface="Arial" pitchFamily="34" charset="-122"/>
+                <a:cs typeface="Arial" pitchFamily="34" charset="-120"/>
+              </a:rPr>
+              <a:t>Their average ticket: ~$20,200. The same 31 roofs at T^Rock's $30,000 ticket ≈ $930,000 revenue — ~$159,000 net to T^Rock.</a:t>
             </a:r>
             <a:endParaRPr lang="en-US" sz="1200" dirty="0"/>
           </a:p>
@@ -14306,1705 +14801,7 @@
       </p:sp>
       <p:sp>
         <p:nvSpPr>
-          <p:cNvPr id="17" name="Text 12"/>
-          <p:cNvSpPr/>
-          <p:nvPr/>
-        </p:nvSpPr>
-        <p:spPr>
-          <a:xfrm>
-            <a:off x="8412480" y="2377440"/>
-            <a:ext cx="1188720" cy="685800"/>
-          </a:xfrm>
-          <a:prstGeom prst="rect">
-            <a:avLst/>
-          </a:prstGeom>
-          <a:noFill/>
-          <a:ln/>
-        </p:spPr>
-        <p:txBody>
-          <a:bodyPr wrap="square" lIns="0" tIns="0" rIns="0" bIns="0" rtlCol="0" anchor="ctr"/>
-          <a:lstStyle/>
-          <a:p>
-            <a:pPr indent="0" marL="0">
-              <a:buNone/>
-            </a:pPr>
-            <a:r>
-              <a:rPr lang="en-US" sz="4000" b="1" dirty="0">
-                <a:solidFill>
-                  <a:srgbClr val="111111"/>
-                </a:solidFill>
-                <a:latin typeface="Arial" pitchFamily="34" charset="0"/>
-                <a:ea typeface="Arial" pitchFamily="34" charset="-122"/>
-                <a:cs typeface="Arial" pitchFamily="34" charset="-120"/>
-              </a:rPr>
-              <a:t>30</a:t>
-            </a:r>
-            <a:endParaRPr lang="en-US" sz="4000" dirty="0"/>
-          </a:p>
-        </p:txBody>
-      </p:sp>
-      <p:sp>
-        <p:nvSpPr>
-          <p:cNvPr id="18" name="Text 13"/>
-          <p:cNvSpPr/>
-          <p:nvPr/>
-        </p:nvSpPr>
-        <p:spPr>
-          <a:xfrm>
-            <a:off x="9601200" y="2697480"/>
-            <a:ext cx="1920240" cy="274320"/>
-          </a:xfrm>
-          <a:prstGeom prst="rect">
-            <a:avLst/>
-          </a:prstGeom>
-          <a:noFill/>
-          <a:ln/>
-        </p:spPr>
-        <p:txBody>
-          <a:bodyPr wrap="square" lIns="0" tIns="0" rIns="0" bIns="0" rtlCol="0" anchor="ctr"/>
-          <a:lstStyle/>
-          <a:p>
-            <a:pPr indent="0" marL="0">
-              <a:buNone/>
-            </a:pPr>
-            <a:r>
-              <a:rPr lang="en-US" sz="1200" dirty="0">
-                <a:solidFill>
-                  <a:srgbClr val="6E6E6E"/>
-                </a:solidFill>
-                <a:latin typeface="Arial" pitchFamily="34" charset="0"/>
-                <a:ea typeface="Arial" pitchFamily="34" charset="-122"/>
-                <a:cs typeface="Arial" pitchFamily="34" charset="-120"/>
-              </a:rPr>
-              <a:t>incremental roofs / yr</a:t>
-            </a:r>
-            <a:endParaRPr lang="en-US" sz="1200" dirty="0"/>
-          </a:p>
-        </p:txBody>
-      </p:sp>
-      <p:graphicFrame>
-        <p:nvGraphicFramePr>
-          <p:cNvPr id="10" name="Table 0"/>
-          <p:cNvGraphicFramePr>
-            <a:graphicFrameLocks noGrp="1"/>
-          </p:cNvGraphicFramePr>
-          <p:nvPr>
-            <p:extLst>
-              <p:ext uri="{D42A27DB-BD31-4B8C-83A1-F6EECF244321}">
-                <p14:modId xmlns:p14="http://schemas.microsoft.com/office/powerpoint/2010/main" val="1579011935"/>
-              </p:ext>
-            </p:extLst>
-          </p:nvPr>
-        </p:nvGraphicFramePr>
-        <p:xfrm>
-          <a:off x="548640" y="3611880"/>
-          <a:ext cx="11064240" cy="914400"/>
-        </p:xfrm>
-        <a:graphic>
-          <a:graphicData uri="http://schemas.openxmlformats.org/drawingml/2006/table">
-            <a:tbl>
-              <a:tblPr/>
-              <a:tblGrid>
-                <a:gridCol w="1005840"/>
-                <a:gridCol w="2148840"/>
-                <a:gridCol w="2011680"/>
-                <a:gridCol w="2011680"/>
-                <a:gridCol w="1965960"/>
-                <a:gridCol w="1920240"/>
-              </a:tblGrid>
-              <a:tr h="457200">
-                <a:tc>
-                  <a:txBody>
-                    <a:bodyPr/>
-                    <a:lstStyle/>
-                    <a:p>
-                      <a:pPr algn="ctr" indent="0" marL="0">
-                        <a:buNone/>
-                      </a:pPr>
-                      <a:r>
-                        <a:rPr lang="en-US" sz="1150" b="1" dirty="0">
-                          <a:solidFill>
-                            <a:srgbClr val="FFFFFF"/>
-                          </a:solidFill>
-                          <a:latin typeface="Arial" pitchFamily="34" charset="0"/>
-                          <a:ea typeface="Arial" pitchFamily="34" charset="-122"/>
-                          <a:cs typeface="Arial" pitchFamily="34" charset="-120"/>
-                        </a:rPr>
-                        <a:t>Roofs</a:t>
-                      </a:r>
-                      <a:endParaRPr lang="en-US" sz="1150" dirty="0">
-                        <a:latin typeface="Arial" charset="0"/>
-                        <a:ea typeface="Arial" charset="0"/>
-                        <a:cs typeface="Arial" charset="0"/>
-                      </a:endParaRPr>
-                    </a:p>
-                  </a:txBody>
-                  <a:tcPr marL="54864" marR="54864" marT="54864" marB="54864" anchor="ctr">
-                    <a:lnL w="9525" cap="flat" cmpd="sng" algn="ctr">
-                      <a:solidFill>
-                        <a:srgbClr val="DDDDDD"/>
-                      </a:solidFill>
-                      <a:prstDash val="solid"/>
-                      <a:round/>
-                      <a:headEnd type="none" w="med" len="med"/>
-                      <a:tailEnd type="none" w="med" len="med"/>
-                    </a:lnL>
-                    <a:lnR w="9525" cap="flat" cmpd="sng" algn="ctr">
-                      <a:solidFill>
-                        <a:srgbClr val="DDDDDD"/>
-                      </a:solidFill>
-                      <a:prstDash val="solid"/>
-                      <a:round/>
-                      <a:headEnd type="none" w="med" len="med"/>
-                      <a:tailEnd type="none" w="med" len="med"/>
-                    </a:lnR>
-                    <a:lnT w="9525" cap="flat" cmpd="sng" algn="ctr">
-                      <a:solidFill>
-                        <a:srgbClr val="DDDDDD"/>
-                      </a:solidFill>
-                      <a:prstDash val="solid"/>
-                      <a:round/>
-                      <a:headEnd type="none" w="med" len="med"/>
-                      <a:tailEnd type="none" w="med" len="med"/>
-                    </a:lnT>
-                    <a:lnB w="9525" cap="flat" cmpd="sng" algn="ctr">
-                      <a:solidFill>
-                        <a:srgbClr val="DDDDDD"/>
-                      </a:solidFill>
-                      <a:prstDash val="solid"/>
-                      <a:round/>
-                      <a:headEnd type="none" w="med" len="med"/>
-                      <a:tailEnd type="none" w="med" len="med"/>
-                    </a:lnB>
-                    <a:solidFill>
-                      <a:srgbClr val="111111"/>
-                    </a:solidFill>
-                  </a:tcPr>
-                </a:tc>
-                <a:tc>
-                  <a:txBody>
-                    <a:bodyPr/>
-                    <a:lstStyle/>
-                    <a:p>
-                      <a:pPr algn="ctr" indent="0" marL="0">
-                        <a:buNone/>
-                      </a:pPr>
-                      <a:r>
-                        <a:rPr lang="en-US" sz="1150" b="1" dirty="0">
-                          <a:solidFill>
-                            <a:srgbClr val="FFFFFF"/>
-                          </a:solidFill>
-                          <a:latin typeface="Arial" pitchFamily="34" charset="0"/>
-                          <a:ea typeface="Arial" pitchFamily="34" charset="-122"/>
-                          <a:cs typeface="Arial" pitchFamily="34" charset="-120"/>
-                        </a:rPr>
-                        <a:t>Revenue (× $30,000)</a:t>
-                      </a:r>
-                      <a:endParaRPr lang="en-US" sz="1150" dirty="0">
-                        <a:latin typeface="Arial" charset="0"/>
-                        <a:ea typeface="Arial" charset="0"/>
-                        <a:cs typeface="Arial" charset="0"/>
-                      </a:endParaRPr>
-                    </a:p>
-                  </a:txBody>
-                  <a:tcPr marL="54864" marR="54864" marT="54864" marB="54864" anchor="ctr">
-                    <a:lnL w="9525" cap="flat" cmpd="sng" algn="ctr">
-                      <a:solidFill>
-                        <a:srgbClr val="DDDDDD"/>
-                      </a:solidFill>
-                      <a:prstDash val="solid"/>
-                      <a:round/>
-                      <a:headEnd type="none" w="med" len="med"/>
-                      <a:tailEnd type="none" w="med" len="med"/>
-                    </a:lnL>
-                    <a:lnR w="9525" cap="flat" cmpd="sng" algn="ctr">
-                      <a:solidFill>
-                        <a:srgbClr val="DDDDDD"/>
-                      </a:solidFill>
-                      <a:prstDash val="solid"/>
-                      <a:round/>
-                      <a:headEnd type="none" w="med" len="med"/>
-                      <a:tailEnd type="none" w="med" len="med"/>
-                    </a:lnR>
-                    <a:lnT w="9525" cap="flat" cmpd="sng" algn="ctr">
-                      <a:solidFill>
-                        <a:srgbClr val="DDDDDD"/>
-                      </a:solidFill>
-                      <a:prstDash val="solid"/>
-                      <a:round/>
-                      <a:headEnd type="none" w="med" len="med"/>
-                      <a:tailEnd type="none" w="med" len="med"/>
-                    </a:lnT>
-                    <a:lnB w="9525" cap="flat" cmpd="sng" algn="ctr">
-                      <a:solidFill>
-                        <a:srgbClr val="DDDDDD"/>
-                      </a:solidFill>
-                      <a:prstDash val="solid"/>
-                      <a:round/>
-                      <a:headEnd type="none" w="med" len="med"/>
-                      <a:tailEnd type="none" w="med" len="med"/>
-                    </a:lnB>
-                    <a:solidFill>
-                      <a:srgbClr val="111111"/>
-                    </a:solidFill>
-                  </a:tcPr>
-                </a:tc>
-                <a:tc>
-                  <a:txBody>
-                    <a:bodyPr/>
-                    <a:lstStyle/>
-                    <a:p>
-                      <a:pPr algn="ctr" indent="0" marL="0">
-                        <a:buNone/>
-                      </a:pPr>
-                      <a:r>
-                        <a:rPr lang="en-US" sz="1150" b="1" dirty="0">
-                          <a:solidFill>
-                            <a:srgbClr val="FFFFFF"/>
-                          </a:solidFill>
-                          <a:latin typeface="Arial" pitchFamily="34" charset="0"/>
-                          <a:ea typeface="Arial" pitchFamily="34" charset="-122"/>
-                          <a:cs typeface="Arial" pitchFamily="34" charset="-120"/>
-                        </a:rPr>
-                        <a:t>Gross profit (35%)</a:t>
-                      </a:r>
-                      <a:endParaRPr lang="en-US" sz="1150" dirty="0">
-                        <a:latin typeface="Arial" charset="0"/>
-                        <a:ea typeface="Arial" charset="0"/>
-                        <a:cs typeface="Arial" charset="0"/>
-                      </a:endParaRPr>
-                    </a:p>
-                  </a:txBody>
-                  <a:tcPr marL="54864" marR="54864" marT="54864" marB="54864" anchor="ctr">
-                    <a:lnL w="9525" cap="flat" cmpd="sng" algn="ctr">
-                      <a:solidFill>
-                        <a:srgbClr val="DDDDDD"/>
-                      </a:solidFill>
-                      <a:prstDash val="solid"/>
-                      <a:round/>
-                      <a:headEnd type="none" w="med" len="med"/>
-                      <a:tailEnd type="none" w="med" len="med"/>
-                    </a:lnL>
-                    <a:lnR w="9525" cap="flat" cmpd="sng" algn="ctr">
-                      <a:solidFill>
-                        <a:srgbClr val="DDDDDD"/>
-                      </a:solidFill>
-                      <a:prstDash val="solid"/>
-                      <a:round/>
-                      <a:headEnd type="none" w="med" len="med"/>
-                      <a:tailEnd type="none" w="med" len="med"/>
-                    </a:lnR>
-                    <a:lnT w="9525" cap="flat" cmpd="sng" algn="ctr">
-                      <a:solidFill>
-                        <a:srgbClr val="DDDDDD"/>
-                      </a:solidFill>
-                      <a:prstDash val="solid"/>
-                      <a:round/>
-                      <a:headEnd type="none" w="med" len="med"/>
-                      <a:tailEnd type="none" w="med" len="med"/>
-                    </a:lnT>
-                    <a:lnB w="9525" cap="flat" cmpd="sng" algn="ctr">
-                      <a:solidFill>
-                        <a:srgbClr val="DDDDDD"/>
-                      </a:solidFill>
-                      <a:prstDash val="solid"/>
-                      <a:round/>
-                      <a:headEnd type="none" w="med" len="med"/>
-                      <a:tailEnd type="none" w="med" len="med"/>
-                    </a:lnB>
-                    <a:solidFill>
-                      <a:srgbClr val="111111"/>
-                    </a:solidFill>
-                  </a:tcPr>
-                </a:tc>
-                <a:tc>
-                  <a:txBody>
-                    <a:bodyPr/>
-                    <a:lstStyle/>
-                    <a:p>
-                      <a:pPr algn="ctr" indent="0" marL="0">
-                        <a:buNone/>
-                      </a:pPr>
-                      <a:r>
-                        <a:rPr lang="en-US" sz="1150" b="1" dirty="0">
-                          <a:solidFill>
-                            <a:srgbClr val="FFFFFF"/>
-                          </a:solidFill>
-                          <a:latin typeface="Arial" pitchFamily="34" charset="0"/>
-                          <a:ea typeface="Arial" pitchFamily="34" charset="-122"/>
-                          <a:cs typeface="Arial" pitchFamily="34" charset="-120"/>
-                        </a:rPr>
-                        <a:t>Lead fee (2% of profit)</a:t>
-                      </a:r>
-                      <a:endParaRPr lang="en-US" sz="1150" dirty="0">
-                        <a:latin typeface="Arial" charset="0"/>
-                        <a:ea typeface="Arial" charset="0"/>
-                        <a:cs typeface="Arial" charset="0"/>
-                      </a:endParaRPr>
-                    </a:p>
-                  </a:txBody>
-                  <a:tcPr marL="54864" marR="54864" marT="54864" marB="54864" anchor="ctr">
-                    <a:lnL w="9525" cap="flat" cmpd="sng" algn="ctr">
-                      <a:solidFill>
-                        <a:srgbClr val="DDDDDD"/>
-                      </a:solidFill>
-                      <a:prstDash val="solid"/>
-                      <a:round/>
-                      <a:headEnd type="none" w="med" len="med"/>
-                      <a:tailEnd type="none" w="med" len="med"/>
-                    </a:lnL>
-                    <a:lnR w="9525" cap="flat" cmpd="sng" algn="ctr">
-                      <a:solidFill>
-                        <a:srgbClr val="DDDDDD"/>
-                      </a:solidFill>
-                      <a:prstDash val="solid"/>
-                      <a:round/>
-                      <a:headEnd type="none" w="med" len="med"/>
-                      <a:tailEnd type="none" w="med" len="med"/>
-                    </a:lnR>
-                    <a:lnT w="9525" cap="flat" cmpd="sng" algn="ctr">
-                      <a:solidFill>
-                        <a:srgbClr val="DDDDDD"/>
-                      </a:solidFill>
-                      <a:prstDash val="solid"/>
-                      <a:round/>
-                      <a:headEnd type="none" w="med" len="med"/>
-                      <a:tailEnd type="none" w="med" len="med"/>
-                    </a:lnT>
-                    <a:lnB w="9525" cap="flat" cmpd="sng" algn="ctr">
-                      <a:solidFill>
-                        <a:srgbClr val="DDDDDD"/>
-                      </a:solidFill>
-                      <a:prstDash val="solid"/>
-                      <a:round/>
-                      <a:headEnd type="none" w="med" len="med"/>
-                      <a:tailEnd type="none" w="med" len="med"/>
-                    </a:lnB>
-                    <a:solidFill>
-                      <a:srgbClr val="111111"/>
-                    </a:solidFill>
-                  </a:tcPr>
-                </a:tc>
-                <a:tc>
-                  <a:txBody>
-                    <a:bodyPr/>
-                    <a:lstStyle/>
-                    <a:p>
-                      <a:pPr algn="ctr" indent="0" marL="0">
-                        <a:buNone/>
-                      </a:pPr>
-                      <a:r>
-                        <a:rPr lang="en-US" sz="1150" b="1" dirty="0">
-                          <a:solidFill>
-                            <a:srgbClr val="FFFFFF"/>
-                          </a:solidFill>
-                          <a:latin typeface="Arial" pitchFamily="34" charset="0"/>
-                          <a:ea typeface="Arial" pitchFamily="34" charset="-122"/>
-                          <a:cs typeface="Arial" pitchFamily="34" charset="-120"/>
-                        </a:rPr>
-                        <a:t>T^Rock half after fee</a:t>
-                      </a:r>
-                      <a:endParaRPr lang="en-US" sz="1150" dirty="0">
-                        <a:latin typeface="Arial" charset="0"/>
-                        <a:ea typeface="Arial" charset="0"/>
-                        <a:cs typeface="Arial" charset="0"/>
-                      </a:endParaRPr>
-                    </a:p>
-                  </a:txBody>
-                  <a:tcPr marL="54864" marR="54864" marT="54864" marB="54864" anchor="ctr">
-                    <a:lnL w="9525" cap="flat" cmpd="sng" algn="ctr">
-                      <a:solidFill>
-                        <a:srgbClr val="DDDDDD"/>
-                      </a:solidFill>
-                      <a:prstDash val="solid"/>
-                      <a:round/>
-                      <a:headEnd type="none" w="med" len="med"/>
-                      <a:tailEnd type="none" w="med" len="med"/>
-                    </a:lnL>
-                    <a:lnR w="9525" cap="flat" cmpd="sng" algn="ctr">
-                      <a:solidFill>
-                        <a:srgbClr val="DDDDDD"/>
-                      </a:solidFill>
-                      <a:prstDash val="solid"/>
-                      <a:round/>
-                      <a:headEnd type="none" w="med" len="med"/>
-                      <a:tailEnd type="none" w="med" len="med"/>
-                    </a:lnR>
-                    <a:lnT w="9525" cap="flat" cmpd="sng" algn="ctr">
-                      <a:solidFill>
-                        <a:srgbClr val="DDDDDD"/>
-                      </a:solidFill>
-                      <a:prstDash val="solid"/>
-                      <a:round/>
-                      <a:headEnd type="none" w="med" len="med"/>
-                      <a:tailEnd type="none" w="med" len="med"/>
-                    </a:lnT>
-                    <a:lnB w="9525" cap="flat" cmpd="sng" algn="ctr">
-                      <a:solidFill>
-                        <a:srgbClr val="DDDDDD"/>
-                      </a:solidFill>
-                      <a:prstDash val="solid"/>
-                      <a:round/>
-                      <a:headEnd type="none" w="med" len="med"/>
-                      <a:tailEnd type="none" w="med" len="med"/>
-                    </a:lnB>
-                    <a:solidFill>
-                      <a:srgbClr val="111111"/>
-                    </a:solidFill>
-                  </a:tcPr>
-                </a:tc>
-                <a:tc>
-                  <a:txBody>
-                    <a:bodyPr/>
-                    <a:lstStyle/>
-                    <a:p>
-                      <a:pPr algn="ctr" indent="0" marL="0">
-                        <a:buNone/>
-                      </a:pPr>
-                      <a:r>
-                        <a:rPr lang="en-US" sz="1150" b="1" dirty="0">
-                          <a:solidFill>
-                            <a:srgbClr val="FFFFFF"/>
-                          </a:solidFill>
-                          <a:latin typeface="Arial" pitchFamily="34" charset="0"/>
-                          <a:ea typeface="Arial" pitchFamily="34" charset="-122"/>
-                          <a:cs typeface="Arial" pitchFamily="34" charset="-120"/>
-                        </a:rPr>
-                        <a:t>Less $24,000 sub = NET</a:t>
-                      </a:r>
-                      <a:endParaRPr lang="en-US" sz="1150" dirty="0">
-                        <a:latin typeface="Arial" charset="0"/>
-                        <a:ea typeface="Arial" charset="0"/>
-                        <a:cs typeface="Arial" charset="0"/>
-                      </a:endParaRPr>
-                    </a:p>
-                  </a:txBody>
-                  <a:tcPr marL="54864" marR="54864" marT="54864" marB="54864" anchor="ctr">
-                    <a:lnL w="9525" cap="flat" cmpd="sng" algn="ctr">
-                      <a:solidFill>
-                        <a:srgbClr val="DDDDDD"/>
-                      </a:solidFill>
-                      <a:prstDash val="solid"/>
-                      <a:round/>
-                      <a:headEnd type="none" w="med" len="med"/>
-                      <a:tailEnd type="none" w="med" len="med"/>
-                    </a:lnL>
-                    <a:lnR w="9525" cap="flat" cmpd="sng" algn="ctr">
-                      <a:solidFill>
-                        <a:srgbClr val="DDDDDD"/>
-                      </a:solidFill>
-                      <a:prstDash val="solid"/>
-                      <a:round/>
-                      <a:headEnd type="none" w="med" len="med"/>
-                      <a:tailEnd type="none" w="med" len="med"/>
-                    </a:lnR>
-                    <a:lnT w="9525" cap="flat" cmpd="sng" algn="ctr">
-                      <a:solidFill>
-                        <a:srgbClr val="DDDDDD"/>
-                      </a:solidFill>
-                      <a:prstDash val="solid"/>
-                      <a:round/>
-                      <a:headEnd type="none" w="med" len="med"/>
-                      <a:tailEnd type="none" w="med" len="med"/>
-                    </a:lnT>
-                    <a:lnB w="9525" cap="flat" cmpd="sng" algn="ctr">
-                      <a:solidFill>
-                        <a:srgbClr val="DDDDDD"/>
-                      </a:solidFill>
-                      <a:prstDash val="solid"/>
-                      <a:round/>
-                      <a:headEnd type="none" w="med" len="med"/>
-                      <a:tailEnd type="none" w="med" len="med"/>
-                    </a:lnB>
-                    <a:solidFill>
-                      <a:srgbClr val="111111"/>
-                    </a:solidFill>
-                  </a:tcPr>
-                </a:tc>
-              </a:tr>
-              <a:tr h="411480">
-                <a:tc>
-                  <a:txBody>
-                    <a:bodyPr/>
-                    <a:lstStyle/>
-                    <a:p>
-                      <a:pPr algn="ctr" indent="0" marL="0">
-                        <a:buNone/>
-                      </a:pPr>
-                      <a:r>
-                        <a:rPr lang="en-US" sz="1200" dirty="0">
-                          <a:solidFill>
-                            <a:srgbClr val="2A2A2A"/>
-                          </a:solidFill>
-                          <a:latin typeface="Arial" pitchFamily="34" charset="0"/>
-                          <a:ea typeface="Arial" pitchFamily="34" charset="-122"/>
-                          <a:cs typeface="Arial" pitchFamily="34" charset="-120"/>
-                        </a:rPr>
-                        <a:t>8</a:t>
-                      </a:r>
-                      <a:endParaRPr lang="en-US" sz="1200" dirty="0">
-                        <a:latin typeface="Arial" charset="0"/>
-                        <a:ea typeface="Arial" charset="0"/>
-                        <a:cs typeface="Arial" charset="0"/>
-                      </a:endParaRPr>
-                    </a:p>
-                  </a:txBody>
-                  <a:tcPr marL="54864" marR="54864" marT="54864" marB="54864" anchor="ctr">
-                    <a:lnL w="9525" cap="flat" cmpd="sng" algn="ctr">
-                      <a:solidFill>
-                        <a:srgbClr val="DDDDDD"/>
-                      </a:solidFill>
-                      <a:prstDash val="solid"/>
-                      <a:round/>
-                      <a:headEnd type="none" w="med" len="med"/>
-                      <a:tailEnd type="none" w="med" len="med"/>
-                    </a:lnL>
-                    <a:lnR w="9525" cap="flat" cmpd="sng" algn="ctr">
-                      <a:solidFill>
-                        <a:srgbClr val="DDDDDD"/>
-                      </a:solidFill>
-                      <a:prstDash val="solid"/>
-                      <a:round/>
-                      <a:headEnd type="none" w="med" len="med"/>
-                      <a:tailEnd type="none" w="med" len="med"/>
-                    </a:lnR>
-                    <a:lnT w="9525" cap="flat" cmpd="sng" algn="ctr">
-                      <a:solidFill>
-                        <a:srgbClr val="DDDDDD"/>
-                      </a:solidFill>
-                      <a:prstDash val="solid"/>
-                      <a:round/>
-                      <a:headEnd type="none" w="med" len="med"/>
-                      <a:tailEnd type="none" w="med" len="med"/>
-                    </a:lnT>
-                    <a:lnB w="9525" cap="flat" cmpd="sng" algn="ctr">
-                      <a:solidFill>
-                        <a:srgbClr val="DDDDDD"/>
-                      </a:solidFill>
-                      <a:prstDash val="solid"/>
-                      <a:round/>
-                      <a:headEnd type="none" w="med" len="med"/>
-                      <a:tailEnd type="none" w="med" len="med"/>
-                    </a:lnB>
-                  </a:tcPr>
-                </a:tc>
-                <a:tc>
-                  <a:txBody>
-                    <a:bodyPr/>
-                    <a:lstStyle/>
-                    <a:p>
-                      <a:pPr algn="ctr" indent="0" marL="0">
-                        <a:buNone/>
-                      </a:pPr>
-                      <a:r>
-                        <a:rPr lang="en-US" sz="1200" dirty="0">
-                          <a:solidFill>
-                            <a:srgbClr val="2A2A2A"/>
-                          </a:solidFill>
-                          <a:latin typeface="Arial" pitchFamily="34" charset="0"/>
-                          <a:ea typeface="Arial" pitchFamily="34" charset="-122"/>
-                          <a:cs typeface="Arial" pitchFamily="34" charset="-120"/>
-                        </a:rPr>
-                        <a:t>$240,000</a:t>
-                      </a:r>
-                      <a:endParaRPr lang="en-US" sz="1200" dirty="0">
-                        <a:latin typeface="Arial" charset="0"/>
-                        <a:ea typeface="Arial" charset="0"/>
-                        <a:cs typeface="Arial" charset="0"/>
-                      </a:endParaRPr>
-                    </a:p>
-                  </a:txBody>
-                  <a:tcPr marL="54864" marR="54864" marT="54864" marB="54864" anchor="ctr">
-                    <a:lnL w="9525" cap="flat" cmpd="sng" algn="ctr">
-                      <a:solidFill>
-                        <a:srgbClr val="DDDDDD"/>
-                      </a:solidFill>
-                      <a:prstDash val="solid"/>
-                      <a:round/>
-                      <a:headEnd type="none" w="med" len="med"/>
-                      <a:tailEnd type="none" w="med" len="med"/>
-                    </a:lnL>
-                    <a:lnR w="9525" cap="flat" cmpd="sng" algn="ctr">
-                      <a:solidFill>
-                        <a:srgbClr val="DDDDDD"/>
-                      </a:solidFill>
-                      <a:prstDash val="solid"/>
-                      <a:round/>
-                      <a:headEnd type="none" w="med" len="med"/>
-                      <a:tailEnd type="none" w="med" len="med"/>
-                    </a:lnR>
-                    <a:lnT w="9525" cap="flat" cmpd="sng" algn="ctr">
-                      <a:solidFill>
-                        <a:srgbClr val="DDDDDD"/>
-                      </a:solidFill>
-                      <a:prstDash val="solid"/>
-                      <a:round/>
-                      <a:headEnd type="none" w="med" len="med"/>
-                      <a:tailEnd type="none" w="med" len="med"/>
-                    </a:lnT>
-                    <a:lnB w="9525" cap="flat" cmpd="sng" algn="ctr">
-                      <a:solidFill>
-                        <a:srgbClr val="DDDDDD"/>
-                      </a:solidFill>
-                      <a:prstDash val="solid"/>
-                      <a:round/>
-                      <a:headEnd type="none" w="med" len="med"/>
-                      <a:tailEnd type="none" w="med" len="med"/>
-                    </a:lnB>
-                  </a:tcPr>
-                </a:tc>
-                <a:tc>
-                  <a:txBody>
-                    <a:bodyPr/>
-                    <a:lstStyle/>
-                    <a:p>
-                      <a:pPr algn="ctr" indent="0" marL="0">
-                        <a:buNone/>
-                      </a:pPr>
-                      <a:r>
-                        <a:rPr lang="en-US" sz="1200" dirty="0">
-                          <a:solidFill>
-                            <a:srgbClr val="2A2A2A"/>
-                          </a:solidFill>
-                          <a:latin typeface="Arial" pitchFamily="34" charset="0"/>
-                          <a:ea typeface="Arial" pitchFamily="34" charset="-122"/>
-                          <a:cs typeface="Arial" pitchFamily="34" charset="-120"/>
-                        </a:rPr>
-                        <a:t>$84,000</a:t>
-                      </a:r>
-                      <a:endParaRPr lang="en-US" sz="1200" dirty="0">
-                        <a:latin typeface="Arial" charset="0"/>
-                        <a:ea typeface="Arial" charset="0"/>
-                        <a:cs typeface="Arial" charset="0"/>
-                      </a:endParaRPr>
-                    </a:p>
-                  </a:txBody>
-                  <a:tcPr marL="54864" marR="54864" marT="54864" marB="54864" anchor="ctr">
-                    <a:lnL w="9525" cap="flat" cmpd="sng" algn="ctr">
-                      <a:solidFill>
-                        <a:srgbClr val="DDDDDD"/>
-                      </a:solidFill>
-                      <a:prstDash val="solid"/>
-                      <a:round/>
-                      <a:headEnd type="none" w="med" len="med"/>
-                      <a:tailEnd type="none" w="med" len="med"/>
-                    </a:lnL>
-                    <a:lnR w="9525" cap="flat" cmpd="sng" algn="ctr">
-                      <a:solidFill>
-                        <a:srgbClr val="DDDDDD"/>
-                      </a:solidFill>
-                      <a:prstDash val="solid"/>
-                      <a:round/>
-                      <a:headEnd type="none" w="med" len="med"/>
-                      <a:tailEnd type="none" w="med" len="med"/>
-                    </a:lnR>
-                    <a:lnT w="9525" cap="flat" cmpd="sng" algn="ctr">
-                      <a:solidFill>
-                        <a:srgbClr val="DDDDDD"/>
-                      </a:solidFill>
-                      <a:prstDash val="solid"/>
-                      <a:round/>
-                      <a:headEnd type="none" w="med" len="med"/>
-                      <a:tailEnd type="none" w="med" len="med"/>
-                    </a:lnT>
-                    <a:lnB w="9525" cap="flat" cmpd="sng" algn="ctr">
-                      <a:solidFill>
-                        <a:srgbClr val="DDDDDD"/>
-                      </a:solidFill>
-                      <a:prstDash val="solid"/>
-                      <a:round/>
-                      <a:headEnd type="none" w="med" len="med"/>
-                      <a:tailEnd type="none" w="med" len="med"/>
-                    </a:lnB>
-                  </a:tcPr>
-                </a:tc>
-                <a:tc>
-                  <a:txBody>
-                    <a:bodyPr/>
-                    <a:lstStyle/>
-                    <a:p>
-                      <a:pPr algn="ctr" indent="0" marL="0">
-                        <a:buNone/>
-                      </a:pPr>
-                      <a:r>
-                        <a:rPr lang="en-US" sz="1200" dirty="0">
-                          <a:solidFill>
-                            <a:srgbClr val="2A2A2A"/>
-                          </a:solidFill>
-                          <a:latin typeface="Arial" pitchFamily="34" charset="0"/>
-                          <a:ea typeface="Arial" pitchFamily="34" charset="-122"/>
-                          <a:cs typeface="Arial" pitchFamily="34" charset="-120"/>
-                        </a:rPr>
-                        <a:t>− $1,680</a:t>
-                      </a:r>
-                      <a:endParaRPr lang="en-US" sz="1200" dirty="0">
-                        <a:latin typeface="Arial" charset="0"/>
-                        <a:ea typeface="Arial" charset="0"/>
-                        <a:cs typeface="Arial" charset="0"/>
-                      </a:endParaRPr>
-                    </a:p>
-                  </a:txBody>
-                  <a:tcPr marL="54864" marR="54864" marT="54864" marB="54864" anchor="ctr">
-                    <a:lnL w="9525" cap="flat" cmpd="sng" algn="ctr">
-                      <a:solidFill>
-                        <a:srgbClr val="DDDDDD"/>
-                      </a:solidFill>
-                      <a:prstDash val="solid"/>
-                      <a:round/>
-                      <a:headEnd type="none" w="med" len="med"/>
-                      <a:tailEnd type="none" w="med" len="med"/>
-                    </a:lnL>
-                    <a:lnR w="9525" cap="flat" cmpd="sng" algn="ctr">
-                      <a:solidFill>
-                        <a:srgbClr val="DDDDDD"/>
-                      </a:solidFill>
-                      <a:prstDash val="solid"/>
-                      <a:round/>
-                      <a:headEnd type="none" w="med" len="med"/>
-                      <a:tailEnd type="none" w="med" len="med"/>
-                    </a:lnR>
-                    <a:lnT w="9525" cap="flat" cmpd="sng" algn="ctr">
-                      <a:solidFill>
-                        <a:srgbClr val="DDDDDD"/>
-                      </a:solidFill>
-                      <a:prstDash val="solid"/>
-                      <a:round/>
-                      <a:headEnd type="none" w="med" len="med"/>
-                      <a:tailEnd type="none" w="med" len="med"/>
-                    </a:lnT>
-                    <a:lnB w="9525" cap="flat" cmpd="sng" algn="ctr">
-                      <a:solidFill>
-                        <a:srgbClr val="DDDDDD"/>
-                      </a:solidFill>
-                      <a:prstDash val="solid"/>
-                      <a:round/>
-                      <a:headEnd type="none" w="med" len="med"/>
-                      <a:tailEnd type="none" w="med" len="med"/>
-                    </a:lnB>
-                  </a:tcPr>
-                </a:tc>
-                <a:tc>
-                  <a:txBody>
-                    <a:bodyPr/>
-                    <a:lstStyle/>
-                    <a:p>
-                      <a:pPr algn="ctr" indent="0" marL="0">
-                        <a:buNone/>
-                      </a:pPr>
-                      <a:r>
-                        <a:rPr lang="en-US" sz="1200" dirty="0">
-                          <a:solidFill>
-                            <a:srgbClr val="2A2A2A"/>
-                          </a:solidFill>
-                          <a:latin typeface="Arial" pitchFamily="34" charset="0"/>
-                          <a:ea typeface="Arial" pitchFamily="34" charset="-122"/>
-                          <a:cs typeface="Arial" pitchFamily="34" charset="-120"/>
-                        </a:rPr>
-                        <a:t>$41,160</a:t>
-                      </a:r>
-                      <a:endParaRPr lang="en-US" sz="1200" dirty="0">
-                        <a:latin typeface="Arial" charset="0"/>
-                        <a:ea typeface="Arial" charset="0"/>
-                        <a:cs typeface="Arial" charset="0"/>
-                      </a:endParaRPr>
-                    </a:p>
-                  </a:txBody>
-                  <a:tcPr marL="54864" marR="54864" marT="54864" marB="54864" anchor="ctr">
-                    <a:lnL w="9525" cap="flat" cmpd="sng" algn="ctr">
-                      <a:solidFill>
-                        <a:srgbClr val="DDDDDD"/>
-                      </a:solidFill>
-                      <a:prstDash val="solid"/>
-                      <a:round/>
-                      <a:headEnd type="none" w="med" len="med"/>
-                      <a:tailEnd type="none" w="med" len="med"/>
-                    </a:lnL>
-                    <a:lnR w="9525" cap="flat" cmpd="sng" algn="ctr">
-                      <a:solidFill>
-                        <a:srgbClr val="DDDDDD"/>
-                      </a:solidFill>
-                      <a:prstDash val="solid"/>
-                      <a:round/>
-                      <a:headEnd type="none" w="med" len="med"/>
-                      <a:tailEnd type="none" w="med" len="med"/>
-                    </a:lnR>
-                    <a:lnT w="9525" cap="flat" cmpd="sng" algn="ctr">
-                      <a:solidFill>
-                        <a:srgbClr val="DDDDDD"/>
-                      </a:solidFill>
-                      <a:prstDash val="solid"/>
-                      <a:round/>
-                      <a:headEnd type="none" w="med" len="med"/>
-                      <a:tailEnd type="none" w="med" len="med"/>
-                    </a:lnT>
-                    <a:lnB w="9525" cap="flat" cmpd="sng" algn="ctr">
-                      <a:solidFill>
-                        <a:srgbClr val="DDDDDD"/>
-                      </a:solidFill>
-                      <a:prstDash val="solid"/>
-                      <a:round/>
-                      <a:headEnd type="none" w="med" len="med"/>
-                      <a:tailEnd type="none" w="med" len="med"/>
-                    </a:lnB>
-                  </a:tcPr>
-                </a:tc>
-                <a:tc>
-                  <a:txBody>
-                    <a:bodyPr/>
-                    <a:lstStyle/>
-                    <a:p>
-                      <a:pPr algn="ctr" indent="0" marL="0">
-                        <a:buNone/>
-                      </a:pPr>
-                      <a:r>
-                        <a:rPr lang="en-US" sz="1250" b="1" dirty="0">
-                          <a:solidFill>
-                            <a:srgbClr val="C8102E"/>
-                          </a:solidFill>
-                          <a:latin typeface="Arial" pitchFamily="34" charset="0"/>
-                          <a:ea typeface="Arial" pitchFamily="34" charset="-122"/>
-                          <a:cs typeface="Arial" pitchFamily="34" charset="-120"/>
-                        </a:rPr>
-                        <a:t>+$17,160</a:t>
-                      </a:r>
-                      <a:endParaRPr lang="en-US" sz="1250" dirty="0">
-                        <a:latin typeface="Arial" charset="0"/>
-                        <a:ea typeface="Arial" charset="0"/>
-                        <a:cs typeface="Arial" charset="0"/>
-                      </a:endParaRPr>
-                    </a:p>
-                  </a:txBody>
-                  <a:tcPr marL="54864" marR="54864" marT="54864" marB="54864" anchor="ctr">
-                    <a:lnL w="9525" cap="flat" cmpd="sng" algn="ctr">
-                      <a:solidFill>
-                        <a:srgbClr val="DDDDDD"/>
-                      </a:solidFill>
-                      <a:prstDash val="solid"/>
-                      <a:round/>
-                      <a:headEnd type="none" w="med" len="med"/>
-                      <a:tailEnd type="none" w="med" len="med"/>
-                    </a:lnL>
-                    <a:lnR w="9525" cap="flat" cmpd="sng" algn="ctr">
-                      <a:solidFill>
-                        <a:srgbClr val="DDDDDD"/>
-                      </a:solidFill>
-                      <a:prstDash val="solid"/>
-                      <a:round/>
-                      <a:headEnd type="none" w="med" len="med"/>
-                      <a:tailEnd type="none" w="med" len="med"/>
-                    </a:lnR>
-                    <a:lnT w="9525" cap="flat" cmpd="sng" algn="ctr">
-                      <a:solidFill>
-                        <a:srgbClr val="DDDDDD"/>
-                      </a:solidFill>
-                      <a:prstDash val="solid"/>
-                      <a:round/>
-                      <a:headEnd type="none" w="med" len="med"/>
-                      <a:tailEnd type="none" w="med" len="med"/>
-                    </a:lnT>
-                    <a:lnB w="9525" cap="flat" cmpd="sng" algn="ctr">
-                      <a:solidFill>
-                        <a:srgbClr val="DDDDDD"/>
-                      </a:solidFill>
-                      <a:prstDash val="solid"/>
-                      <a:round/>
-                      <a:headEnd type="none" w="med" len="med"/>
-                      <a:tailEnd type="none" w="med" len="med"/>
-                    </a:lnB>
-                  </a:tcPr>
-                </a:tc>
-              </a:tr>
-              <a:tr h="411480">
-                <a:tc>
-                  <a:txBody>
-                    <a:bodyPr/>
-                    <a:lstStyle/>
-                    <a:p>
-                      <a:pPr algn="ctr" indent="0" marL="0">
-                        <a:buNone/>
-                      </a:pPr>
-                      <a:r>
-                        <a:rPr lang="en-US" sz="1200" dirty="0">
-                          <a:solidFill>
-                            <a:srgbClr val="2A2A2A"/>
-                          </a:solidFill>
-                          <a:latin typeface="Arial" pitchFamily="34" charset="0"/>
-                          <a:ea typeface="Arial" pitchFamily="34" charset="-122"/>
-                          <a:cs typeface="Arial" pitchFamily="34" charset="-120"/>
-                        </a:rPr>
-                        <a:t>18</a:t>
-                      </a:r>
-                      <a:endParaRPr lang="en-US" sz="1200" dirty="0">
-                        <a:latin typeface="Arial" charset="0"/>
-                        <a:ea typeface="Arial" charset="0"/>
-                        <a:cs typeface="Arial" charset="0"/>
-                      </a:endParaRPr>
-                    </a:p>
-                  </a:txBody>
-                  <a:tcPr marL="54864" marR="54864" marT="54864" marB="54864" anchor="ctr">
-                    <a:lnL w="9525" cap="flat" cmpd="sng" algn="ctr">
-                      <a:solidFill>
-                        <a:srgbClr val="DDDDDD"/>
-                      </a:solidFill>
-                      <a:prstDash val="solid"/>
-                      <a:round/>
-                      <a:headEnd type="none" w="med" len="med"/>
-                      <a:tailEnd type="none" w="med" len="med"/>
-                    </a:lnL>
-                    <a:lnR w="9525" cap="flat" cmpd="sng" algn="ctr">
-                      <a:solidFill>
-                        <a:srgbClr val="DDDDDD"/>
-                      </a:solidFill>
-                      <a:prstDash val="solid"/>
-                      <a:round/>
-                      <a:headEnd type="none" w="med" len="med"/>
-                      <a:tailEnd type="none" w="med" len="med"/>
-                    </a:lnR>
-                    <a:lnT w="9525" cap="flat" cmpd="sng" algn="ctr">
-                      <a:solidFill>
-                        <a:srgbClr val="DDDDDD"/>
-                      </a:solidFill>
-                      <a:prstDash val="solid"/>
-                      <a:round/>
-                      <a:headEnd type="none" w="med" len="med"/>
-                      <a:tailEnd type="none" w="med" len="med"/>
-                    </a:lnT>
-                    <a:lnB w="9525" cap="flat" cmpd="sng" algn="ctr">
-                      <a:solidFill>
-                        <a:srgbClr val="DDDDDD"/>
-                      </a:solidFill>
-                      <a:prstDash val="solid"/>
-                      <a:round/>
-                      <a:headEnd type="none" w="med" len="med"/>
-                      <a:tailEnd type="none" w="med" len="med"/>
-                    </a:lnB>
-                  </a:tcPr>
-                </a:tc>
-                <a:tc>
-                  <a:txBody>
-                    <a:bodyPr/>
-                    <a:lstStyle/>
-                    <a:p>
-                      <a:pPr algn="ctr" indent="0" marL="0">
-                        <a:buNone/>
-                      </a:pPr>
-                      <a:r>
-                        <a:rPr lang="en-US" sz="1200" dirty="0">
-                          <a:solidFill>
-                            <a:srgbClr val="2A2A2A"/>
-                          </a:solidFill>
-                          <a:latin typeface="Arial" pitchFamily="34" charset="0"/>
-                          <a:ea typeface="Arial" pitchFamily="34" charset="-122"/>
-                          <a:cs typeface="Arial" pitchFamily="34" charset="-120"/>
-                        </a:rPr>
-                        <a:t>$540,000</a:t>
-                      </a:r>
-                      <a:endParaRPr lang="en-US" sz="1200" dirty="0">
-                        <a:latin typeface="Arial" charset="0"/>
-                        <a:ea typeface="Arial" charset="0"/>
-                        <a:cs typeface="Arial" charset="0"/>
-                      </a:endParaRPr>
-                    </a:p>
-                  </a:txBody>
-                  <a:tcPr marL="54864" marR="54864" marT="54864" marB="54864" anchor="ctr">
-                    <a:lnL w="9525" cap="flat" cmpd="sng" algn="ctr">
-                      <a:solidFill>
-                        <a:srgbClr val="DDDDDD"/>
-                      </a:solidFill>
-                      <a:prstDash val="solid"/>
-                      <a:round/>
-                      <a:headEnd type="none" w="med" len="med"/>
-                      <a:tailEnd type="none" w="med" len="med"/>
-                    </a:lnL>
-                    <a:lnR w="9525" cap="flat" cmpd="sng" algn="ctr">
-                      <a:solidFill>
-                        <a:srgbClr val="DDDDDD"/>
-                      </a:solidFill>
-                      <a:prstDash val="solid"/>
-                      <a:round/>
-                      <a:headEnd type="none" w="med" len="med"/>
-                      <a:tailEnd type="none" w="med" len="med"/>
-                    </a:lnR>
-                    <a:lnT w="9525" cap="flat" cmpd="sng" algn="ctr">
-                      <a:solidFill>
-                        <a:srgbClr val="DDDDDD"/>
-                      </a:solidFill>
-                      <a:prstDash val="solid"/>
-                      <a:round/>
-                      <a:headEnd type="none" w="med" len="med"/>
-                      <a:tailEnd type="none" w="med" len="med"/>
-                    </a:lnT>
-                    <a:lnB w="9525" cap="flat" cmpd="sng" algn="ctr">
-                      <a:solidFill>
-                        <a:srgbClr val="DDDDDD"/>
-                      </a:solidFill>
-                      <a:prstDash val="solid"/>
-                      <a:round/>
-                      <a:headEnd type="none" w="med" len="med"/>
-                      <a:tailEnd type="none" w="med" len="med"/>
-                    </a:lnB>
-                  </a:tcPr>
-                </a:tc>
-                <a:tc>
-                  <a:txBody>
-                    <a:bodyPr/>
-                    <a:lstStyle/>
-                    <a:p>
-                      <a:pPr algn="ctr" indent="0" marL="0">
-                        <a:buNone/>
-                      </a:pPr>
-                      <a:r>
-                        <a:rPr lang="en-US" sz="1200" dirty="0">
-                          <a:solidFill>
-                            <a:srgbClr val="2A2A2A"/>
-                          </a:solidFill>
-                          <a:latin typeface="Arial" pitchFamily="34" charset="0"/>
-                          <a:ea typeface="Arial" pitchFamily="34" charset="-122"/>
-                          <a:cs typeface="Arial" pitchFamily="34" charset="-120"/>
-                        </a:rPr>
-                        <a:t>$189,000</a:t>
-                      </a:r>
-                      <a:endParaRPr lang="en-US" sz="1200" dirty="0">
-                        <a:latin typeface="Arial" charset="0"/>
-                        <a:ea typeface="Arial" charset="0"/>
-                        <a:cs typeface="Arial" charset="0"/>
-                      </a:endParaRPr>
-                    </a:p>
-                  </a:txBody>
-                  <a:tcPr marL="54864" marR="54864" marT="54864" marB="54864" anchor="ctr">
-                    <a:lnL w="9525" cap="flat" cmpd="sng" algn="ctr">
-                      <a:solidFill>
-                        <a:srgbClr val="DDDDDD"/>
-                      </a:solidFill>
-                      <a:prstDash val="solid"/>
-                      <a:round/>
-                      <a:headEnd type="none" w="med" len="med"/>
-                      <a:tailEnd type="none" w="med" len="med"/>
-                    </a:lnL>
-                    <a:lnR w="9525" cap="flat" cmpd="sng" algn="ctr">
-                      <a:solidFill>
-                        <a:srgbClr val="DDDDDD"/>
-                      </a:solidFill>
-                      <a:prstDash val="solid"/>
-                      <a:round/>
-                      <a:headEnd type="none" w="med" len="med"/>
-                      <a:tailEnd type="none" w="med" len="med"/>
-                    </a:lnR>
-                    <a:lnT w="9525" cap="flat" cmpd="sng" algn="ctr">
-                      <a:solidFill>
-                        <a:srgbClr val="DDDDDD"/>
-                      </a:solidFill>
-                      <a:prstDash val="solid"/>
-                      <a:round/>
-                      <a:headEnd type="none" w="med" len="med"/>
-                      <a:tailEnd type="none" w="med" len="med"/>
-                    </a:lnT>
-                    <a:lnB w="9525" cap="flat" cmpd="sng" algn="ctr">
-                      <a:solidFill>
-                        <a:srgbClr val="DDDDDD"/>
-                      </a:solidFill>
-                      <a:prstDash val="solid"/>
-                      <a:round/>
-                      <a:headEnd type="none" w="med" len="med"/>
-                      <a:tailEnd type="none" w="med" len="med"/>
-                    </a:lnB>
-                  </a:tcPr>
-                </a:tc>
-                <a:tc>
-                  <a:txBody>
-                    <a:bodyPr/>
-                    <a:lstStyle/>
-                    <a:p>
-                      <a:pPr algn="ctr" indent="0" marL="0">
-                        <a:buNone/>
-                      </a:pPr>
-                      <a:r>
-                        <a:rPr lang="en-US" sz="1200" dirty="0">
-                          <a:solidFill>
-                            <a:srgbClr val="2A2A2A"/>
-                          </a:solidFill>
-                          <a:latin typeface="Arial" pitchFamily="34" charset="0"/>
-                          <a:ea typeface="Arial" pitchFamily="34" charset="-122"/>
-                          <a:cs typeface="Arial" pitchFamily="34" charset="-120"/>
-                        </a:rPr>
-                        <a:t>− $3,780</a:t>
-                      </a:r>
-                      <a:endParaRPr lang="en-US" sz="1200" dirty="0">
-                        <a:latin typeface="Arial" charset="0"/>
-                        <a:ea typeface="Arial" charset="0"/>
-                        <a:cs typeface="Arial" charset="0"/>
-                      </a:endParaRPr>
-                    </a:p>
-                  </a:txBody>
-                  <a:tcPr marL="54864" marR="54864" marT="54864" marB="54864" anchor="ctr">
-                    <a:lnL w="9525" cap="flat" cmpd="sng" algn="ctr">
-                      <a:solidFill>
-                        <a:srgbClr val="DDDDDD"/>
-                      </a:solidFill>
-                      <a:prstDash val="solid"/>
-                      <a:round/>
-                      <a:headEnd type="none" w="med" len="med"/>
-                      <a:tailEnd type="none" w="med" len="med"/>
-                    </a:lnL>
-                    <a:lnR w="9525" cap="flat" cmpd="sng" algn="ctr">
-                      <a:solidFill>
-                        <a:srgbClr val="DDDDDD"/>
-                      </a:solidFill>
-                      <a:prstDash val="solid"/>
-                      <a:round/>
-                      <a:headEnd type="none" w="med" len="med"/>
-                      <a:tailEnd type="none" w="med" len="med"/>
-                    </a:lnR>
-                    <a:lnT w="9525" cap="flat" cmpd="sng" algn="ctr">
-                      <a:solidFill>
-                        <a:srgbClr val="DDDDDD"/>
-                      </a:solidFill>
-                      <a:prstDash val="solid"/>
-                      <a:round/>
-                      <a:headEnd type="none" w="med" len="med"/>
-                      <a:tailEnd type="none" w="med" len="med"/>
-                    </a:lnT>
-                    <a:lnB w="9525" cap="flat" cmpd="sng" algn="ctr">
-                      <a:solidFill>
-                        <a:srgbClr val="DDDDDD"/>
-                      </a:solidFill>
-                      <a:prstDash val="solid"/>
-                      <a:round/>
-                      <a:headEnd type="none" w="med" len="med"/>
-                      <a:tailEnd type="none" w="med" len="med"/>
-                    </a:lnB>
-                  </a:tcPr>
-                </a:tc>
-                <a:tc>
-                  <a:txBody>
-                    <a:bodyPr/>
-                    <a:lstStyle/>
-                    <a:p>
-                      <a:pPr algn="ctr" indent="0" marL="0">
-                        <a:buNone/>
-                      </a:pPr>
-                      <a:r>
-                        <a:rPr lang="en-US" sz="1200" dirty="0">
-                          <a:solidFill>
-                            <a:srgbClr val="2A2A2A"/>
-                          </a:solidFill>
-                          <a:latin typeface="Arial" pitchFamily="34" charset="0"/>
-                          <a:ea typeface="Arial" pitchFamily="34" charset="-122"/>
-                          <a:cs typeface="Arial" pitchFamily="34" charset="-120"/>
-                        </a:rPr>
-                        <a:t>$92,610</a:t>
-                      </a:r>
-                      <a:endParaRPr lang="en-US" sz="1200" dirty="0">
-                        <a:latin typeface="Arial" charset="0"/>
-                        <a:ea typeface="Arial" charset="0"/>
-                        <a:cs typeface="Arial" charset="0"/>
-                      </a:endParaRPr>
-                    </a:p>
-                  </a:txBody>
-                  <a:tcPr marL="54864" marR="54864" marT="54864" marB="54864" anchor="ctr">
-                    <a:lnL w="9525" cap="flat" cmpd="sng" algn="ctr">
-                      <a:solidFill>
-                        <a:srgbClr val="DDDDDD"/>
-                      </a:solidFill>
-                      <a:prstDash val="solid"/>
-                      <a:round/>
-                      <a:headEnd type="none" w="med" len="med"/>
-                      <a:tailEnd type="none" w="med" len="med"/>
-                    </a:lnL>
-                    <a:lnR w="9525" cap="flat" cmpd="sng" algn="ctr">
-                      <a:solidFill>
-                        <a:srgbClr val="DDDDDD"/>
-                      </a:solidFill>
-                      <a:prstDash val="solid"/>
-                      <a:round/>
-                      <a:headEnd type="none" w="med" len="med"/>
-                      <a:tailEnd type="none" w="med" len="med"/>
-                    </a:lnR>
-                    <a:lnT w="9525" cap="flat" cmpd="sng" algn="ctr">
-                      <a:solidFill>
-                        <a:srgbClr val="DDDDDD"/>
-                      </a:solidFill>
-                      <a:prstDash val="solid"/>
-                      <a:round/>
-                      <a:headEnd type="none" w="med" len="med"/>
-                      <a:tailEnd type="none" w="med" len="med"/>
-                    </a:lnT>
-                    <a:lnB w="9525" cap="flat" cmpd="sng" algn="ctr">
-                      <a:solidFill>
-                        <a:srgbClr val="DDDDDD"/>
-                      </a:solidFill>
-                      <a:prstDash val="solid"/>
-                      <a:round/>
-                      <a:headEnd type="none" w="med" len="med"/>
-                      <a:tailEnd type="none" w="med" len="med"/>
-                    </a:lnB>
-                  </a:tcPr>
-                </a:tc>
-                <a:tc>
-                  <a:txBody>
-                    <a:bodyPr/>
-                    <a:lstStyle/>
-                    <a:p>
-                      <a:pPr algn="ctr" indent="0" marL="0">
-                        <a:buNone/>
-                      </a:pPr>
-                      <a:r>
-                        <a:rPr lang="en-US" sz="1250" b="1" dirty="0">
-                          <a:solidFill>
-                            <a:srgbClr val="C8102E"/>
-                          </a:solidFill>
-                          <a:latin typeface="Arial" pitchFamily="34" charset="0"/>
-                          <a:ea typeface="Arial" pitchFamily="34" charset="-122"/>
-                          <a:cs typeface="Arial" pitchFamily="34" charset="-120"/>
-                        </a:rPr>
-                        <a:t>+$68,610</a:t>
-                      </a:r>
-                      <a:endParaRPr lang="en-US" sz="1250" dirty="0">
-                        <a:latin typeface="Arial" charset="0"/>
-                        <a:ea typeface="Arial" charset="0"/>
-                        <a:cs typeface="Arial" charset="0"/>
-                      </a:endParaRPr>
-                    </a:p>
-                  </a:txBody>
-                  <a:tcPr marL="54864" marR="54864" marT="54864" marB="54864" anchor="ctr">
-                    <a:lnL w="9525" cap="flat" cmpd="sng" algn="ctr">
-                      <a:solidFill>
-                        <a:srgbClr val="DDDDDD"/>
-                      </a:solidFill>
-                      <a:prstDash val="solid"/>
-                      <a:round/>
-                      <a:headEnd type="none" w="med" len="med"/>
-                      <a:tailEnd type="none" w="med" len="med"/>
-                    </a:lnL>
-                    <a:lnR w="9525" cap="flat" cmpd="sng" algn="ctr">
-                      <a:solidFill>
-                        <a:srgbClr val="DDDDDD"/>
-                      </a:solidFill>
-                      <a:prstDash val="solid"/>
-                      <a:round/>
-                      <a:headEnd type="none" w="med" len="med"/>
-                      <a:tailEnd type="none" w="med" len="med"/>
-                    </a:lnR>
-                    <a:lnT w="9525" cap="flat" cmpd="sng" algn="ctr">
-                      <a:solidFill>
-                        <a:srgbClr val="DDDDDD"/>
-                      </a:solidFill>
-                      <a:prstDash val="solid"/>
-                      <a:round/>
-                      <a:headEnd type="none" w="med" len="med"/>
-                      <a:tailEnd type="none" w="med" len="med"/>
-                    </a:lnT>
-                    <a:lnB w="9525" cap="flat" cmpd="sng" algn="ctr">
-                      <a:solidFill>
-                        <a:srgbClr val="DDDDDD"/>
-                      </a:solidFill>
-                      <a:prstDash val="solid"/>
-                      <a:round/>
-                      <a:headEnd type="none" w="med" len="med"/>
-                      <a:tailEnd type="none" w="med" len="med"/>
-                    </a:lnB>
-                  </a:tcPr>
-                </a:tc>
-              </a:tr>
-              <a:tr h="411480">
-                <a:tc>
-                  <a:txBody>
-                    <a:bodyPr/>
-                    <a:lstStyle/>
-                    <a:p>
-                      <a:pPr algn="ctr" indent="0" marL="0">
-                        <a:buNone/>
-                      </a:pPr>
-                      <a:r>
-                        <a:rPr lang="en-US" sz="1200" dirty="0">
-                          <a:solidFill>
-                            <a:srgbClr val="2A2A2A"/>
-                          </a:solidFill>
-                          <a:latin typeface="Arial" pitchFamily="34" charset="0"/>
-                          <a:ea typeface="Arial" pitchFamily="34" charset="-122"/>
-                          <a:cs typeface="Arial" pitchFamily="34" charset="-120"/>
-                        </a:rPr>
-                        <a:t>30</a:t>
-                      </a:r>
-                      <a:endParaRPr lang="en-US" sz="1200" dirty="0">
-                        <a:latin typeface="Arial" charset="0"/>
-                        <a:ea typeface="Arial" charset="0"/>
-                        <a:cs typeface="Arial" charset="0"/>
-                      </a:endParaRPr>
-                    </a:p>
-                  </a:txBody>
-                  <a:tcPr marL="54864" marR="54864" marT="54864" marB="54864" anchor="ctr">
-                    <a:lnL w="9525" cap="flat" cmpd="sng" algn="ctr">
-                      <a:solidFill>
-                        <a:srgbClr val="DDDDDD"/>
-                      </a:solidFill>
-                      <a:prstDash val="solid"/>
-                      <a:round/>
-                      <a:headEnd type="none" w="med" len="med"/>
-                      <a:tailEnd type="none" w="med" len="med"/>
-                    </a:lnL>
-                    <a:lnR w="9525" cap="flat" cmpd="sng" algn="ctr">
-                      <a:solidFill>
-                        <a:srgbClr val="DDDDDD"/>
-                      </a:solidFill>
-                      <a:prstDash val="solid"/>
-                      <a:round/>
-                      <a:headEnd type="none" w="med" len="med"/>
-                      <a:tailEnd type="none" w="med" len="med"/>
-                    </a:lnR>
-                    <a:lnT w="9525" cap="flat" cmpd="sng" algn="ctr">
-                      <a:solidFill>
-                        <a:srgbClr val="DDDDDD"/>
-                      </a:solidFill>
-                      <a:prstDash val="solid"/>
-                      <a:round/>
-                      <a:headEnd type="none" w="med" len="med"/>
-                      <a:tailEnd type="none" w="med" len="med"/>
-                    </a:lnT>
-                    <a:lnB w="9525" cap="flat" cmpd="sng" algn="ctr">
-                      <a:solidFill>
-                        <a:srgbClr val="DDDDDD"/>
-                      </a:solidFill>
-                      <a:prstDash val="solid"/>
-                      <a:round/>
-                      <a:headEnd type="none" w="med" len="med"/>
-                      <a:tailEnd type="none" w="med" len="med"/>
-                    </a:lnB>
-                  </a:tcPr>
-                </a:tc>
-                <a:tc>
-                  <a:txBody>
-                    <a:bodyPr/>
-                    <a:lstStyle/>
-                    <a:p>
-                      <a:pPr algn="ctr" indent="0" marL="0">
-                        <a:buNone/>
-                      </a:pPr>
-                      <a:r>
-                        <a:rPr lang="en-US" sz="1200" dirty="0">
-                          <a:solidFill>
-                            <a:srgbClr val="2A2A2A"/>
-                          </a:solidFill>
-                          <a:latin typeface="Arial" pitchFamily="34" charset="0"/>
-                          <a:ea typeface="Arial" pitchFamily="34" charset="-122"/>
-                          <a:cs typeface="Arial" pitchFamily="34" charset="-120"/>
-                        </a:rPr>
-                        <a:t>$900,000</a:t>
-                      </a:r>
-                      <a:endParaRPr lang="en-US" sz="1200" dirty="0">
-                        <a:latin typeface="Arial" charset="0"/>
-                        <a:ea typeface="Arial" charset="0"/>
-                        <a:cs typeface="Arial" charset="0"/>
-                      </a:endParaRPr>
-                    </a:p>
-                  </a:txBody>
-                  <a:tcPr marL="54864" marR="54864" marT="54864" marB="54864" anchor="ctr">
-                    <a:lnL w="9525" cap="flat" cmpd="sng" algn="ctr">
-                      <a:solidFill>
-                        <a:srgbClr val="DDDDDD"/>
-                      </a:solidFill>
-                      <a:prstDash val="solid"/>
-                      <a:round/>
-                      <a:headEnd type="none" w="med" len="med"/>
-                      <a:tailEnd type="none" w="med" len="med"/>
-                    </a:lnL>
-                    <a:lnR w="9525" cap="flat" cmpd="sng" algn="ctr">
-                      <a:solidFill>
-                        <a:srgbClr val="DDDDDD"/>
-                      </a:solidFill>
-                      <a:prstDash val="solid"/>
-                      <a:round/>
-                      <a:headEnd type="none" w="med" len="med"/>
-                      <a:tailEnd type="none" w="med" len="med"/>
-                    </a:lnR>
-                    <a:lnT w="9525" cap="flat" cmpd="sng" algn="ctr">
-                      <a:solidFill>
-                        <a:srgbClr val="DDDDDD"/>
-                      </a:solidFill>
-                      <a:prstDash val="solid"/>
-                      <a:round/>
-                      <a:headEnd type="none" w="med" len="med"/>
-                      <a:tailEnd type="none" w="med" len="med"/>
-                    </a:lnT>
-                    <a:lnB w="9525" cap="flat" cmpd="sng" algn="ctr">
-                      <a:solidFill>
-                        <a:srgbClr val="DDDDDD"/>
-                      </a:solidFill>
-                      <a:prstDash val="solid"/>
-                      <a:round/>
-                      <a:headEnd type="none" w="med" len="med"/>
-                      <a:tailEnd type="none" w="med" len="med"/>
-                    </a:lnB>
-                  </a:tcPr>
-                </a:tc>
-                <a:tc>
-                  <a:txBody>
-                    <a:bodyPr/>
-                    <a:lstStyle/>
-                    <a:p>
-                      <a:pPr algn="ctr" indent="0" marL="0">
-                        <a:buNone/>
-                      </a:pPr>
-                      <a:r>
-                        <a:rPr lang="en-US" sz="1200" dirty="0">
-                          <a:solidFill>
-                            <a:srgbClr val="2A2A2A"/>
-                          </a:solidFill>
-                          <a:latin typeface="Arial" pitchFamily="34" charset="0"/>
-                          <a:ea typeface="Arial" pitchFamily="34" charset="-122"/>
-                          <a:cs typeface="Arial" pitchFamily="34" charset="-120"/>
-                        </a:rPr>
-                        <a:t>$315,000</a:t>
-                      </a:r>
-                      <a:endParaRPr lang="en-US" sz="1200" dirty="0">
-                        <a:latin typeface="Arial" charset="0"/>
-                        <a:ea typeface="Arial" charset="0"/>
-                        <a:cs typeface="Arial" charset="0"/>
-                      </a:endParaRPr>
-                    </a:p>
-                  </a:txBody>
-                  <a:tcPr marL="54864" marR="54864" marT="54864" marB="54864" anchor="ctr">
-                    <a:lnL w="9525" cap="flat" cmpd="sng" algn="ctr">
-                      <a:solidFill>
-                        <a:srgbClr val="DDDDDD"/>
-                      </a:solidFill>
-                      <a:prstDash val="solid"/>
-                      <a:round/>
-                      <a:headEnd type="none" w="med" len="med"/>
-                      <a:tailEnd type="none" w="med" len="med"/>
-                    </a:lnL>
-                    <a:lnR w="9525" cap="flat" cmpd="sng" algn="ctr">
-                      <a:solidFill>
-                        <a:srgbClr val="DDDDDD"/>
-                      </a:solidFill>
-                      <a:prstDash val="solid"/>
-                      <a:round/>
-                      <a:headEnd type="none" w="med" len="med"/>
-                      <a:tailEnd type="none" w="med" len="med"/>
-                    </a:lnR>
-                    <a:lnT w="9525" cap="flat" cmpd="sng" algn="ctr">
-                      <a:solidFill>
-                        <a:srgbClr val="DDDDDD"/>
-                      </a:solidFill>
-                      <a:prstDash val="solid"/>
-                      <a:round/>
-                      <a:headEnd type="none" w="med" len="med"/>
-                      <a:tailEnd type="none" w="med" len="med"/>
-                    </a:lnT>
-                    <a:lnB w="9525" cap="flat" cmpd="sng" algn="ctr">
-                      <a:solidFill>
-                        <a:srgbClr val="DDDDDD"/>
-                      </a:solidFill>
-                      <a:prstDash val="solid"/>
-                      <a:round/>
-                      <a:headEnd type="none" w="med" len="med"/>
-                      <a:tailEnd type="none" w="med" len="med"/>
-                    </a:lnB>
-                  </a:tcPr>
-                </a:tc>
-                <a:tc>
-                  <a:txBody>
-                    <a:bodyPr/>
-                    <a:lstStyle/>
-                    <a:p>
-                      <a:pPr algn="ctr" indent="0" marL="0">
-                        <a:buNone/>
-                      </a:pPr>
-                      <a:r>
-                        <a:rPr lang="en-US" sz="1200" dirty="0">
-                          <a:solidFill>
-                            <a:srgbClr val="2A2A2A"/>
-                          </a:solidFill>
-                          <a:latin typeface="Arial" pitchFamily="34" charset="0"/>
-                          <a:ea typeface="Arial" pitchFamily="34" charset="-122"/>
-                          <a:cs typeface="Arial" pitchFamily="34" charset="-120"/>
-                        </a:rPr>
-                        <a:t>− $6,300</a:t>
-                      </a:r>
-                      <a:endParaRPr lang="en-US" sz="1200" dirty="0">
-                        <a:latin typeface="Arial" charset="0"/>
-                        <a:ea typeface="Arial" charset="0"/>
-                        <a:cs typeface="Arial" charset="0"/>
-                      </a:endParaRPr>
-                    </a:p>
-                  </a:txBody>
-                  <a:tcPr marL="54864" marR="54864" marT="54864" marB="54864" anchor="ctr">
-                    <a:lnL w="9525" cap="flat" cmpd="sng" algn="ctr">
-                      <a:solidFill>
-                        <a:srgbClr val="DDDDDD"/>
-                      </a:solidFill>
-                      <a:prstDash val="solid"/>
-                      <a:round/>
-                      <a:headEnd type="none" w="med" len="med"/>
-                      <a:tailEnd type="none" w="med" len="med"/>
-                    </a:lnL>
-                    <a:lnR w="9525" cap="flat" cmpd="sng" algn="ctr">
-                      <a:solidFill>
-                        <a:srgbClr val="DDDDDD"/>
-                      </a:solidFill>
-                      <a:prstDash val="solid"/>
-                      <a:round/>
-                      <a:headEnd type="none" w="med" len="med"/>
-                      <a:tailEnd type="none" w="med" len="med"/>
-                    </a:lnR>
-                    <a:lnT w="9525" cap="flat" cmpd="sng" algn="ctr">
-                      <a:solidFill>
-                        <a:srgbClr val="DDDDDD"/>
-                      </a:solidFill>
-                      <a:prstDash val="solid"/>
-                      <a:round/>
-                      <a:headEnd type="none" w="med" len="med"/>
-                      <a:tailEnd type="none" w="med" len="med"/>
-                    </a:lnT>
-                    <a:lnB w="9525" cap="flat" cmpd="sng" algn="ctr">
-                      <a:solidFill>
-                        <a:srgbClr val="DDDDDD"/>
-                      </a:solidFill>
-                      <a:prstDash val="solid"/>
-                      <a:round/>
-                      <a:headEnd type="none" w="med" len="med"/>
-                      <a:tailEnd type="none" w="med" len="med"/>
-                    </a:lnB>
-                  </a:tcPr>
-                </a:tc>
-                <a:tc>
-                  <a:txBody>
-                    <a:bodyPr/>
-                    <a:lstStyle/>
-                    <a:p>
-                      <a:pPr algn="ctr" indent="0" marL="0">
-                        <a:buNone/>
-                      </a:pPr>
-                      <a:r>
-                        <a:rPr lang="en-US" sz="1200" dirty="0">
-                          <a:solidFill>
-                            <a:srgbClr val="2A2A2A"/>
-                          </a:solidFill>
-                          <a:latin typeface="Arial" pitchFamily="34" charset="0"/>
-                          <a:ea typeface="Arial" pitchFamily="34" charset="-122"/>
-                          <a:cs typeface="Arial" pitchFamily="34" charset="-120"/>
-                        </a:rPr>
-                        <a:t>$154,350</a:t>
-                      </a:r>
-                      <a:endParaRPr lang="en-US" sz="1200" dirty="0">
-                        <a:latin typeface="Arial" charset="0"/>
-                        <a:ea typeface="Arial" charset="0"/>
-                        <a:cs typeface="Arial" charset="0"/>
-                      </a:endParaRPr>
-                    </a:p>
-                  </a:txBody>
-                  <a:tcPr marL="54864" marR="54864" marT="54864" marB="54864" anchor="ctr">
-                    <a:lnL w="9525" cap="flat" cmpd="sng" algn="ctr">
-                      <a:solidFill>
-                        <a:srgbClr val="DDDDDD"/>
-                      </a:solidFill>
-                      <a:prstDash val="solid"/>
-                      <a:round/>
-                      <a:headEnd type="none" w="med" len="med"/>
-                      <a:tailEnd type="none" w="med" len="med"/>
-                    </a:lnL>
-                    <a:lnR w="9525" cap="flat" cmpd="sng" algn="ctr">
-                      <a:solidFill>
-                        <a:srgbClr val="DDDDDD"/>
-                      </a:solidFill>
-                      <a:prstDash val="solid"/>
-                      <a:round/>
-                      <a:headEnd type="none" w="med" len="med"/>
-                      <a:tailEnd type="none" w="med" len="med"/>
-                    </a:lnR>
-                    <a:lnT w="9525" cap="flat" cmpd="sng" algn="ctr">
-                      <a:solidFill>
-                        <a:srgbClr val="DDDDDD"/>
-                      </a:solidFill>
-                      <a:prstDash val="solid"/>
-                      <a:round/>
-                      <a:headEnd type="none" w="med" len="med"/>
-                      <a:tailEnd type="none" w="med" len="med"/>
-                    </a:lnT>
-                    <a:lnB w="9525" cap="flat" cmpd="sng" algn="ctr">
-                      <a:solidFill>
-                        <a:srgbClr val="DDDDDD"/>
-                      </a:solidFill>
-                      <a:prstDash val="solid"/>
-                      <a:round/>
-                      <a:headEnd type="none" w="med" len="med"/>
-                      <a:tailEnd type="none" w="med" len="med"/>
-                    </a:lnB>
-                  </a:tcPr>
-                </a:tc>
-                <a:tc>
-                  <a:txBody>
-                    <a:bodyPr/>
-                    <a:lstStyle/>
-                    <a:p>
-                      <a:pPr algn="ctr" indent="0" marL="0">
-                        <a:buNone/>
-                      </a:pPr>
-                      <a:r>
-                        <a:rPr lang="en-US" sz="1250" b="1" dirty="0">
-                          <a:solidFill>
-                            <a:srgbClr val="C8102E"/>
-                          </a:solidFill>
-                          <a:latin typeface="Arial" pitchFamily="34" charset="0"/>
-                          <a:ea typeface="Arial" pitchFamily="34" charset="-122"/>
-                          <a:cs typeface="Arial" pitchFamily="34" charset="-120"/>
-                        </a:rPr>
-                        <a:t>+$130,350</a:t>
-                      </a:r>
-                      <a:endParaRPr lang="en-US" sz="1250" dirty="0">
-                        <a:latin typeface="Arial" charset="0"/>
-                        <a:ea typeface="Arial" charset="0"/>
-                        <a:cs typeface="Arial" charset="0"/>
-                      </a:endParaRPr>
-                    </a:p>
-                  </a:txBody>
-                  <a:tcPr marL="54864" marR="54864" marT="54864" marB="54864" anchor="ctr">
-                    <a:lnL w="9525" cap="flat" cmpd="sng" algn="ctr">
-                      <a:solidFill>
-                        <a:srgbClr val="DDDDDD"/>
-                      </a:solidFill>
-                      <a:prstDash val="solid"/>
-                      <a:round/>
-                      <a:headEnd type="none" w="med" len="med"/>
-                      <a:tailEnd type="none" w="med" len="med"/>
-                    </a:lnL>
-                    <a:lnR w="9525" cap="flat" cmpd="sng" algn="ctr">
-                      <a:solidFill>
-                        <a:srgbClr val="DDDDDD"/>
-                      </a:solidFill>
-                      <a:prstDash val="solid"/>
-                      <a:round/>
-                      <a:headEnd type="none" w="med" len="med"/>
-                      <a:tailEnd type="none" w="med" len="med"/>
-                    </a:lnR>
-                    <a:lnT w="9525" cap="flat" cmpd="sng" algn="ctr">
-                      <a:solidFill>
-                        <a:srgbClr val="DDDDDD"/>
-                      </a:solidFill>
-                      <a:prstDash val="solid"/>
-                      <a:round/>
-                      <a:headEnd type="none" w="med" len="med"/>
-                      <a:tailEnd type="none" w="med" len="med"/>
-                    </a:lnT>
-                    <a:lnB w="9525" cap="flat" cmpd="sng" algn="ctr">
-                      <a:solidFill>
-                        <a:srgbClr val="DDDDDD"/>
-                      </a:solidFill>
-                      <a:prstDash val="solid"/>
-                      <a:round/>
-                      <a:headEnd type="none" w="med" len="med"/>
-                      <a:tailEnd type="none" w="med" len="med"/>
-                    </a:lnB>
-                  </a:tcPr>
-                </a:tc>
-              </a:tr>
-            </a:tbl>
-          </a:graphicData>
-        </a:graphic>
-      </p:graphicFrame>
-      <p:sp>
-        <p:nvSpPr>
-          <p:cNvPr id="20" name="Shape 14"/>
+          <p:cNvPr id="31" name="Shape 26"/>
           <p:cNvSpPr/>
           <p:nvPr/>
         </p:nvSpPr>
@@ -16026,14 +14823,14 @@
       </p:sp>
       <p:sp>
         <p:nvSpPr>
-          <p:cNvPr id="21" name="Text 15"/>
-          <p:cNvSpPr/>
-          <p:nvPr/>
-        </p:nvSpPr>
-        <p:spPr>
-          <a:xfrm>
-            <a:off x="868680" y="5650992"/>
-            <a:ext cx="10515600" cy="502920"/>
+          <p:cNvPr id="32" name="Text 27"/>
+          <p:cNvSpPr/>
+          <p:nvPr/>
+        </p:nvSpPr>
+        <p:spPr>
+          <a:xfrm>
+            <a:off x="868680" y="5623560"/>
+            <a:ext cx="10515600" cy="566928"/>
           </a:xfrm>
           <a:prstGeom prst="rect">
             <a:avLst/>
@@ -16049,7 +14846,7 @@
               <a:buNone/>
             </a:pPr>
             <a:r>
-              <a:rPr lang="en-US" sz="1500" b="1" dirty="0">
+              <a:rPr lang="en-US" sz="1350" b="1" dirty="0">
                 <a:solidFill>
                   <a:srgbClr val="FFFFFF"/>
                 </a:solidFill>
@@ -16057,13 +14854,13 @@
                 <a:ea typeface="Arial" pitchFamily="34" charset="-122"/>
                 <a:cs typeface="Arial" pitchFamily="34" charset="-120"/>
               </a:rPr>
-              <a:t>The maps exist either way. </a:t>
+              <a:t>$7,100 in, $627,000 out — an 88× return, at $229 per signed roof. </a:t>
             </a:r>
             <a:pPr indent="0" marL="0">
               <a:buNone/>
             </a:pPr>
             <a:r>
-              <a:rPr lang="en-US" sz="1500" dirty="0">
+              <a:rPr lang="en-US" sz="1350" dirty="0">
                 <a:solidFill>
                   <a:srgbClr val="E6E6E6"/>
                 </a:solidFill>
@@ -16071,15 +14868,15 @@
                 <a:ea typeface="Arial" pitchFamily="34" charset="-122"/>
                 <a:cs typeface="Arial" pitchFamily="34" charset="-120"/>
               </a:rPr>
-              <a:t>The only question is whether T^Rock or a competitor is holding them when the next storm hits.</a:t>
-            </a:r>
-            <a:endParaRPr lang="en-US" sz="1500" dirty="0"/>
-          </a:p>
-        </p:txBody>
-      </p:sp>
-      <p:sp>
-        <p:nvSpPr>
-          <p:cNvPr id="22" name="Text 16"/>
+              <a:t>That's the benchmark our 90-day scorecard is aiming at.</a:t>
+            </a:r>
+            <a:endParaRPr lang="en-US" sz="1350" dirty="0"/>
+          </a:p>
+        </p:txBody>
+      </p:sp>
+      <p:sp>
+        <p:nvSpPr>
+          <p:cNvPr id="33" name="Text 28"/>
           <p:cNvSpPr/>
           <p:nvPr/>
         </p:nvSpPr>
@@ -16110,7 +14907,7 @@
                 <a:ea typeface="Arial" pitchFamily="34" charset="-122"/>
                 <a:cs typeface="Arial" pitchFamily="34" charset="-120"/>
               </a:rPr>
-              <a:t>T^Rock half = (gross profit − lead fee) ÷ 2 (50/50 PM split). Lead fee shown at the 2% floor. Any shared-lead or ad spend this replaces is a direct offset on top.</a:t>
+              <a:t>Operator-reported figures shared with us directly; company name withheld at their request. 128 selling days followed a 30-day ramp — roughly their first 4 months on the system.</a:t>
             </a:r>
             <a:endParaRPr lang="en-US" sz="900" dirty="0"/>
           </a:p>
@@ -16118,7 +14915,7 @@
       </p:sp>
       <p:sp>
         <p:nvSpPr>
-          <p:cNvPr id="23" name="Text 17"/>
+          <p:cNvPr id="34" name="Text 29"/>
           <p:cNvSpPr/>
           <p:nvPr/>
         </p:nvSpPr>

</xml_diff>

<commit_message>
Add expectations slide projecting Company A rates onto T^Rock
New slide 10: what the first five months look like - a 30-day ramp
then production timeline, and a par-vs-half-rate table applying
Company A's funnel (3.3% call-to-inspection, 29.5% inspection-to-sign)
to T^Rock's $30,000 ticket at the same 2-dialer effort: ~31 roofs /
~$149k net at par, ~15 roofs / ~$67k net at half rate - still 6x the
subscription. Later slides renumbered.

Co-Authored-By: Claude Fable 5 <noreply@anthropic.com>
Claude-Session: https://claude.ai/code/session_01Qj1b2D7LVH4xves4mfA9FY
</commit_message>
<xml_diff>
--- a/pitch/Storm-Scout-Pitch.pptx
+++ b/pitch/Storm-Scout-Pitch.pptx
@@ -17,9 +17,10 @@
     <p:sldId id="265" r:id="rId11"/>
     <p:sldId id="266" r:id="rId12"/>
     <p:sldId id="267" r:id="rId13"/>
+    <p:sldId id="268" r:id="rId14"/>
   </p:sldIdLst>
   <p:notesMasterIdLst>
-    <p:notesMasterId r:id="rId14"/>
+    <p:notesMasterId r:id="rId15"/>
   </p:notesMasterIdLst>
   <p:sldSz cx="12192000" cy="6858000"/>
   <p:notesSz cx="6858000" cy="12192000"/>
@@ -801,6 +802,94 @@
             <a:fld id="{F7021451-1387-4CA6-816F-3879F97B5CBC}" type="slidenum">
               <a:rPr lang="en-US"/>
               <a:t>12</a:t>
+            </a:fld>
+            <a:endParaRPr lang="en-US"/>
+          </a:p>
+        </p:txBody>
+      </p:sp>
+    </p:spTree>
+    <p:extLst>
+      <p:ext uri="{BB962C8B-B14F-4D97-AF65-F5344CB8AC3E}">
+        <p14:creationId xmlns:p14="http://schemas.microsoft.com/office/powerpoint/2010/main" val="1024086991"/>
+      </p:ext>
+    </p:extLst>
+  </p:cSld>
+  <p:clrMapOvr>
+    <a:masterClrMapping/>
+  </p:clrMapOvr>
+</p:notes>
+</file>
+
+<file path=ppt/notesSlides/notesSlide13.xml><?xml version="1.0" encoding="utf-8"?>
+<p:notes xmlns:a="http://schemas.openxmlformats.org/drawingml/2006/main" xmlns:r="http://schemas.openxmlformats.org/officeDocument/2006/relationships" xmlns:p="http://schemas.openxmlformats.org/presentationml/2006/main">
+  <p:cSld>
+    <p:spTree>
+      <p:nvGrpSpPr>
+        <p:cNvPr id="1" name=""/>
+        <p:cNvGrpSpPr/>
+        <p:nvPr/>
+      </p:nvGrpSpPr>
+      <p:grpSpPr>
+        <a:xfrm>
+          <a:off x="0" y="0"/>
+          <a:ext cx="0" cy="0"/>
+          <a:chOff x="0" y="0"/>
+          <a:chExt cx="0" cy="0"/>
+        </a:xfrm>
+      </p:grpSpPr>
+      <p:sp>
+        <p:nvSpPr>
+          <p:cNvPr id="2" name="Slide Image Placeholder 1"/>
+          <p:cNvSpPr>
+            <a:spLocks noGrp="1" noRot="1" noChangeAspect="1"/>
+          </p:cNvSpPr>
+          <p:nvPr>
+            <p:ph type="sldImg"/>
+          </p:nvPr>
+        </p:nvSpPr>
+        <p:spPr/>
+      </p:sp>
+      <p:sp>
+        <p:nvSpPr>
+          <p:cNvPr id="3" name="Notes Placeholder 2"/>
+          <p:cNvSpPr>
+            <a:spLocks noGrp="1"/>
+          </p:cNvSpPr>
+          <p:nvPr>
+            <p:ph type="body" idx="1"/>
+          </p:nvPr>
+        </p:nvSpPr>
+        <p:spPr/>
+        <p:txBody>
+          <a:bodyPr/>
+          <a:lstStyle/>
+          <a:p>
+            <a:r>
+              <a:rPr lang="en-US" dirty="0"/>
+              <a:t/>
+            </a:r>
+            <a:endParaRPr lang="en-US" dirty="0"/>
+          </a:p>
+        </p:txBody>
+      </p:sp>
+      <p:sp>
+        <p:nvSpPr>
+          <p:cNvPr id="4" name="Slide Number Placeholder 3"/>
+          <p:cNvSpPr>
+            <a:spLocks noGrp="1"/>
+          </p:cNvSpPr>
+          <p:nvPr>
+            <p:ph type="sldNum" sz="quarter" idx="10"/>
+          </p:nvPr>
+        </p:nvSpPr>
+        <p:spPr/>
+        <p:txBody>
+          <a:bodyPr/>
+          <a:lstStyle/>
+          <a:p>
+            <a:fld id="{F7021451-1387-4CA6-816F-3879F97B5CBC}" type="slidenum">
+              <a:rPr lang="en-US"/>
+              <a:t>13</a:t>
             </a:fld>
             <a:endParaRPr lang="en-US"/>
           </a:p>
@@ -2113,7 +2202,7 @@
                 <a:ea typeface="Arial" pitchFamily="34" charset="-122"/>
                 <a:cs typeface="Arial" pitchFamily="34" charset="-120"/>
               </a:rPr>
-              <a:t>The 90-day proof period: scored, capped, killable</a:t>
+              <a:t>What T^Rock can expect: the first five months</a:t>
             </a:r>
             <a:endParaRPr lang="en-US" sz="3200" dirty="0"/>
           </a:p>
@@ -2152,15 +2241,1839 @@
                 <a:ea typeface="Arial" pitchFamily="34" charset="-122"/>
                 <a:cs typeface="Arial" pitchFamily="34" charset="-120"/>
               </a:rPr>
-              <a:t>Full team goes live on Founding day 1 — but 2 reps keep the current playbook as the control, so the comparison stays honest.</a:t>
+              <a:t>Company A's observed funnel, applied to T^Rock's ticket at the same effort level — 2 dialers, ~12 dials a day each.</a:t>
             </a:r>
             <a:endParaRPr lang="en-US" sz="1500" dirty="0"/>
+          </a:p>
+        </p:txBody>
+      </p:sp>
+      <p:sp>
+        <p:nvSpPr>
+          <p:cNvPr id="4" name="Shape 2"/>
+          <p:cNvSpPr/>
+          <p:nvPr/>
+        </p:nvSpPr>
+        <p:spPr>
+          <a:xfrm>
+            <a:off x="548640" y="1737360"/>
+            <a:ext cx="4206240" cy="1097280"/>
+          </a:xfrm>
+          <a:prstGeom prst="roundRect">
+            <a:avLst>
+              <a:gd name="adj" fmla="val 6667"/>
+            </a:avLst>
+          </a:prstGeom>
+          <a:solidFill>
+            <a:srgbClr val="F5F5F5"/>
+          </a:solidFill>
+          <a:ln/>
+        </p:spPr>
+      </p:sp>
+      <p:sp>
+        <p:nvSpPr>
+          <p:cNvPr id="5" name="Text 3"/>
+          <p:cNvSpPr/>
+          <p:nvPr/>
+        </p:nvSpPr>
+        <p:spPr>
+          <a:xfrm>
+            <a:off x="822960" y="1828800"/>
+            <a:ext cx="3657600" cy="457200"/>
+          </a:xfrm>
+          <a:prstGeom prst="rect">
+            <a:avLst/>
+          </a:prstGeom>
+          <a:noFill/>
+          <a:ln/>
+        </p:spPr>
+        <p:txBody>
+          <a:bodyPr wrap="square" lIns="0" tIns="0" rIns="0" bIns="0" rtlCol="0" anchor="ctr"/>
+          <a:lstStyle/>
+          <a:p>
+            <a:pPr indent="0" marL="0">
+              <a:buNone/>
+            </a:pPr>
+            <a:r>
+              <a:rPr lang="en-US" sz="1250" b="1" dirty="0">
+                <a:solidFill>
+                  <a:srgbClr val="C8102E"/>
+                </a:solidFill>
+                <a:latin typeface="Arial" pitchFamily="34" charset="0"/>
+                <a:ea typeface="Arial" pitchFamily="34" charset="-122"/>
+                <a:cs typeface="Arial" pitchFamily="34" charset="-120"/>
+              </a:rPr>
+              <a:t>Days 0–30 — Ramp</a:t>
+            </a:r>
+            <a:endParaRPr lang="en-US" sz="1250" dirty="0"/>
+          </a:p>
+        </p:txBody>
+      </p:sp>
+      <p:sp>
+        <p:nvSpPr>
+          <p:cNvPr id="6" name="Text 4"/>
+          <p:cNvSpPr/>
+          <p:nvPr/>
+        </p:nvSpPr>
+        <p:spPr>
+          <a:xfrm>
+            <a:off x="822960" y="2267712"/>
+            <a:ext cx="3657600" cy="530352"/>
+          </a:xfrm>
+          <a:prstGeom prst="rect">
+            <a:avLst/>
+          </a:prstGeom>
+          <a:noFill/>
+          <a:ln/>
+        </p:spPr>
+        <p:txBody>
+          <a:bodyPr wrap="square" lIns="0" tIns="0" rIns="0" bIns="0" rtlCol="0" anchor="ctr"/>
+          <a:lstStyle/>
+          <a:p>
+            <a:pPr indent="0" marL="0">
+              <a:buNone/>
+            </a:pPr>
+            <a:r>
+              <a:rPr lang="en-US" sz="1050" dirty="0">
+                <a:solidFill>
+                  <a:srgbClr val="2A2A2A"/>
+                </a:solidFill>
+                <a:latin typeface="Arial" pitchFamily="34" charset="0"/>
+                <a:ea typeface="Arial" pitchFamily="34" charset="-122"/>
+                <a:cs typeface="Arial" pitchFamily="34" charset="-120"/>
+              </a:rPr>
+              <a:t>Lists built, territories set, dialers trained. Expect $0 signed. Company A saw the same.</a:t>
+            </a:r>
+            <a:endParaRPr lang="en-US" sz="1050" dirty="0"/>
+          </a:p>
+        </p:txBody>
+      </p:sp>
+      <p:sp>
+        <p:nvSpPr>
+          <p:cNvPr id="7" name="Shape 5"/>
+          <p:cNvSpPr/>
+          <p:nvPr/>
+        </p:nvSpPr>
+        <p:spPr>
+          <a:xfrm>
+            <a:off x="548640" y="2971800"/>
+            <a:ext cx="4206240" cy="1097280"/>
+          </a:xfrm>
+          <a:prstGeom prst="roundRect">
+            <a:avLst>
+              <a:gd name="adj" fmla="val 6667"/>
+            </a:avLst>
+          </a:prstGeom>
+          <a:solidFill>
+            <a:srgbClr val="F5F5F5"/>
+          </a:solidFill>
+          <a:ln/>
+        </p:spPr>
+      </p:sp>
+      <p:sp>
+        <p:nvSpPr>
+          <p:cNvPr id="8" name="Text 6"/>
+          <p:cNvSpPr/>
+          <p:nvPr/>
+        </p:nvSpPr>
+        <p:spPr>
+          <a:xfrm>
+            <a:off x="822960" y="3063240"/>
+            <a:ext cx="3657600" cy="457200"/>
+          </a:xfrm>
+          <a:prstGeom prst="rect">
+            <a:avLst/>
+          </a:prstGeom>
+          <a:noFill/>
+          <a:ln/>
+        </p:spPr>
+        <p:txBody>
+          <a:bodyPr wrap="square" lIns="0" tIns="0" rIns="0" bIns="0" rtlCol="0" anchor="ctr"/>
+          <a:lstStyle/>
+          <a:p>
+            <a:pPr indent="0" marL="0">
+              <a:buNone/>
+            </a:pPr>
+            <a:r>
+              <a:rPr lang="en-US" sz="1250" b="1" dirty="0">
+                <a:solidFill>
+                  <a:srgbClr val="C8102E"/>
+                </a:solidFill>
+                <a:latin typeface="Arial" pitchFamily="34" charset="0"/>
+                <a:ea typeface="Arial" pitchFamily="34" charset="-122"/>
+                <a:cs typeface="Arial" pitchFamily="34" charset="-120"/>
+              </a:rPr>
+              <a:t>Days 31–150 — Production</a:t>
+            </a:r>
+            <a:endParaRPr lang="en-US" sz="1250" dirty="0"/>
+          </a:p>
+        </p:txBody>
+      </p:sp>
+      <p:sp>
+        <p:nvSpPr>
+          <p:cNvPr id="9" name="Text 7"/>
+          <p:cNvSpPr/>
+          <p:nvPr/>
+        </p:nvSpPr>
+        <p:spPr>
+          <a:xfrm>
+            <a:off x="822960" y="3502152"/>
+            <a:ext cx="3657600" cy="530352"/>
+          </a:xfrm>
+          <a:prstGeom prst="rect">
+            <a:avLst/>
+          </a:prstGeom>
+          <a:noFill/>
+          <a:ln/>
+        </p:spPr>
+        <p:txBody>
+          <a:bodyPr wrap="square" lIns="0" tIns="0" rIns="0" bIns="0" rtlCol="0" anchor="ctr"/>
+          <a:lstStyle/>
+          <a:p>
+            <a:pPr indent="0" marL="0">
+              <a:buNone/>
+            </a:pPr>
+            <a:r>
+              <a:rPr lang="en-US" sz="1050" dirty="0">
+                <a:solidFill>
+                  <a:srgbClr val="2A2A2A"/>
+                </a:solidFill>
+                <a:latin typeface="Arial" pitchFamily="34" charset="0"/>
+                <a:ea typeface="Arial" pitchFamily="34" charset="-122"/>
+                <a:cs typeface="Arial" pitchFamily="34" charset="-120"/>
+              </a:rPr>
+              <a:t>Steady dialing on verified-damage lists. Inspections start booking within the first weeks of calling.</a:t>
+            </a:r>
+            <a:endParaRPr lang="en-US" sz="1050" dirty="0"/>
+          </a:p>
+        </p:txBody>
+      </p:sp>
+      <p:sp>
+        <p:nvSpPr>
+          <p:cNvPr id="10" name="Shape 8"/>
+          <p:cNvSpPr/>
+          <p:nvPr/>
+        </p:nvSpPr>
+        <p:spPr>
+          <a:xfrm>
+            <a:off x="548640" y="4206240"/>
+            <a:ext cx="4206240" cy="1097280"/>
+          </a:xfrm>
+          <a:prstGeom prst="roundRect">
+            <a:avLst>
+              <a:gd name="adj" fmla="val 6667"/>
+            </a:avLst>
+          </a:prstGeom>
+          <a:solidFill>
+            <a:srgbClr val="111111"/>
+          </a:solidFill>
+          <a:ln/>
+        </p:spPr>
+      </p:sp>
+      <p:sp>
+        <p:nvSpPr>
+          <p:cNvPr id="11" name="Text 9"/>
+          <p:cNvSpPr/>
+          <p:nvPr/>
+        </p:nvSpPr>
+        <p:spPr>
+          <a:xfrm>
+            <a:off x="822960" y="4297680"/>
+            <a:ext cx="3657600" cy="457200"/>
+          </a:xfrm>
+          <a:prstGeom prst="rect">
+            <a:avLst/>
+          </a:prstGeom>
+          <a:noFill/>
+          <a:ln/>
+        </p:spPr>
+        <p:txBody>
+          <a:bodyPr wrap="square" lIns="0" tIns="0" rIns="0" bIns="0" rtlCol="0" anchor="ctr"/>
+          <a:lstStyle/>
+          <a:p>
+            <a:pPr indent="0" marL="0">
+              <a:buNone/>
+            </a:pPr>
+            <a:r>
+              <a:rPr lang="en-US" sz="1250" b="1" dirty="0">
+                <a:solidFill>
+                  <a:srgbClr val="C8102E"/>
+                </a:solidFill>
+                <a:latin typeface="Arial" pitchFamily="34" charset="0"/>
+                <a:ea typeface="Arial" pitchFamily="34" charset="-122"/>
+                <a:cs typeface="Arial" pitchFamily="34" charset="-120"/>
+              </a:rPr>
+              <a:t>Day ~120 of production — Decision</a:t>
+            </a:r>
+            <a:endParaRPr lang="en-US" sz="1250" dirty="0"/>
+          </a:p>
+        </p:txBody>
+      </p:sp>
+      <p:sp>
+        <p:nvSpPr>
+          <p:cNvPr id="12" name="Text 10"/>
+          <p:cNvSpPr/>
+          <p:nvPr/>
+        </p:nvSpPr>
+        <p:spPr>
+          <a:xfrm>
+            <a:off x="822960" y="4736592"/>
+            <a:ext cx="3657600" cy="530352"/>
+          </a:xfrm>
+          <a:prstGeom prst="rect">
+            <a:avLst/>
+          </a:prstGeom>
+          <a:noFill/>
+          <a:ln/>
+        </p:spPr>
+        <p:txBody>
+          <a:bodyPr wrap="square" lIns="0" tIns="0" rIns="0" bIns="0" rtlCol="0" anchor="ctr"/>
+          <a:lstStyle/>
+          <a:p>
+            <a:pPr indent="0" marL="0">
+              <a:buNone/>
+            </a:pPr>
+            <a:r>
+              <a:rPr lang="en-US" sz="1050" dirty="0">
+                <a:solidFill>
+                  <a:srgbClr val="E0E0E0"/>
+                </a:solidFill>
+                <a:latin typeface="Arial" pitchFamily="34" charset="0"/>
+                <a:ea typeface="Arial" pitchFamily="34" charset="-122"/>
+                <a:cs typeface="Arial" pitchFamily="34" charset="-120"/>
+              </a:rPr>
+              <a:t>Scorecard vs. this table. Beat the half-rate column and it stays; beat par and it scales.</a:t>
+            </a:r>
+            <a:endParaRPr lang="en-US" sz="1050" dirty="0"/>
           </a:p>
         </p:txBody>
       </p:sp>
       <p:graphicFrame>
         <p:nvGraphicFramePr>
           <p:cNvPr id="11" name="Table 0"/>
+          <p:cNvGraphicFramePr>
+            <a:graphicFrameLocks noGrp="1"/>
+          </p:cNvGraphicFramePr>
+          <p:nvPr>
+            <p:extLst>
+              <p:ext uri="{D42A27DB-BD31-4B8C-83A1-F6EECF244321}">
+                <p14:modId xmlns:p14="http://schemas.microsoft.com/office/powerpoint/2010/main" val="1579011935"/>
+              </p:ext>
+            </p:extLst>
+          </p:nvPr>
+        </p:nvGraphicFramePr>
+        <p:xfrm>
+          <a:off x="5029200" y="1737360"/>
+          <a:ext cx="6583680" cy="914400"/>
+        </p:xfrm>
+        <a:graphic>
+          <a:graphicData uri="http://schemas.openxmlformats.org/drawingml/2006/table">
+            <a:tbl>
+              <a:tblPr/>
+              <a:tblGrid>
+                <a:gridCol w="2651760"/>
+                <a:gridCol w="2011680"/>
+                <a:gridCol w="1920240"/>
+              </a:tblGrid>
+              <a:tr h="457200">
+                <a:tc>
+                  <a:txBody>
+                    <a:bodyPr/>
+                    <a:lstStyle/>
+                    <a:p>
+                      <a:pPr algn="ctr" indent="0" marL="0">
+                        <a:buNone/>
+                      </a:pPr>
+                      <a:r>
+                        <a:rPr lang="en-US" sz="1200" b="1" dirty="0">
+                          <a:solidFill>
+                            <a:srgbClr val="FFFFFF"/>
+                          </a:solidFill>
+                          <a:latin typeface="Arial" pitchFamily="34" charset="0"/>
+                          <a:ea typeface="Arial" pitchFamily="34" charset="-122"/>
+                          <a:cs typeface="Arial" pitchFamily="34" charset="-120"/>
+                        </a:rPr>
+                        <a:t>First ~5 months</a:t>
+                      </a:r>
+                      <a:endParaRPr lang="en-US" sz="1200" dirty="0">
+                        <a:latin typeface="Arial" charset="0"/>
+                        <a:ea typeface="Arial" charset="0"/>
+                        <a:cs typeface="Arial" charset="0"/>
+                      </a:endParaRPr>
+                    </a:p>
+                  </a:txBody>
+                  <a:tcPr marL="64008" marR="64008" marT="64008" marB="64008" anchor="ctr">
+                    <a:lnL w="9525" cap="flat" cmpd="sng" algn="ctr">
+                      <a:solidFill>
+                        <a:srgbClr val="DDDDDD"/>
+                      </a:solidFill>
+                      <a:prstDash val="solid"/>
+                      <a:round/>
+                      <a:headEnd type="none" w="med" len="med"/>
+                      <a:tailEnd type="none" w="med" len="med"/>
+                    </a:lnL>
+                    <a:lnR w="9525" cap="flat" cmpd="sng" algn="ctr">
+                      <a:solidFill>
+                        <a:srgbClr val="DDDDDD"/>
+                      </a:solidFill>
+                      <a:prstDash val="solid"/>
+                      <a:round/>
+                      <a:headEnd type="none" w="med" len="med"/>
+                      <a:tailEnd type="none" w="med" len="med"/>
+                    </a:lnR>
+                    <a:lnT w="9525" cap="flat" cmpd="sng" algn="ctr">
+                      <a:solidFill>
+                        <a:srgbClr val="DDDDDD"/>
+                      </a:solidFill>
+                      <a:prstDash val="solid"/>
+                      <a:round/>
+                      <a:headEnd type="none" w="med" len="med"/>
+                      <a:tailEnd type="none" w="med" len="med"/>
+                    </a:lnT>
+                    <a:lnB w="9525" cap="flat" cmpd="sng" algn="ctr">
+                      <a:solidFill>
+                        <a:srgbClr val="DDDDDD"/>
+                      </a:solidFill>
+                      <a:prstDash val="solid"/>
+                      <a:round/>
+                      <a:headEnd type="none" w="med" len="med"/>
+                      <a:tailEnd type="none" w="med" len="med"/>
+                    </a:lnB>
+                    <a:solidFill>
+                      <a:srgbClr val="111111"/>
+                    </a:solidFill>
+                  </a:tcPr>
+                </a:tc>
+                <a:tc>
+                  <a:txBody>
+                    <a:bodyPr/>
+                    <a:lstStyle/>
+                    <a:p>
+                      <a:pPr algn="ctr" indent="0" marL="0">
+                        <a:buNone/>
+                      </a:pPr>
+                      <a:r>
+                        <a:rPr lang="en-US" sz="1200" b="1" dirty="0">
+                          <a:solidFill>
+                            <a:srgbClr val="FFFFFF"/>
+                          </a:solidFill>
+                          <a:latin typeface="Arial" pitchFamily="34" charset="0"/>
+                          <a:ea typeface="Arial" pitchFamily="34" charset="-122"/>
+                          <a:cs typeface="Arial" pitchFamily="34" charset="-120"/>
+                        </a:rPr>
+                        <a:t>At Company A's rates</a:t>
+                      </a:r>
+                      <a:endParaRPr lang="en-US" sz="1200" dirty="0">
+                        <a:latin typeface="Arial" charset="0"/>
+                        <a:ea typeface="Arial" charset="0"/>
+                        <a:cs typeface="Arial" charset="0"/>
+                      </a:endParaRPr>
+                    </a:p>
+                  </a:txBody>
+                  <a:tcPr marL="64008" marR="64008" marT="64008" marB="64008" anchor="ctr">
+                    <a:lnL w="9525" cap="flat" cmpd="sng" algn="ctr">
+                      <a:solidFill>
+                        <a:srgbClr val="DDDDDD"/>
+                      </a:solidFill>
+                      <a:prstDash val="solid"/>
+                      <a:round/>
+                      <a:headEnd type="none" w="med" len="med"/>
+                      <a:tailEnd type="none" w="med" len="med"/>
+                    </a:lnL>
+                    <a:lnR w="9525" cap="flat" cmpd="sng" algn="ctr">
+                      <a:solidFill>
+                        <a:srgbClr val="DDDDDD"/>
+                      </a:solidFill>
+                      <a:prstDash val="solid"/>
+                      <a:round/>
+                      <a:headEnd type="none" w="med" len="med"/>
+                      <a:tailEnd type="none" w="med" len="med"/>
+                    </a:lnR>
+                    <a:lnT w="9525" cap="flat" cmpd="sng" algn="ctr">
+                      <a:solidFill>
+                        <a:srgbClr val="DDDDDD"/>
+                      </a:solidFill>
+                      <a:prstDash val="solid"/>
+                      <a:round/>
+                      <a:headEnd type="none" w="med" len="med"/>
+                      <a:tailEnd type="none" w="med" len="med"/>
+                    </a:lnT>
+                    <a:lnB w="9525" cap="flat" cmpd="sng" algn="ctr">
+                      <a:solidFill>
+                        <a:srgbClr val="DDDDDD"/>
+                      </a:solidFill>
+                      <a:prstDash val="solid"/>
+                      <a:round/>
+                      <a:headEnd type="none" w="med" len="med"/>
+                      <a:tailEnd type="none" w="med" len="med"/>
+                    </a:lnB>
+                    <a:solidFill>
+                      <a:srgbClr val="111111"/>
+                    </a:solidFill>
+                  </a:tcPr>
+                </a:tc>
+                <a:tc>
+                  <a:txBody>
+                    <a:bodyPr/>
+                    <a:lstStyle/>
+                    <a:p>
+                      <a:pPr algn="ctr" indent="0" marL="0">
+                        <a:buNone/>
+                      </a:pPr>
+                      <a:r>
+                        <a:rPr lang="en-US" sz="1200" b="1" dirty="0">
+                          <a:solidFill>
+                            <a:srgbClr val="FFFFFF"/>
+                          </a:solidFill>
+                          <a:latin typeface="Arial" pitchFamily="34" charset="0"/>
+                          <a:ea typeface="Arial" pitchFamily="34" charset="-122"/>
+                          <a:cs typeface="Arial" pitchFamily="34" charset="-120"/>
+                        </a:rPr>
+                        <a:t>At HALF their rates</a:t>
+                      </a:r>
+                      <a:endParaRPr lang="en-US" sz="1200" dirty="0">
+                        <a:latin typeface="Arial" charset="0"/>
+                        <a:ea typeface="Arial" charset="0"/>
+                        <a:cs typeface="Arial" charset="0"/>
+                      </a:endParaRPr>
+                    </a:p>
+                  </a:txBody>
+                  <a:tcPr marL="64008" marR="64008" marT="64008" marB="64008" anchor="ctr">
+                    <a:lnL w="9525" cap="flat" cmpd="sng" algn="ctr">
+                      <a:solidFill>
+                        <a:srgbClr val="DDDDDD"/>
+                      </a:solidFill>
+                      <a:prstDash val="solid"/>
+                      <a:round/>
+                      <a:headEnd type="none" w="med" len="med"/>
+                      <a:tailEnd type="none" w="med" len="med"/>
+                    </a:lnL>
+                    <a:lnR w="9525" cap="flat" cmpd="sng" algn="ctr">
+                      <a:solidFill>
+                        <a:srgbClr val="DDDDDD"/>
+                      </a:solidFill>
+                      <a:prstDash val="solid"/>
+                      <a:round/>
+                      <a:headEnd type="none" w="med" len="med"/>
+                      <a:tailEnd type="none" w="med" len="med"/>
+                    </a:lnR>
+                    <a:lnT w="9525" cap="flat" cmpd="sng" algn="ctr">
+                      <a:solidFill>
+                        <a:srgbClr val="DDDDDD"/>
+                      </a:solidFill>
+                      <a:prstDash val="solid"/>
+                      <a:round/>
+                      <a:headEnd type="none" w="med" len="med"/>
+                      <a:tailEnd type="none" w="med" len="med"/>
+                    </a:lnT>
+                    <a:lnB w="9525" cap="flat" cmpd="sng" algn="ctr">
+                      <a:solidFill>
+                        <a:srgbClr val="DDDDDD"/>
+                      </a:solidFill>
+                      <a:prstDash val="solid"/>
+                      <a:round/>
+                      <a:headEnd type="none" w="med" len="med"/>
+                      <a:tailEnd type="none" w="med" len="med"/>
+                    </a:lnB>
+                    <a:solidFill>
+                      <a:srgbClr val="111111"/>
+                    </a:solidFill>
+                  </a:tcPr>
+                </a:tc>
+              </a:tr>
+              <a:tr h="411480">
+                <a:tc>
+                  <a:txBody>
+                    <a:bodyPr/>
+                    <a:lstStyle/>
+                    <a:p>
+                      <a:pPr indent="0" marL="0">
+                        <a:buNone/>
+                      </a:pPr>
+                      <a:r>
+                        <a:rPr lang="en-US" sz="1200" b="1" dirty="0">
+                          <a:solidFill>
+                            <a:srgbClr val="111111"/>
+                          </a:solidFill>
+                          <a:latin typeface="Arial" pitchFamily="34" charset="0"/>
+                          <a:ea typeface="Arial" pitchFamily="34" charset="-122"/>
+                          <a:cs typeface="Arial" pitchFamily="34" charset="-120"/>
+                        </a:rPr>
+                        <a:t>Homeowners called</a:t>
+                      </a:r>
+                      <a:endParaRPr lang="en-US" sz="1200" dirty="0">
+                        <a:latin typeface="Arial" charset="0"/>
+                        <a:ea typeface="Arial" charset="0"/>
+                        <a:cs typeface="Arial" charset="0"/>
+                      </a:endParaRPr>
+                    </a:p>
+                  </a:txBody>
+                  <a:tcPr marL="64008" marR="64008" marT="64008" marB="64008" anchor="ctr">
+                    <a:lnL w="9525" cap="flat" cmpd="sng" algn="ctr">
+                      <a:solidFill>
+                        <a:srgbClr val="DDDDDD"/>
+                      </a:solidFill>
+                      <a:prstDash val="solid"/>
+                      <a:round/>
+                      <a:headEnd type="none" w="med" len="med"/>
+                      <a:tailEnd type="none" w="med" len="med"/>
+                    </a:lnL>
+                    <a:lnR w="9525" cap="flat" cmpd="sng" algn="ctr">
+                      <a:solidFill>
+                        <a:srgbClr val="DDDDDD"/>
+                      </a:solidFill>
+                      <a:prstDash val="solid"/>
+                      <a:round/>
+                      <a:headEnd type="none" w="med" len="med"/>
+                      <a:tailEnd type="none" w="med" len="med"/>
+                    </a:lnR>
+                    <a:lnT w="9525" cap="flat" cmpd="sng" algn="ctr">
+                      <a:solidFill>
+                        <a:srgbClr val="DDDDDD"/>
+                      </a:solidFill>
+                      <a:prstDash val="solid"/>
+                      <a:round/>
+                      <a:headEnd type="none" w="med" len="med"/>
+                      <a:tailEnd type="none" w="med" len="med"/>
+                    </a:lnT>
+                    <a:lnB w="9525" cap="flat" cmpd="sng" algn="ctr">
+                      <a:solidFill>
+                        <a:srgbClr val="DDDDDD"/>
+                      </a:solidFill>
+                      <a:prstDash val="solid"/>
+                      <a:round/>
+                      <a:headEnd type="none" w="med" len="med"/>
+                      <a:tailEnd type="none" w="med" len="med"/>
+                    </a:lnB>
+                  </a:tcPr>
+                </a:tc>
+                <a:tc>
+                  <a:txBody>
+                    <a:bodyPr/>
+                    <a:lstStyle/>
+                    <a:p>
+                      <a:pPr algn="ctr" indent="0" marL="0">
+                        <a:buNone/>
+                      </a:pPr>
+                      <a:r>
+                        <a:rPr lang="en-US" sz="1250" dirty="0">
+                          <a:solidFill>
+                            <a:srgbClr val="2A2A2A"/>
+                          </a:solidFill>
+                          <a:latin typeface="Arial" pitchFamily="34" charset="0"/>
+                          <a:ea typeface="Arial" pitchFamily="34" charset="-122"/>
+                          <a:cs typeface="Arial" pitchFamily="34" charset="-120"/>
+                        </a:rPr>
+                        <a:t>~3,200</a:t>
+                      </a:r>
+                      <a:endParaRPr lang="en-US" sz="1250" dirty="0">
+                        <a:latin typeface="Arial" charset="0"/>
+                        <a:ea typeface="Arial" charset="0"/>
+                        <a:cs typeface="Arial" charset="0"/>
+                      </a:endParaRPr>
+                    </a:p>
+                  </a:txBody>
+                  <a:tcPr marL="64008" marR="64008" marT="64008" marB="64008" anchor="ctr">
+                    <a:lnL w="9525" cap="flat" cmpd="sng" algn="ctr">
+                      <a:solidFill>
+                        <a:srgbClr val="DDDDDD"/>
+                      </a:solidFill>
+                      <a:prstDash val="solid"/>
+                      <a:round/>
+                      <a:headEnd type="none" w="med" len="med"/>
+                      <a:tailEnd type="none" w="med" len="med"/>
+                    </a:lnL>
+                    <a:lnR w="9525" cap="flat" cmpd="sng" algn="ctr">
+                      <a:solidFill>
+                        <a:srgbClr val="DDDDDD"/>
+                      </a:solidFill>
+                      <a:prstDash val="solid"/>
+                      <a:round/>
+                      <a:headEnd type="none" w="med" len="med"/>
+                      <a:tailEnd type="none" w="med" len="med"/>
+                    </a:lnR>
+                    <a:lnT w="9525" cap="flat" cmpd="sng" algn="ctr">
+                      <a:solidFill>
+                        <a:srgbClr val="DDDDDD"/>
+                      </a:solidFill>
+                      <a:prstDash val="solid"/>
+                      <a:round/>
+                      <a:headEnd type="none" w="med" len="med"/>
+                      <a:tailEnd type="none" w="med" len="med"/>
+                    </a:lnT>
+                    <a:lnB w="9525" cap="flat" cmpd="sng" algn="ctr">
+                      <a:solidFill>
+                        <a:srgbClr val="DDDDDD"/>
+                      </a:solidFill>
+                      <a:prstDash val="solid"/>
+                      <a:round/>
+                      <a:headEnd type="none" w="med" len="med"/>
+                      <a:tailEnd type="none" w="med" len="med"/>
+                    </a:lnB>
+                  </a:tcPr>
+                </a:tc>
+                <a:tc>
+                  <a:txBody>
+                    <a:bodyPr/>
+                    <a:lstStyle/>
+                    <a:p>
+                      <a:pPr algn="ctr" indent="0" marL="0">
+                        <a:buNone/>
+                      </a:pPr>
+                      <a:r>
+                        <a:rPr lang="en-US" sz="1250" dirty="0">
+                          <a:solidFill>
+                            <a:srgbClr val="2A2A2A"/>
+                          </a:solidFill>
+                          <a:latin typeface="Arial" pitchFamily="34" charset="0"/>
+                          <a:ea typeface="Arial" pitchFamily="34" charset="-122"/>
+                          <a:cs typeface="Arial" pitchFamily="34" charset="-120"/>
+                        </a:rPr>
+                        <a:t>~3,200</a:t>
+                      </a:r>
+                      <a:endParaRPr lang="en-US" sz="1250" dirty="0">
+                        <a:latin typeface="Arial" charset="0"/>
+                        <a:ea typeface="Arial" charset="0"/>
+                        <a:cs typeface="Arial" charset="0"/>
+                      </a:endParaRPr>
+                    </a:p>
+                  </a:txBody>
+                  <a:tcPr marL="64008" marR="64008" marT="64008" marB="64008" anchor="ctr">
+                    <a:lnL w="9525" cap="flat" cmpd="sng" algn="ctr">
+                      <a:solidFill>
+                        <a:srgbClr val="DDDDDD"/>
+                      </a:solidFill>
+                      <a:prstDash val="solid"/>
+                      <a:round/>
+                      <a:headEnd type="none" w="med" len="med"/>
+                      <a:tailEnd type="none" w="med" len="med"/>
+                    </a:lnL>
+                    <a:lnR w="9525" cap="flat" cmpd="sng" algn="ctr">
+                      <a:solidFill>
+                        <a:srgbClr val="DDDDDD"/>
+                      </a:solidFill>
+                      <a:prstDash val="solid"/>
+                      <a:round/>
+                      <a:headEnd type="none" w="med" len="med"/>
+                      <a:tailEnd type="none" w="med" len="med"/>
+                    </a:lnR>
+                    <a:lnT w="9525" cap="flat" cmpd="sng" algn="ctr">
+                      <a:solidFill>
+                        <a:srgbClr val="DDDDDD"/>
+                      </a:solidFill>
+                      <a:prstDash val="solid"/>
+                      <a:round/>
+                      <a:headEnd type="none" w="med" len="med"/>
+                      <a:tailEnd type="none" w="med" len="med"/>
+                    </a:lnT>
+                    <a:lnB w="9525" cap="flat" cmpd="sng" algn="ctr">
+                      <a:solidFill>
+                        <a:srgbClr val="DDDDDD"/>
+                      </a:solidFill>
+                      <a:prstDash val="solid"/>
+                      <a:round/>
+                      <a:headEnd type="none" w="med" len="med"/>
+                      <a:tailEnd type="none" w="med" len="med"/>
+                    </a:lnB>
+                  </a:tcPr>
+                </a:tc>
+              </a:tr>
+              <a:tr h="411480">
+                <a:tc>
+                  <a:txBody>
+                    <a:bodyPr/>
+                    <a:lstStyle/>
+                    <a:p>
+                      <a:pPr indent="0" marL="0">
+                        <a:buNone/>
+                      </a:pPr>
+                      <a:r>
+                        <a:rPr lang="en-US" sz="1200" b="1" dirty="0">
+                          <a:solidFill>
+                            <a:srgbClr val="111111"/>
+                          </a:solidFill>
+                          <a:latin typeface="Arial" pitchFamily="34" charset="0"/>
+                          <a:ea typeface="Arial" pitchFamily="34" charset="-122"/>
+                          <a:cs typeface="Arial" pitchFamily="34" charset="-120"/>
+                        </a:rPr>
+                        <a:t>Inspections booked</a:t>
+                      </a:r>
+                      <a:endParaRPr lang="en-US" sz="1200" dirty="0">
+                        <a:latin typeface="Arial" charset="0"/>
+                        <a:ea typeface="Arial" charset="0"/>
+                        <a:cs typeface="Arial" charset="0"/>
+                      </a:endParaRPr>
+                    </a:p>
+                  </a:txBody>
+                  <a:tcPr marL="64008" marR="64008" marT="64008" marB="64008" anchor="ctr">
+                    <a:lnL w="9525" cap="flat" cmpd="sng" algn="ctr">
+                      <a:solidFill>
+                        <a:srgbClr val="DDDDDD"/>
+                      </a:solidFill>
+                      <a:prstDash val="solid"/>
+                      <a:round/>
+                      <a:headEnd type="none" w="med" len="med"/>
+                      <a:tailEnd type="none" w="med" len="med"/>
+                    </a:lnL>
+                    <a:lnR w="9525" cap="flat" cmpd="sng" algn="ctr">
+                      <a:solidFill>
+                        <a:srgbClr val="DDDDDD"/>
+                      </a:solidFill>
+                      <a:prstDash val="solid"/>
+                      <a:round/>
+                      <a:headEnd type="none" w="med" len="med"/>
+                      <a:tailEnd type="none" w="med" len="med"/>
+                    </a:lnR>
+                    <a:lnT w="9525" cap="flat" cmpd="sng" algn="ctr">
+                      <a:solidFill>
+                        <a:srgbClr val="DDDDDD"/>
+                      </a:solidFill>
+                      <a:prstDash val="solid"/>
+                      <a:round/>
+                      <a:headEnd type="none" w="med" len="med"/>
+                      <a:tailEnd type="none" w="med" len="med"/>
+                    </a:lnT>
+                    <a:lnB w="9525" cap="flat" cmpd="sng" algn="ctr">
+                      <a:solidFill>
+                        <a:srgbClr val="DDDDDD"/>
+                      </a:solidFill>
+                      <a:prstDash val="solid"/>
+                      <a:round/>
+                      <a:headEnd type="none" w="med" len="med"/>
+                      <a:tailEnd type="none" w="med" len="med"/>
+                    </a:lnB>
+                  </a:tcPr>
+                </a:tc>
+                <a:tc>
+                  <a:txBody>
+                    <a:bodyPr/>
+                    <a:lstStyle/>
+                    <a:p>
+                      <a:pPr algn="ctr" indent="0" marL="0">
+                        <a:buNone/>
+                      </a:pPr>
+                      <a:r>
+                        <a:rPr lang="en-US" sz="1250" dirty="0">
+                          <a:solidFill>
+                            <a:srgbClr val="2A2A2A"/>
+                          </a:solidFill>
+                          <a:latin typeface="Arial" pitchFamily="34" charset="0"/>
+                          <a:ea typeface="Arial" pitchFamily="34" charset="-122"/>
+                          <a:cs typeface="Arial" pitchFamily="34" charset="-120"/>
+                        </a:rPr>
+                        <a:t>~105</a:t>
+                      </a:r>
+                      <a:endParaRPr lang="en-US" sz="1250" dirty="0">
+                        <a:latin typeface="Arial" charset="0"/>
+                        <a:ea typeface="Arial" charset="0"/>
+                        <a:cs typeface="Arial" charset="0"/>
+                      </a:endParaRPr>
+                    </a:p>
+                  </a:txBody>
+                  <a:tcPr marL="64008" marR="64008" marT="64008" marB="64008" anchor="ctr">
+                    <a:lnL w="9525" cap="flat" cmpd="sng" algn="ctr">
+                      <a:solidFill>
+                        <a:srgbClr val="DDDDDD"/>
+                      </a:solidFill>
+                      <a:prstDash val="solid"/>
+                      <a:round/>
+                      <a:headEnd type="none" w="med" len="med"/>
+                      <a:tailEnd type="none" w="med" len="med"/>
+                    </a:lnL>
+                    <a:lnR w="9525" cap="flat" cmpd="sng" algn="ctr">
+                      <a:solidFill>
+                        <a:srgbClr val="DDDDDD"/>
+                      </a:solidFill>
+                      <a:prstDash val="solid"/>
+                      <a:round/>
+                      <a:headEnd type="none" w="med" len="med"/>
+                      <a:tailEnd type="none" w="med" len="med"/>
+                    </a:lnR>
+                    <a:lnT w="9525" cap="flat" cmpd="sng" algn="ctr">
+                      <a:solidFill>
+                        <a:srgbClr val="DDDDDD"/>
+                      </a:solidFill>
+                      <a:prstDash val="solid"/>
+                      <a:round/>
+                      <a:headEnd type="none" w="med" len="med"/>
+                      <a:tailEnd type="none" w="med" len="med"/>
+                    </a:lnT>
+                    <a:lnB w="9525" cap="flat" cmpd="sng" algn="ctr">
+                      <a:solidFill>
+                        <a:srgbClr val="DDDDDD"/>
+                      </a:solidFill>
+                      <a:prstDash val="solid"/>
+                      <a:round/>
+                      <a:headEnd type="none" w="med" len="med"/>
+                      <a:tailEnd type="none" w="med" len="med"/>
+                    </a:lnB>
+                  </a:tcPr>
+                </a:tc>
+                <a:tc>
+                  <a:txBody>
+                    <a:bodyPr/>
+                    <a:lstStyle/>
+                    <a:p>
+                      <a:pPr algn="ctr" indent="0" marL="0">
+                        <a:buNone/>
+                      </a:pPr>
+                      <a:r>
+                        <a:rPr lang="en-US" sz="1250" dirty="0">
+                          <a:solidFill>
+                            <a:srgbClr val="2A2A2A"/>
+                          </a:solidFill>
+                          <a:latin typeface="Arial" pitchFamily="34" charset="0"/>
+                          <a:ea typeface="Arial" pitchFamily="34" charset="-122"/>
+                          <a:cs typeface="Arial" pitchFamily="34" charset="-120"/>
+                        </a:rPr>
+                        <a:t>~53</a:t>
+                      </a:r>
+                      <a:endParaRPr lang="en-US" sz="1250" dirty="0">
+                        <a:latin typeface="Arial" charset="0"/>
+                        <a:ea typeface="Arial" charset="0"/>
+                        <a:cs typeface="Arial" charset="0"/>
+                      </a:endParaRPr>
+                    </a:p>
+                  </a:txBody>
+                  <a:tcPr marL="64008" marR="64008" marT="64008" marB="64008" anchor="ctr">
+                    <a:lnL w="9525" cap="flat" cmpd="sng" algn="ctr">
+                      <a:solidFill>
+                        <a:srgbClr val="DDDDDD"/>
+                      </a:solidFill>
+                      <a:prstDash val="solid"/>
+                      <a:round/>
+                      <a:headEnd type="none" w="med" len="med"/>
+                      <a:tailEnd type="none" w="med" len="med"/>
+                    </a:lnL>
+                    <a:lnR w="9525" cap="flat" cmpd="sng" algn="ctr">
+                      <a:solidFill>
+                        <a:srgbClr val="DDDDDD"/>
+                      </a:solidFill>
+                      <a:prstDash val="solid"/>
+                      <a:round/>
+                      <a:headEnd type="none" w="med" len="med"/>
+                      <a:tailEnd type="none" w="med" len="med"/>
+                    </a:lnR>
+                    <a:lnT w="9525" cap="flat" cmpd="sng" algn="ctr">
+                      <a:solidFill>
+                        <a:srgbClr val="DDDDDD"/>
+                      </a:solidFill>
+                      <a:prstDash val="solid"/>
+                      <a:round/>
+                      <a:headEnd type="none" w="med" len="med"/>
+                      <a:tailEnd type="none" w="med" len="med"/>
+                    </a:lnT>
+                    <a:lnB w="9525" cap="flat" cmpd="sng" algn="ctr">
+                      <a:solidFill>
+                        <a:srgbClr val="DDDDDD"/>
+                      </a:solidFill>
+                      <a:prstDash val="solid"/>
+                      <a:round/>
+                      <a:headEnd type="none" w="med" len="med"/>
+                      <a:tailEnd type="none" w="med" len="med"/>
+                    </a:lnB>
+                  </a:tcPr>
+                </a:tc>
+              </a:tr>
+              <a:tr h="411480">
+                <a:tc>
+                  <a:txBody>
+                    <a:bodyPr/>
+                    <a:lstStyle/>
+                    <a:p>
+                      <a:pPr indent="0" marL="0">
+                        <a:buNone/>
+                      </a:pPr>
+                      <a:r>
+                        <a:rPr lang="en-US" sz="1200" b="1" dirty="0">
+                          <a:solidFill>
+                            <a:srgbClr val="111111"/>
+                          </a:solidFill>
+                          <a:latin typeface="Arial" pitchFamily="34" charset="0"/>
+                          <a:ea typeface="Arial" pitchFamily="34" charset="-122"/>
+                          <a:cs typeface="Arial" pitchFamily="34" charset="-120"/>
+                        </a:rPr>
+                        <a:t>Roofs signed</a:t>
+                      </a:r>
+                      <a:endParaRPr lang="en-US" sz="1200" dirty="0">
+                        <a:latin typeface="Arial" charset="0"/>
+                        <a:ea typeface="Arial" charset="0"/>
+                        <a:cs typeface="Arial" charset="0"/>
+                      </a:endParaRPr>
+                    </a:p>
+                  </a:txBody>
+                  <a:tcPr marL="64008" marR="64008" marT="64008" marB="64008" anchor="ctr">
+                    <a:lnL w="9525" cap="flat" cmpd="sng" algn="ctr">
+                      <a:solidFill>
+                        <a:srgbClr val="DDDDDD"/>
+                      </a:solidFill>
+                      <a:prstDash val="solid"/>
+                      <a:round/>
+                      <a:headEnd type="none" w="med" len="med"/>
+                      <a:tailEnd type="none" w="med" len="med"/>
+                    </a:lnL>
+                    <a:lnR w="9525" cap="flat" cmpd="sng" algn="ctr">
+                      <a:solidFill>
+                        <a:srgbClr val="DDDDDD"/>
+                      </a:solidFill>
+                      <a:prstDash val="solid"/>
+                      <a:round/>
+                      <a:headEnd type="none" w="med" len="med"/>
+                      <a:tailEnd type="none" w="med" len="med"/>
+                    </a:lnR>
+                    <a:lnT w="9525" cap="flat" cmpd="sng" algn="ctr">
+                      <a:solidFill>
+                        <a:srgbClr val="DDDDDD"/>
+                      </a:solidFill>
+                      <a:prstDash val="solid"/>
+                      <a:round/>
+                      <a:headEnd type="none" w="med" len="med"/>
+                      <a:tailEnd type="none" w="med" len="med"/>
+                    </a:lnT>
+                    <a:lnB w="9525" cap="flat" cmpd="sng" algn="ctr">
+                      <a:solidFill>
+                        <a:srgbClr val="DDDDDD"/>
+                      </a:solidFill>
+                      <a:prstDash val="solid"/>
+                      <a:round/>
+                      <a:headEnd type="none" w="med" len="med"/>
+                      <a:tailEnd type="none" w="med" len="med"/>
+                    </a:lnB>
+                  </a:tcPr>
+                </a:tc>
+                <a:tc>
+                  <a:txBody>
+                    <a:bodyPr/>
+                    <a:lstStyle/>
+                    <a:p>
+                      <a:pPr algn="ctr" indent="0" marL="0">
+                        <a:buNone/>
+                      </a:pPr>
+                      <a:r>
+                        <a:rPr lang="en-US" sz="1250" dirty="0">
+                          <a:solidFill>
+                            <a:srgbClr val="2A2A2A"/>
+                          </a:solidFill>
+                          <a:latin typeface="Arial" pitchFamily="34" charset="0"/>
+                          <a:ea typeface="Arial" pitchFamily="34" charset="-122"/>
+                          <a:cs typeface="Arial" pitchFamily="34" charset="-120"/>
+                        </a:rPr>
+                        <a:t>~31</a:t>
+                      </a:r>
+                      <a:endParaRPr lang="en-US" sz="1250" dirty="0">
+                        <a:latin typeface="Arial" charset="0"/>
+                        <a:ea typeface="Arial" charset="0"/>
+                        <a:cs typeface="Arial" charset="0"/>
+                      </a:endParaRPr>
+                    </a:p>
+                  </a:txBody>
+                  <a:tcPr marL="64008" marR="64008" marT="64008" marB="64008" anchor="ctr">
+                    <a:lnL w="9525" cap="flat" cmpd="sng" algn="ctr">
+                      <a:solidFill>
+                        <a:srgbClr val="DDDDDD"/>
+                      </a:solidFill>
+                      <a:prstDash val="solid"/>
+                      <a:round/>
+                      <a:headEnd type="none" w="med" len="med"/>
+                      <a:tailEnd type="none" w="med" len="med"/>
+                    </a:lnL>
+                    <a:lnR w="9525" cap="flat" cmpd="sng" algn="ctr">
+                      <a:solidFill>
+                        <a:srgbClr val="DDDDDD"/>
+                      </a:solidFill>
+                      <a:prstDash val="solid"/>
+                      <a:round/>
+                      <a:headEnd type="none" w="med" len="med"/>
+                      <a:tailEnd type="none" w="med" len="med"/>
+                    </a:lnR>
+                    <a:lnT w="9525" cap="flat" cmpd="sng" algn="ctr">
+                      <a:solidFill>
+                        <a:srgbClr val="DDDDDD"/>
+                      </a:solidFill>
+                      <a:prstDash val="solid"/>
+                      <a:round/>
+                      <a:headEnd type="none" w="med" len="med"/>
+                      <a:tailEnd type="none" w="med" len="med"/>
+                    </a:lnT>
+                    <a:lnB w="9525" cap="flat" cmpd="sng" algn="ctr">
+                      <a:solidFill>
+                        <a:srgbClr val="DDDDDD"/>
+                      </a:solidFill>
+                      <a:prstDash val="solid"/>
+                      <a:round/>
+                      <a:headEnd type="none" w="med" len="med"/>
+                      <a:tailEnd type="none" w="med" len="med"/>
+                    </a:lnB>
+                  </a:tcPr>
+                </a:tc>
+                <a:tc>
+                  <a:txBody>
+                    <a:bodyPr/>
+                    <a:lstStyle/>
+                    <a:p>
+                      <a:pPr algn="ctr" indent="0" marL="0">
+                        <a:buNone/>
+                      </a:pPr>
+                      <a:r>
+                        <a:rPr lang="en-US" sz="1250" dirty="0">
+                          <a:solidFill>
+                            <a:srgbClr val="2A2A2A"/>
+                          </a:solidFill>
+                          <a:latin typeface="Arial" pitchFamily="34" charset="0"/>
+                          <a:ea typeface="Arial" pitchFamily="34" charset="-122"/>
+                          <a:cs typeface="Arial" pitchFamily="34" charset="-120"/>
+                        </a:rPr>
+                        <a:t>~15</a:t>
+                      </a:r>
+                      <a:endParaRPr lang="en-US" sz="1250" dirty="0">
+                        <a:latin typeface="Arial" charset="0"/>
+                        <a:ea typeface="Arial" charset="0"/>
+                        <a:cs typeface="Arial" charset="0"/>
+                      </a:endParaRPr>
+                    </a:p>
+                  </a:txBody>
+                  <a:tcPr marL="64008" marR="64008" marT="64008" marB="64008" anchor="ctr">
+                    <a:lnL w="9525" cap="flat" cmpd="sng" algn="ctr">
+                      <a:solidFill>
+                        <a:srgbClr val="DDDDDD"/>
+                      </a:solidFill>
+                      <a:prstDash val="solid"/>
+                      <a:round/>
+                      <a:headEnd type="none" w="med" len="med"/>
+                      <a:tailEnd type="none" w="med" len="med"/>
+                    </a:lnL>
+                    <a:lnR w="9525" cap="flat" cmpd="sng" algn="ctr">
+                      <a:solidFill>
+                        <a:srgbClr val="DDDDDD"/>
+                      </a:solidFill>
+                      <a:prstDash val="solid"/>
+                      <a:round/>
+                      <a:headEnd type="none" w="med" len="med"/>
+                      <a:tailEnd type="none" w="med" len="med"/>
+                    </a:lnR>
+                    <a:lnT w="9525" cap="flat" cmpd="sng" algn="ctr">
+                      <a:solidFill>
+                        <a:srgbClr val="DDDDDD"/>
+                      </a:solidFill>
+                      <a:prstDash val="solid"/>
+                      <a:round/>
+                      <a:headEnd type="none" w="med" len="med"/>
+                      <a:tailEnd type="none" w="med" len="med"/>
+                    </a:lnT>
+                    <a:lnB w="9525" cap="flat" cmpd="sng" algn="ctr">
+                      <a:solidFill>
+                        <a:srgbClr val="DDDDDD"/>
+                      </a:solidFill>
+                      <a:prstDash val="solid"/>
+                      <a:round/>
+                      <a:headEnd type="none" w="med" len="med"/>
+                      <a:tailEnd type="none" w="med" len="med"/>
+                    </a:lnB>
+                  </a:tcPr>
+                </a:tc>
+              </a:tr>
+              <a:tr h="411480">
+                <a:tc>
+                  <a:txBody>
+                    <a:bodyPr/>
+                    <a:lstStyle/>
+                    <a:p>
+                      <a:pPr indent="0" marL="0">
+                        <a:buNone/>
+                      </a:pPr>
+                      <a:r>
+                        <a:rPr lang="en-US" sz="1200" b="1" dirty="0">
+                          <a:solidFill>
+                            <a:srgbClr val="111111"/>
+                          </a:solidFill>
+                          <a:latin typeface="Arial" pitchFamily="34" charset="0"/>
+                          <a:ea typeface="Arial" pitchFamily="34" charset="-122"/>
+                          <a:cs typeface="Arial" pitchFamily="34" charset="-120"/>
+                        </a:rPr>
+                        <a:t>Revenue @ $30,000 ticket</a:t>
+                      </a:r>
+                      <a:endParaRPr lang="en-US" sz="1200" dirty="0">
+                        <a:latin typeface="Arial" charset="0"/>
+                        <a:ea typeface="Arial" charset="0"/>
+                        <a:cs typeface="Arial" charset="0"/>
+                      </a:endParaRPr>
+                    </a:p>
+                  </a:txBody>
+                  <a:tcPr marL="64008" marR="64008" marT="64008" marB="64008" anchor="ctr">
+                    <a:lnL w="9525" cap="flat" cmpd="sng" algn="ctr">
+                      <a:solidFill>
+                        <a:srgbClr val="DDDDDD"/>
+                      </a:solidFill>
+                      <a:prstDash val="solid"/>
+                      <a:round/>
+                      <a:headEnd type="none" w="med" len="med"/>
+                      <a:tailEnd type="none" w="med" len="med"/>
+                    </a:lnL>
+                    <a:lnR w="9525" cap="flat" cmpd="sng" algn="ctr">
+                      <a:solidFill>
+                        <a:srgbClr val="DDDDDD"/>
+                      </a:solidFill>
+                      <a:prstDash val="solid"/>
+                      <a:round/>
+                      <a:headEnd type="none" w="med" len="med"/>
+                      <a:tailEnd type="none" w="med" len="med"/>
+                    </a:lnR>
+                    <a:lnT w="9525" cap="flat" cmpd="sng" algn="ctr">
+                      <a:solidFill>
+                        <a:srgbClr val="DDDDDD"/>
+                      </a:solidFill>
+                      <a:prstDash val="solid"/>
+                      <a:round/>
+                      <a:headEnd type="none" w="med" len="med"/>
+                      <a:tailEnd type="none" w="med" len="med"/>
+                    </a:lnT>
+                    <a:lnB w="9525" cap="flat" cmpd="sng" algn="ctr">
+                      <a:solidFill>
+                        <a:srgbClr val="DDDDDD"/>
+                      </a:solidFill>
+                      <a:prstDash val="solid"/>
+                      <a:round/>
+                      <a:headEnd type="none" w="med" len="med"/>
+                      <a:tailEnd type="none" w="med" len="med"/>
+                    </a:lnB>
+                  </a:tcPr>
+                </a:tc>
+                <a:tc>
+                  <a:txBody>
+                    <a:bodyPr/>
+                    <a:lstStyle/>
+                    <a:p>
+                      <a:pPr algn="ctr" indent="0" marL="0">
+                        <a:buNone/>
+                      </a:pPr>
+                      <a:r>
+                        <a:rPr lang="en-US" sz="1250" dirty="0">
+                          <a:solidFill>
+                            <a:srgbClr val="2A2A2A"/>
+                          </a:solidFill>
+                          <a:latin typeface="Arial" pitchFamily="34" charset="0"/>
+                          <a:ea typeface="Arial" pitchFamily="34" charset="-122"/>
+                          <a:cs typeface="Arial" pitchFamily="34" charset="-120"/>
+                        </a:rPr>
+                        <a:t>~$930,000</a:t>
+                      </a:r>
+                      <a:endParaRPr lang="en-US" sz="1250" dirty="0">
+                        <a:latin typeface="Arial" charset="0"/>
+                        <a:ea typeface="Arial" charset="0"/>
+                        <a:cs typeface="Arial" charset="0"/>
+                      </a:endParaRPr>
+                    </a:p>
+                  </a:txBody>
+                  <a:tcPr marL="64008" marR="64008" marT="64008" marB="64008" anchor="ctr">
+                    <a:lnL w="9525" cap="flat" cmpd="sng" algn="ctr">
+                      <a:solidFill>
+                        <a:srgbClr val="DDDDDD"/>
+                      </a:solidFill>
+                      <a:prstDash val="solid"/>
+                      <a:round/>
+                      <a:headEnd type="none" w="med" len="med"/>
+                      <a:tailEnd type="none" w="med" len="med"/>
+                    </a:lnL>
+                    <a:lnR w="9525" cap="flat" cmpd="sng" algn="ctr">
+                      <a:solidFill>
+                        <a:srgbClr val="DDDDDD"/>
+                      </a:solidFill>
+                      <a:prstDash val="solid"/>
+                      <a:round/>
+                      <a:headEnd type="none" w="med" len="med"/>
+                      <a:tailEnd type="none" w="med" len="med"/>
+                    </a:lnR>
+                    <a:lnT w="9525" cap="flat" cmpd="sng" algn="ctr">
+                      <a:solidFill>
+                        <a:srgbClr val="DDDDDD"/>
+                      </a:solidFill>
+                      <a:prstDash val="solid"/>
+                      <a:round/>
+                      <a:headEnd type="none" w="med" len="med"/>
+                      <a:tailEnd type="none" w="med" len="med"/>
+                    </a:lnT>
+                    <a:lnB w="9525" cap="flat" cmpd="sng" algn="ctr">
+                      <a:solidFill>
+                        <a:srgbClr val="DDDDDD"/>
+                      </a:solidFill>
+                      <a:prstDash val="solid"/>
+                      <a:round/>
+                      <a:headEnd type="none" w="med" len="med"/>
+                      <a:tailEnd type="none" w="med" len="med"/>
+                    </a:lnB>
+                  </a:tcPr>
+                </a:tc>
+                <a:tc>
+                  <a:txBody>
+                    <a:bodyPr/>
+                    <a:lstStyle/>
+                    <a:p>
+                      <a:pPr algn="ctr" indent="0" marL="0">
+                        <a:buNone/>
+                      </a:pPr>
+                      <a:r>
+                        <a:rPr lang="en-US" sz="1250" dirty="0">
+                          <a:solidFill>
+                            <a:srgbClr val="2A2A2A"/>
+                          </a:solidFill>
+                          <a:latin typeface="Arial" pitchFamily="34" charset="0"/>
+                          <a:ea typeface="Arial" pitchFamily="34" charset="-122"/>
+                          <a:cs typeface="Arial" pitchFamily="34" charset="-120"/>
+                        </a:rPr>
+                        <a:t>~$450,000</a:t>
+                      </a:r>
+                      <a:endParaRPr lang="en-US" sz="1250" dirty="0">
+                        <a:latin typeface="Arial" charset="0"/>
+                        <a:ea typeface="Arial" charset="0"/>
+                        <a:cs typeface="Arial" charset="0"/>
+                      </a:endParaRPr>
+                    </a:p>
+                  </a:txBody>
+                  <a:tcPr marL="64008" marR="64008" marT="64008" marB="64008" anchor="ctr">
+                    <a:lnL w="9525" cap="flat" cmpd="sng" algn="ctr">
+                      <a:solidFill>
+                        <a:srgbClr val="DDDDDD"/>
+                      </a:solidFill>
+                      <a:prstDash val="solid"/>
+                      <a:round/>
+                      <a:headEnd type="none" w="med" len="med"/>
+                      <a:tailEnd type="none" w="med" len="med"/>
+                    </a:lnL>
+                    <a:lnR w="9525" cap="flat" cmpd="sng" algn="ctr">
+                      <a:solidFill>
+                        <a:srgbClr val="DDDDDD"/>
+                      </a:solidFill>
+                      <a:prstDash val="solid"/>
+                      <a:round/>
+                      <a:headEnd type="none" w="med" len="med"/>
+                      <a:tailEnd type="none" w="med" len="med"/>
+                    </a:lnR>
+                    <a:lnT w="9525" cap="flat" cmpd="sng" algn="ctr">
+                      <a:solidFill>
+                        <a:srgbClr val="DDDDDD"/>
+                      </a:solidFill>
+                      <a:prstDash val="solid"/>
+                      <a:round/>
+                      <a:headEnd type="none" w="med" len="med"/>
+                      <a:tailEnd type="none" w="med" len="med"/>
+                    </a:lnT>
+                    <a:lnB w="9525" cap="flat" cmpd="sng" algn="ctr">
+                      <a:solidFill>
+                        <a:srgbClr val="DDDDDD"/>
+                      </a:solidFill>
+                      <a:prstDash val="solid"/>
+                      <a:round/>
+                      <a:headEnd type="none" w="med" len="med"/>
+                      <a:tailEnd type="none" w="med" len="med"/>
+                    </a:lnB>
+                  </a:tcPr>
+                </a:tc>
+              </a:tr>
+              <a:tr h="502920">
+                <a:tc>
+                  <a:txBody>
+                    <a:bodyPr/>
+                    <a:lstStyle/>
+                    <a:p>
+                      <a:pPr indent="0" marL="0">
+                        <a:buNone/>
+                      </a:pPr>
+                      <a:r>
+                        <a:rPr lang="en-US" sz="1200" b="1" dirty="0">
+                          <a:solidFill>
+                            <a:srgbClr val="111111"/>
+                          </a:solidFill>
+                          <a:latin typeface="Arial" pitchFamily="34" charset="0"/>
+                          <a:ea typeface="Arial" pitchFamily="34" charset="-122"/>
+                          <a:cs typeface="Arial" pitchFamily="34" charset="-120"/>
+                        </a:rPr>
+                        <a:t>T^Rock net (after fee, split &amp; sub)</a:t>
+                      </a:r>
+                      <a:endParaRPr lang="en-US" sz="1200" dirty="0">
+                        <a:latin typeface="Arial" charset="0"/>
+                        <a:ea typeface="Arial" charset="0"/>
+                        <a:cs typeface="Arial" charset="0"/>
+                      </a:endParaRPr>
+                    </a:p>
+                  </a:txBody>
+                  <a:tcPr marL="64008" marR="64008" marT="64008" marB="64008" anchor="ctr">
+                    <a:lnL w="9525" cap="flat" cmpd="sng" algn="ctr">
+                      <a:solidFill>
+                        <a:srgbClr val="DDDDDD"/>
+                      </a:solidFill>
+                      <a:prstDash val="solid"/>
+                      <a:round/>
+                      <a:headEnd type="none" w="med" len="med"/>
+                      <a:tailEnd type="none" w="med" len="med"/>
+                    </a:lnL>
+                    <a:lnR w="9525" cap="flat" cmpd="sng" algn="ctr">
+                      <a:solidFill>
+                        <a:srgbClr val="DDDDDD"/>
+                      </a:solidFill>
+                      <a:prstDash val="solid"/>
+                      <a:round/>
+                      <a:headEnd type="none" w="med" len="med"/>
+                      <a:tailEnd type="none" w="med" len="med"/>
+                    </a:lnR>
+                    <a:lnT w="9525" cap="flat" cmpd="sng" algn="ctr">
+                      <a:solidFill>
+                        <a:srgbClr val="DDDDDD"/>
+                      </a:solidFill>
+                      <a:prstDash val="solid"/>
+                      <a:round/>
+                      <a:headEnd type="none" w="med" len="med"/>
+                      <a:tailEnd type="none" w="med" len="med"/>
+                    </a:lnT>
+                    <a:lnB w="9525" cap="flat" cmpd="sng" algn="ctr">
+                      <a:solidFill>
+                        <a:srgbClr val="DDDDDD"/>
+                      </a:solidFill>
+                      <a:prstDash val="solid"/>
+                      <a:round/>
+                      <a:headEnd type="none" w="med" len="med"/>
+                      <a:tailEnd type="none" w="med" len="med"/>
+                    </a:lnB>
+                  </a:tcPr>
+                </a:tc>
+                <a:tc>
+                  <a:txBody>
+                    <a:bodyPr/>
+                    <a:lstStyle/>
+                    <a:p>
+                      <a:pPr algn="ctr" indent="0" marL="0">
+                        <a:buNone/>
+                      </a:pPr>
+                      <a:r>
+                        <a:rPr lang="en-US" sz="1300" b="1" dirty="0">
+                          <a:solidFill>
+                            <a:srgbClr val="C8102E"/>
+                          </a:solidFill>
+                          <a:latin typeface="Arial" pitchFamily="34" charset="0"/>
+                          <a:ea typeface="Arial" pitchFamily="34" charset="-122"/>
+                          <a:cs typeface="Arial" pitchFamily="34" charset="-120"/>
+                        </a:rPr>
+                        <a:t>~$149,000</a:t>
+                      </a:r>
+                      <a:endParaRPr lang="en-US" sz="1300" dirty="0">
+                        <a:latin typeface="Arial" charset="0"/>
+                        <a:ea typeface="Arial" charset="0"/>
+                        <a:cs typeface="Arial" charset="0"/>
+                      </a:endParaRPr>
+                    </a:p>
+                  </a:txBody>
+                  <a:tcPr marL="64008" marR="64008" marT="64008" marB="64008" anchor="ctr">
+                    <a:lnL w="9525" cap="flat" cmpd="sng" algn="ctr">
+                      <a:solidFill>
+                        <a:srgbClr val="DDDDDD"/>
+                      </a:solidFill>
+                      <a:prstDash val="solid"/>
+                      <a:round/>
+                      <a:headEnd type="none" w="med" len="med"/>
+                      <a:tailEnd type="none" w="med" len="med"/>
+                    </a:lnL>
+                    <a:lnR w="9525" cap="flat" cmpd="sng" algn="ctr">
+                      <a:solidFill>
+                        <a:srgbClr val="DDDDDD"/>
+                      </a:solidFill>
+                      <a:prstDash val="solid"/>
+                      <a:round/>
+                      <a:headEnd type="none" w="med" len="med"/>
+                      <a:tailEnd type="none" w="med" len="med"/>
+                    </a:lnR>
+                    <a:lnT w="9525" cap="flat" cmpd="sng" algn="ctr">
+                      <a:solidFill>
+                        <a:srgbClr val="DDDDDD"/>
+                      </a:solidFill>
+                      <a:prstDash val="solid"/>
+                      <a:round/>
+                      <a:headEnd type="none" w="med" len="med"/>
+                      <a:tailEnd type="none" w="med" len="med"/>
+                    </a:lnT>
+                    <a:lnB w="9525" cap="flat" cmpd="sng" algn="ctr">
+                      <a:solidFill>
+                        <a:srgbClr val="DDDDDD"/>
+                      </a:solidFill>
+                      <a:prstDash val="solid"/>
+                      <a:round/>
+                      <a:headEnd type="none" w="med" len="med"/>
+                      <a:tailEnd type="none" w="med" len="med"/>
+                    </a:lnB>
+                  </a:tcPr>
+                </a:tc>
+                <a:tc>
+                  <a:txBody>
+                    <a:bodyPr/>
+                    <a:lstStyle/>
+                    <a:p>
+                      <a:pPr algn="ctr" indent="0" marL="0">
+                        <a:buNone/>
+                      </a:pPr>
+                      <a:r>
+                        <a:rPr lang="en-US" sz="1300" b="1" dirty="0">
+                          <a:solidFill>
+                            <a:srgbClr val="C8102E"/>
+                          </a:solidFill>
+                          <a:latin typeface="Arial" pitchFamily="34" charset="0"/>
+                          <a:ea typeface="Arial" pitchFamily="34" charset="-122"/>
+                          <a:cs typeface="Arial" pitchFamily="34" charset="-120"/>
+                        </a:rPr>
+                        <a:t>~$67,000</a:t>
+                      </a:r>
+                      <a:endParaRPr lang="en-US" sz="1300" dirty="0">
+                        <a:latin typeface="Arial" charset="0"/>
+                        <a:ea typeface="Arial" charset="0"/>
+                        <a:cs typeface="Arial" charset="0"/>
+                      </a:endParaRPr>
+                    </a:p>
+                  </a:txBody>
+                  <a:tcPr marL="64008" marR="64008" marT="64008" marB="64008" anchor="ctr">
+                    <a:lnL w="9525" cap="flat" cmpd="sng" algn="ctr">
+                      <a:solidFill>
+                        <a:srgbClr val="DDDDDD"/>
+                      </a:solidFill>
+                      <a:prstDash val="solid"/>
+                      <a:round/>
+                      <a:headEnd type="none" w="med" len="med"/>
+                      <a:tailEnd type="none" w="med" len="med"/>
+                    </a:lnL>
+                    <a:lnR w="9525" cap="flat" cmpd="sng" algn="ctr">
+                      <a:solidFill>
+                        <a:srgbClr val="DDDDDD"/>
+                      </a:solidFill>
+                      <a:prstDash val="solid"/>
+                      <a:round/>
+                      <a:headEnd type="none" w="med" len="med"/>
+                      <a:tailEnd type="none" w="med" len="med"/>
+                    </a:lnR>
+                    <a:lnT w="9525" cap="flat" cmpd="sng" algn="ctr">
+                      <a:solidFill>
+                        <a:srgbClr val="DDDDDD"/>
+                      </a:solidFill>
+                      <a:prstDash val="solid"/>
+                      <a:round/>
+                      <a:headEnd type="none" w="med" len="med"/>
+                      <a:tailEnd type="none" w="med" len="med"/>
+                    </a:lnT>
+                    <a:lnB w="9525" cap="flat" cmpd="sng" algn="ctr">
+                      <a:solidFill>
+                        <a:srgbClr val="DDDDDD"/>
+                      </a:solidFill>
+                      <a:prstDash val="solid"/>
+                      <a:round/>
+                      <a:headEnd type="none" w="med" len="med"/>
+                      <a:tailEnd type="none" w="med" len="med"/>
+                    </a:lnB>
+                  </a:tcPr>
+                </a:tc>
+              </a:tr>
+            </a:tbl>
+          </a:graphicData>
+        </a:graphic>
+      </p:graphicFrame>
+      <p:sp>
+        <p:nvSpPr>
+          <p:cNvPr id="14" name="Text 11"/>
+          <p:cNvSpPr/>
+          <p:nvPr/>
+        </p:nvSpPr>
+        <p:spPr>
+          <a:xfrm>
+            <a:off x="5029200" y="4434840"/>
+            <a:ext cx="6583680" cy="365760"/>
+          </a:xfrm>
+          <a:prstGeom prst="rect">
+            <a:avLst/>
+          </a:prstGeom>
+          <a:noFill/>
+          <a:ln/>
+        </p:spPr>
+        <p:txBody>
+          <a:bodyPr wrap="square" lIns="0" tIns="0" rIns="0" bIns="0" rtlCol="0" anchor="ctr"/>
+          <a:lstStyle/>
+          <a:p>
+            <a:pPr indent="0" marL="0">
+              <a:buNone/>
+            </a:pPr>
+            <a:r>
+              <a:rPr lang="en-US" sz="1050" i="1" dirty="0">
+                <a:solidFill>
+                  <a:srgbClr val="6E6E6E"/>
+                </a:solidFill>
+                <a:latin typeface="Arial" pitchFamily="34" charset="0"/>
+                <a:ea typeface="Arial" pitchFamily="34" charset="-122"/>
+                <a:cs typeface="Arial" pitchFamily="34" charset="-120"/>
+              </a:rPr>
+              <a:t>Funnel applied: 3.3% call → inspection, 29.5% inspection → sign (halved in the right column).</a:t>
+            </a:r>
+            <a:endParaRPr lang="en-US" sz="1050" dirty="0"/>
+          </a:p>
+        </p:txBody>
+      </p:sp>
+      <p:sp>
+        <p:nvSpPr>
+          <p:cNvPr id="15" name="Shape 12"/>
+          <p:cNvSpPr/>
+          <p:nvPr/>
+        </p:nvSpPr>
+        <p:spPr>
+          <a:xfrm>
+            <a:off x="548640" y="5532120"/>
+            <a:ext cx="11064240" cy="731520"/>
+          </a:xfrm>
+          <a:prstGeom prst="roundRect">
+            <a:avLst>
+              <a:gd name="adj" fmla="val 7500"/>
+            </a:avLst>
+          </a:prstGeom>
+          <a:solidFill>
+            <a:srgbClr val="111111"/>
+          </a:solidFill>
+          <a:ln/>
+        </p:spPr>
+      </p:sp>
+      <p:sp>
+        <p:nvSpPr>
+          <p:cNvPr id="16" name="Text 13"/>
+          <p:cNvSpPr/>
+          <p:nvPr/>
+        </p:nvSpPr>
+        <p:spPr>
+          <a:xfrm>
+            <a:off x="868680" y="5623560"/>
+            <a:ext cx="10515600" cy="566928"/>
+          </a:xfrm>
+          <a:prstGeom prst="rect">
+            <a:avLst/>
+          </a:prstGeom>
+          <a:noFill/>
+          <a:ln/>
+        </p:spPr>
+        <p:txBody>
+          <a:bodyPr wrap="square" lIns="0" tIns="0" rIns="0" bIns="0" rtlCol="0" anchor="ctr"/>
+          <a:lstStyle/>
+          <a:p>
+            <a:pPr indent="0" marL="0">
+              <a:buNone/>
+            </a:pPr>
+            <a:r>
+              <a:rPr lang="en-US" sz="1350" b="1" dirty="0">
+                <a:solidFill>
+                  <a:srgbClr val="FFFFFF"/>
+                </a:solidFill>
+                <a:latin typeface="Arial" pitchFamily="34" charset="0"/>
+                <a:ea typeface="Arial" pitchFamily="34" charset="-122"/>
+                <a:cs typeface="Arial" pitchFamily="34" charset="-120"/>
+              </a:rPr>
+              <a:t>Even at HALF Company A's conversion, the system nets ~$67k in its first five months — 6× the subscription. </a:t>
+            </a:r>
+            <a:pPr indent="0" marL="0">
+              <a:buNone/>
+            </a:pPr>
+            <a:r>
+              <a:rPr lang="en-US" sz="1350" dirty="0">
+                <a:solidFill>
+                  <a:srgbClr val="E6E6E6"/>
+                </a:solidFill>
+                <a:latin typeface="Arial" pitchFamily="34" charset="0"/>
+                <a:ea typeface="Arial" pitchFamily="34" charset="-122"/>
+                <a:cs typeface="Arial" pitchFamily="34" charset="-120"/>
+              </a:rPr>
+              <a:t>At par, ~$149k.</a:t>
+            </a:r>
+            <a:endParaRPr lang="en-US" sz="1350" dirty="0"/>
+          </a:p>
+        </p:txBody>
+      </p:sp>
+      <p:sp>
+        <p:nvSpPr>
+          <p:cNvPr id="17" name="Text 14"/>
+          <p:cNvSpPr/>
+          <p:nvPr/>
+        </p:nvSpPr>
+        <p:spPr>
+          <a:xfrm>
+            <a:off x="548640" y="6473952"/>
+            <a:ext cx="9601200" cy="274320"/>
+          </a:xfrm>
+          <a:prstGeom prst="rect">
+            <a:avLst/>
+          </a:prstGeom>
+          <a:noFill/>
+          <a:ln/>
+        </p:spPr>
+        <p:txBody>
+          <a:bodyPr wrap="square" lIns="0" tIns="0" rIns="0" bIns="0" rtlCol="0" anchor="ctr"/>
+          <a:lstStyle/>
+          <a:p>
+            <a:pPr indent="0" marL="0">
+              <a:buNone/>
+            </a:pPr>
+            <a:r>
+              <a:rPr lang="en-US" sz="900" dirty="0">
+                <a:solidFill>
+                  <a:srgbClr val="6E6E6E"/>
+                </a:solidFill>
+                <a:latin typeface="Arial" pitchFamily="34" charset="0"/>
+                <a:ea typeface="Arial" pitchFamily="34" charset="-122"/>
+                <a:cs typeface="Arial" pitchFamily="34" charset="-120"/>
+              </a:rPr>
+              <a:t>Net = roofs × $5,145 T^Rock share, less ~$10,400 subscription (5.2 months at $2,000/mo). Projection, not a promise — the scorecard decides.</a:t>
+            </a:r>
+            <a:endParaRPr lang="en-US" sz="900" dirty="0"/>
+          </a:p>
+        </p:txBody>
+      </p:sp>
+      <p:sp>
+        <p:nvSpPr>
+          <p:cNvPr id="18" name="Text 15"/>
+          <p:cNvSpPr/>
+          <p:nvPr/>
+        </p:nvSpPr>
+        <p:spPr>
+          <a:xfrm>
+            <a:off x="11274552" y="6473952"/>
+            <a:ext cx="457200" cy="274320"/>
+          </a:xfrm>
+          <a:prstGeom prst="rect">
+            <a:avLst/>
+          </a:prstGeom>
+          <a:noFill/>
+          <a:ln/>
+        </p:spPr>
+        <p:txBody>
+          <a:bodyPr wrap="square" lIns="0" tIns="0" rIns="0" bIns="0" rtlCol="0" anchor="ctr"/>
+          <a:lstStyle/>
+          <a:p>
+            <a:pPr algn="r" indent="0" marL="0">
+              <a:buNone/>
+            </a:pPr>
+            <a:r>
+              <a:rPr lang="en-US" sz="1000" dirty="0">
+                <a:solidFill>
+                  <a:srgbClr val="6E6E6E"/>
+                </a:solidFill>
+                <a:latin typeface="Arial" pitchFamily="34" charset="0"/>
+                <a:ea typeface="Arial" pitchFamily="34" charset="-122"/>
+                <a:cs typeface="Arial" pitchFamily="34" charset="-120"/>
+              </a:rPr>
+              <a:t>10</a:t>
+            </a:r>
+            <a:endParaRPr lang="en-US" sz="1000" dirty="0"/>
+          </a:p>
+        </p:txBody>
+      </p:sp>
+    </p:spTree>
+  </p:cSld>
+  <p:clrMapOvr>
+    <a:masterClrMapping/>
+  </p:clrMapOvr>
+</p:sld>
+</file>
+
+<file path=ppt/slides/slide11.xml><?xml version="1.0" encoding="utf-8"?>
+<p:sld xmlns:a="http://schemas.openxmlformats.org/drawingml/2006/main" xmlns:r="http://schemas.openxmlformats.org/officeDocument/2006/relationships" xmlns:p="http://schemas.openxmlformats.org/presentationml/2006/main">
+  <p:cSld name="Slide 11">
+    <p:bg>
+      <p:bgPr>
+        <a:solidFill>
+          <a:srgbClr val="FFFFFF"/>
+        </a:solidFill>
+      </p:bgPr>
+    </p:bg>
+    <p:spTree>
+      <p:nvGrpSpPr>
+        <p:cNvPr id="1" name=""/>
+        <p:cNvGrpSpPr/>
+        <p:nvPr/>
+      </p:nvGrpSpPr>
+      <p:grpSpPr>
+        <a:xfrm>
+          <a:off x="0" y="0"/>
+          <a:ext cx="0" cy="0"/>
+          <a:chOff x="0" y="0"/>
+          <a:chExt cx="0" cy="0"/>
+        </a:xfrm>
+      </p:grpSpPr>
+      <p:sp>
+        <p:nvSpPr>
+          <p:cNvPr id="2" name="Text 0"/>
+          <p:cNvSpPr/>
+          <p:nvPr/>
+        </p:nvSpPr>
+        <p:spPr>
+          <a:xfrm>
+            <a:off x="548640" y="411480"/>
+            <a:ext cx="11064240" cy="640080"/>
+          </a:xfrm>
+          <a:prstGeom prst="rect">
+            <a:avLst/>
+          </a:prstGeom>
+          <a:noFill/>
+          <a:ln/>
+        </p:spPr>
+        <p:txBody>
+          <a:bodyPr wrap="square" lIns="0" tIns="0" rIns="0" bIns="0" rtlCol="0" anchor="ctr"/>
+          <a:lstStyle/>
+          <a:p>
+            <a:pPr indent="0" marL="0">
+              <a:buNone/>
+            </a:pPr>
+            <a:r>
+              <a:rPr lang="en-US" sz="3200" b="1" dirty="0">
+                <a:solidFill>
+                  <a:srgbClr val="111111"/>
+                </a:solidFill>
+                <a:latin typeface="Arial" pitchFamily="34" charset="0"/>
+                <a:ea typeface="Arial" pitchFamily="34" charset="-122"/>
+                <a:cs typeface="Arial" pitchFamily="34" charset="-120"/>
+              </a:rPr>
+              <a:t>The 90-day proof period: scored, capped, killable</a:t>
+            </a:r>
+            <a:endParaRPr lang="en-US" sz="3200" dirty="0"/>
+          </a:p>
+        </p:txBody>
+      </p:sp>
+      <p:sp>
+        <p:nvSpPr>
+          <p:cNvPr id="3" name="Text 1"/>
+          <p:cNvSpPr/>
+          <p:nvPr/>
+        </p:nvSpPr>
+        <p:spPr>
+          <a:xfrm>
+            <a:off x="548640" y="1078992"/>
+            <a:ext cx="10881360" cy="502920"/>
+          </a:xfrm>
+          <a:prstGeom prst="rect">
+            <a:avLst/>
+          </a:prstGeom>
+          <a:noFill/>
+          <a:ln/>
+        </p:spPr>
+        <p:txBody>
+          <a:bodyPr wrap="square" lIns="0" tIns="0" rIns="0" bIns="0" rtlCol="0" anchor="ctr"/>
+          <a:lstStyle/>
+          <a:p>
+            <a:pPr indent="0" marL="0">
+              <a:buNone/>
+            </a:pPr>
+            <a:r>
+              <a:rPr lang="en-US" sz="1500" dirty="0">
+                <a:solidFill>
+                  <a:srgbClr val="6E6E6E"/>
+                </a:solidFill>
+                <a:latin typeface="Arial" pitchFamily="34" charset="0"/>
+                <a:ea typeface="Arial" pitchFamily="34" charset="-122"/>
+                <a:cs typeface="Arial" pitchFamily="34" charset="-120"/>
+              </a:rPr>
+              <a:t>Full team goes live on Founding day 1 — but 2 reps keep the current playbook as the control, so the comparison stays honest.</a:t>
+            </a:r>
+            <a:endParaRPr lang="en-US" sz="1500" dirty="0"/>
+          </a:p>
+        </p:txBody>
+      </p:sp>
+      <p:graphicFrame>
+        <p:nvGraphicFramePr>
+          <p:cNvPr id="12" name="Table 0"/>
           <p:cNvGraphicFramePr>
             <a:graphicFrameLocks noGrp="1"/>
           </p:cNvGraphicFramePr>
@@ -3332,7 +5245,7 @@
                 <a:ea typeface="Arial" pitchFamily="34" charset="-122"/>
                 <a:cs typeface="Arial" pitchFamily="34" charset="-120"/>
               </a:rPr>
-              <a:t>10</a:t>
+              <a:t>11</a:t>
             </a:r>
             <a:endParaRPr lang="en-US" sz="1000" dirty="0"/>
           </a:p>
@@ -3346,9 +5259,9 @@
 </p:sld>
 </file>
 
-<file path=ppt/slides/slide11.xml><?xml version="1.0" encoding="utf-8"?>
+<file path=ppt/slides/slide12.xml><?xml version="1.0" encoding="utf-8"?>
 <p:sld xmlns:a="http://schemas.openxmlformats.org/drawingml/2006/main" xmlns:r="http://schemas.openxmlformats.org/officeDocument/2006/relationships" xmlns:p="http://schemas.openxmlformats.org/presentationml/2006/main">
-  <p:cSld name="Slide 11">
+  <p:cSld name="Slide 12">
     <p:bg>
       <p:bgPr>
         <a:solidFill>
@@ -3966,7 +5879,7 @@
                 <a:ea typeface="Arial" pitchFamily="34" charset="-122"/>
                 <a:cs typeface="Arial" pitchFamily="34" charset="-120"/>
               </a:rPr>
-              <a:t>11</a:t>
+              <a:t>12</a:t>
             </a:r>
             <a:endParaRPr lang="en-US" sz="1000" dirty="0"/>
           </a:p>
@@ -3980,9 +5893,9 @@
 </p:sld>
 </file>
 
-<file path=ppt/slides/slide12.xml><?xml version="1.0" encoding="utf-8"?>
+<file path=ppt/slides/slide13.xml><?xml version="1.0" encoding="utf-8"?>
 <p:sld xmlns:a="http://schemas.openxmlformats.org/drawingml/2006/main" xmlns:r="http://schemas.openxmlformats.org/officeDocument/2006/relationships" xmlns:p="http://schemas.openxmlformats.org/presentationml/2006/main">
-  <p:cSld name="Slide 12">
+  <p:cSld name="Slide 13">
     <p:bg>
       <p:bgPr>
         <a:solidFill>

</xml_diff>